<commit_message>
chore: clean project workflow and restore required deliverables
</commit_message>
<xml_diff>
--- a/presentacion_proyecto.pptx
+++ b/presentacion_proyecto.pptx
@@ -4,6 +4,9 @@
   <p:sldMasterIdLst>
     <p:sldMasterId id="2147483648" r:id="rId1"/>
   </p:sldMasterIdLst>
+  <p:notesMasterIdLst>
+    <p:notesMasterId r:id="rId13"/>
+  </p:notesMasterIdLst>
   <p:sldIdLst>
     <p:sldId id="256" r:id="rId2"/>
     <p:sldId id="257" r:id="rId3"/>
@@ -17,10 +20,7 @@
     <p:sldId id="265" r:id="rId11"/>
     <p:sldId id="266" r:id="rId12"/>
   </p:sldIdLst>
-  <p:notesMasterIdLst>
-    <p:notesMasterId r:id="rId13"/>
-  </p:notesMasterIdLst>
-  <p:sldSz cx="9144000" cy="5143500"/>
+  <p:sldSz cx="9144000" cy="5143500" type="screen16x9"/>
   <p:notesSz cx="5143500" cy="9144000"/>
   <p:defaultTextStyle>
     <a:lvl1pPr marL="0" algn="l" defTabSz="914400" rtl="0" eaLnBrk="1" latinLnBrk="0" hangingPunct="1">
@@ -117,7 +117,7 @@
   <p:extLst>
     <p:ext uri="{521415D9-36F7-43E2-AB2F-B90AF26B5E84}">
       <p14:sectionLst xmlns:p14="http://schemas.microsoft.com/office/powerpoint/2010/main">
-        <p14:section name="Proyecto Text-to-SQL" id="{b1e1a072-cc33-a450-5233-03067c59c14e}">
+        <p14:section name="Proyecto Text-to-SQL" id="{B1E1A072-CC33-A450-5233-03067C59C14E}">
           <p14:sldIdLst>
             <p14:sldId id="256"/>
             <p14:sldId id="257"/>
@@ -142,9 +142,11 @@
 </file>
 
 <file path=ppt/charts/chart1.xml><?xml version="1.0" encoding="utf-8"?>
-<c:chartSpace xmlns:c="http://schemas.openxmlformats.org/drawingml/2006/chart" xmlns:a="http://schemas.openxmlformats.org/drawingml/2006/main" xmlns:r="http://schemas.openxmlformats.org/officeDocument/2006/relationships">
+<c:chartSpace xmlns:c="http://schemas.openxmlformats.org/drawingml/2006/chart" xmlns:a="http://schemas.openxmlformats.org/drawingml/2006/main" xmlns:r="http://schemas.openxmlformats.org/officeDocument/2006/relationships" xmlns:c16r2="http://schemas.microsoft.com/office/drawing/2015/06/chart">
   <c:date1904 val="0"/>
+  <c:lang val="es-ES"/>
   <c:roundedCorners val="1"/>
+  <c:style val="2"/>
   <c:chart>
     <c:title>
       <c:tx>
@@ -161,7 +163,7 @@
               </a:defRPr>
             </a:pPr>
             <a:r>
-              <a:rPr sz="1400" b="0" i="0" u="none" strike="noStrike">
+              <a:rPr lang="es-GT" sz="1400" b="0" i="0" u="none" strike="noStrike">
                 <a:solidFill>
                   <a:srgbClr val="1F2A33"/>
                 </a:solidFill>
@@ -172,7 +174,6 @@
           </a:p>
         </c:rich>
       </c:tx>
-      <c:layout/>
       <c:overlay val="0"/>
     </c:title>
     <c:autoTitleDeleted val="0"/>
@@ -203,40 +204,15 @@
             <a:effectLst/>
           </c:spPr>
           <c:invertIfNegative val="0"/>
-          <c:dLbls>
-            <c:numFmt formatCode="0.0&quot;%&quot;" sourceLinked="0"/>
-            <c:txPr>
-              <a:bodyPr/>
-              <a:lstStyle/>
-              <a:p>
-                <a:pPr>
-                  <a:defRPr b="1" i="0" strike="noStrike" sz="1400" u="none">
-                    <a:solidFill>
-                      <a:srgbClr val="1F2A33"/>
-                    </a:solidFill>
-                    <a:latin typeface="+mn-lt"/>
-                  </a:defRPr>
-                </a:pPr>
-              </a:p>
-            </c:txPr>
-            <c:showLegendKey val="0"/>
-            <c:showVal val="1"/>
-            <c:showCatName val="0"/>
-            <c:showSerName val="0"/>
-            <c:showPercent val="0"/>
-            <c:showBubbleSize val="0"/>
-            <c:showLeaderLines val="0"/>
-          </c:dLbls>
           <c:dPt>
             <c:idx val="0"/>
             <c:invertIfNegative val="0"/>
             <c:bubble3D val="0"/>
-            <c:spPr>
-              <a:solidFill>
-                <a:srgbClr val="9AA7AE"/>
-              </a:solidFill>
-              <a:effectLst/>
-            </c:spPr>
+            <c:extLst>
+              <c:ext xmlns:c16="http://schemas.microsoft.com/office/drawing/2014/chart" uri="{C3380CC4-5D6E-409C-BE32-E72D297353CC}">
+                <c16:uniqueId val="{00000001-3B7E-43C7-969C-AB2733B2CE4A}"/>
+              </c:ext>
+            </c:extLst>
           </c:dPt>
           <c:dPt>
             <c:idx val="1"/>
@@ -248,6 +224,11 @@
               </a:solidFill>
               <a:effectLst/>
             </c:spPr>
+            <c:extLst>
+              <c:ext xmlns:c16="http://schemas.microsoft.com/office/drawing/2014/chart" uri="{C3380CC4-5D6E-409C-BE32-E72D297353CC}">
+                <c16:uniqueId val="{00000003-3B7E-43C7-969C-AB2733B2CE4A}"/>
+              </c:ext>
+            </c:extLst>
           </c:dPt>
           <c:dPt>
             <c:idx val="2"/>
@@ -259,25 +240,65 @@
               </a:solidFill>
               <a:effectLst/>
             </c:spPr>
+            <c:extLst>
+              <c:ext xmlns:c16="http://schemas.microsoft.com/office/drawing/2014/chart" uri="{C3380CC4-5D6E-409C-BE32-E72D297353CC}">
+                <c16:uniqueId val="{00000005-3B7E-43C7-969C-AB2733B2CE4A}"/>
+              </c:ext>
+            </c:extLst>
           </c:dPt>
+          <c:dLbls>
+            <c:numFmt formatCode="0.0&quot;%&quot;" sourceLinked="0"/>
+            <c:spPr>
+              <a:noFill/>
+              <a:ln>
+                <a:noFill/>
+              </a:ln>
+              <a:effectLst/>
+            </c:spPr>
+            <c:txPr>
+              <a:bodyPr/>
+              <a:lstStyle/>
+              <a:p>
+                <a:pPr>
+                  <a:defRPr sz="1400" b="1" i="0" u="none" strike="noStrike">
+                    <a:solidFill>
+                      <a:srgbClr val="1F2A33"/>
+                    </a:solidFill>
+                    <a:latin typeface="+mn-lt"/>
+                  </a:defRPr>
+                </a:pPr>
+                <a:endParaRPr lang="es-GT"/>
+              </a:p>
+            </c:txPr>
+            <c:showLegendKey val="0"/>
+            <c:showVal val="1"/>
+            <c:showCatName val="0"/>
+            <c:showSerName val="0"/>
+            <c:showPercent val="0"/>
+            <c:showBubbleSize val="0"/>
+            <c:showLeaderLines val="0"/>
+            <c:extLst>
+              <c:ext xmlns:c15="http://schemas.microsoft.com/office/drawing/2012/chart" uri="{CE6537A1-D6FC-4f65-9D91-7224C49458BB}">
+                <c15:showLeaderLines val="0"/>
+              </c:ext>
+            </c:extLst>
+          </c:dLbls>
           <c:cat>
-            <c:multiLvlStrRef>
+            <c:strRef>
               <c:f>Sheet1!$A$2:$A$4</c:f>
-              <c:multiLvlStrCache>
+              <c:strCache>
                 <c:ptCount val="3"/>
-                <c:lvl>
-                  <c:pt idx="0">
-                    <c:v>Base NF4 (15/40)</c:v>
-                  </c:pt>
-                  <c:pt idx="1">
-                    <c:v>QLoRA rango 8 (21/40)</c:v>
-                  </c:pt>
-                  <c:pt idx="2">
-                    <c:v>QLoRA rango 16 (20/40)</c:v>
-                  </c:pt>
-                </c:lvl>
-              </c:multiLvlStrCache>
-            </c:multiLvlStrRef>
+                <c:pt idx="0">
+                  <c:v>Base NF4 (15/40)</c:v>
+                </c:pt>
+                <c:pt idx="1">
+                  <c:v>QLoRA rango 8 (21/40)</c:v>
+                </c:pt>
+                <c:pt idx="2">
+                  <c:v>QLoRA rango 16 (20/40)</c:v>
+                </c:pt>
+              </c:strCache>
+            </c:strRef>
           </c:cat>
           <c:val>
             <c:numRef>
@@ -292,41 +313,28 @@
                   <c:v>43.9</c:v>
                 </c:pt>
                 <c:pt idx="2">
-                  <c:v>40.2</c:v>
+                  <c:v>40.200000000000003</c:v>
                 </c:pt>
               </c:numCache>
             </c:numRef>
           </c:val>
+          <c:extLst>
+            <c:ext xmlns:c16="http://schemas.microsoft.com/office/drawing/2014/chart" uri="{C3380CC4-5D6E-409C-BE32-E72D297353CC}">
+              <c16:uniqueId val="{00000006-3B7E-43C7-969C-AB2733B2CE4A}"/>
+            </c:ext>
+          </c:extLst>
         </c:ser>
         <c:dLbls>
-          <c:numFmt formatCode="0.0&quot;%&quot;" sourceLinked="0"/>
-          <c:txPr>
-            <a:bodyPr/>
-            <a:lstStyle/>
-            <a:p>
-              <a:pPr>
-                <a:defRPr b="1" i="0" strike="noStrike" sz="1400" u="none">
-                  <a:solidFill>
-                    <a:srgbClr val="1F2A33"/>
-                  </a:solidFill>
-                  <a:latin typeface="+mn-lt"/>
-                </a:defRPr>
-              </a:pPr>
-            </a:p>
-          </c:txPr>
           <c:showLegendKey val="0"/>
           <c:showVal val="1"/>
           <c:showCatName val="0"/>
           <c:showSerName val="0"/>
           <c:showPercent val="0"/>
           <c:showBubbleSize val="0"/>
-          <c:showLeaderLines val="0"/>
         </c:dLbls>
         <c:gapWidth val="60"/>
-        <c:overlap val="0"/>
         <c:axId val="2094734554"/>
         <c:axId val="2094734552"/>
-        <c:axId val="2094734556"/>
       </c:barChart>
       <c:catAx>
         <c:axId val="2094734554"/>
@@ -367,6 +375,7 @@
         <c:crosses val="autoZero"/>
         <c:auto val="1"/>
         <c:lblAlgn val="ctr"/>
+        <c:lblOffset val="100"/>
         <c:noMultiLvlLbl val="1"/>
       </c:catAx>
       <c:valAx>
@@ -432,6 +441,7 @@
     </c:plotArea>
     <c:plotVisOnly val="1"/>
     <c:dispBlanksAs val="span"/>
+    <c:showDLblsOverMax val="1"/>
   </c:chart>
   <c:spPr>
     <a:noFill/>
@@ -447,9 +457,11 @@
 </file>
 
 <file path=ppt/charts/chart2.xml><?xml version="1.0" encoding="utf-8"?>
-<c:chartSpace xmlns:c="http://schemas.openxmlformats.org/drawingml/2006/chart" xmlns:a="http://schemas.openxmlformats.org/drawingml/2006/main" xmlns:r="http://schemas.openxmlformats.org/officeDocument/2006/relationships">
+<c:chartSpace xmlns:c="http://schemas.openxmlformats.org/drawingml/2006/chart" xmlns:a="http://schemas.openxmlformats.org/drawingml/2006/main" xmlns:r="http://schemas.openxmlformats.org/officeDocument/2006/relationships" xmlns:c16r2="http://schemas.microsoft.com/office/drawing/2015/06/chart">
   <c:date1904 val="0"/>
+  <c:lang val="es-ES"/>
   <c:roundedCorners val="1"/>
+  <c:style val="2"/>
   <c:chart>
     <c:title>
       <c:tx>
@@ -466,7 +478,7 @@
               </a:defRPr>
             </a:pPr>
             <a:r>
-              <a:rPr sz="1300" b="0" i="0" u="none" strike="noStrike">
+              <a:rPr lang="es-ES" sz="1300" b="0" i="0" u="none" strike="noStrike">
                 <a:solidFill>
                   <a:srgbClr val="1F2A33"/>
                 </a:solidFill>
@@ -477,7 +489,6 @@
           </a:p>
         </c:rich>
       </c:tx>
-      <c:layout/>
       <c:overlay val="0"/>
     </c:title>
     <c:autoTitleDeleted val="0"/>
@@ -510,18 +521,26 @@
           <c:invertIfNegative val="0"/>
           <c:dLbls>
             <c:numFmt formatCode="#,##0" sourceLinked="0"/>
+            <c:spPr>
+              <a:noFill/>
+              <a:ln>
+                <a:noFill/>
+              </a:ln>
+              <a:effectLst/>
+            </c:spPr>
             <c:txPr>
               <a:bodyPr/>
               <a:lstStyle/>
               <a:p>
                 <a:pPr>
-                  <a:defRPr b="1" i="0" strike="noStrike" sz="1300" u="none">
+                  <a:defRPr sz="1300" b="1" i="0" u="none" strike="noStrike">
                     <a:solidFill>
                       <a:srgbClr val="1F2A33"/>
                     </a:solidFill>
                     <a:latin typeface="+mn-lt"/>
                   </a:defRPr>
                 </a:pPr>
+                <a:endParaRPr lang="es-GT"/>
               </a:p>
             </c:txPr>
             <c:showLegendKey val="0"/>
@@ -531,31 +550,34 @@
             <c:showPercent val="0"/>
             <c:showBubbleSize val="0"/>
             <c:showLeaderLines val="0"/>
+            <c:extLst>
+              <c:ext xmlns:c15="http://schemas.microsoft.com/office/drawing/2012/chart" uri="{CE6537A1-D6FC-4f65-9D91-7224C49458BB}">
+                <c15:showLeaderLines val="0"/>
+              </c:ext>
+            </c:extLst>
           </c:dLbls>
           <c:cat>
-            <c:multiLvlStrRef>
+            <c:strRef>
               <c:f>Sheet1!$A$2:$A$6</c:f>
-              <c:multiLvlStrCache>
+              <c:strCache>
                 <c:ptCount val="5"/>
-                <c:lvl>
-                  <c:pt idx="0">
-                    <c:v>Tabla o columna inexistente</c:v>
-                  </c:pt>
-                  <c:pt idx="1">
-                    <c:v>Agregación</c:v>
-                  </c:pt>
-                  <c:pt idx="2">
-                    <c:v>Filtro</c:v>
-                  </c:pt>
-                  <c:pt idx="3">
-                    <c:v>JOIN</c:v>
-                  </c:pt>
-                  <c:pt idx="4">
-                    <c:v>Sintaxis</c:v>
-                  </c:pt>
-                </c:lvl>
-              </c:multiLvlStrCache>
-            </c:multiLvlStrRef>
+                <c:pt idx="0">
+                  <c:v>Tabla o columna inexistente</c:v>
+                </c:pt>
+                <c:pt idx="1">
+                  <c:v>Agregación</c:v>
+                </c:pt>
+                <c:pt idx="2">
+                  <c:v>Filtro</c:v>
+                </c:pt>
+                <c:pt idx="3">
+                  <c:v>JOIN</c:v>
+                </c:pt>
+                <c:pt idx="4">
+                  <c:v>Sintaxis</c:v>
+                </c:pt>
+              </c:strCache>
+            </c:strRef>
           </c:cat>
           <c:val>
             <c:numRef>
@@ -581,36 +603,23 @@
               </c:numCache>
             </c:numRef>
           </c:val>
+          <c:extLst>
+            <c:ext xmlns:c16="http://schemas.microsoft.com/office/drawing/2014/chart" uri="{C3380CC4-5D6E-409C-BE32-E72D297353CC}">
+              <c16:uniqueId val="{00000000-5191-4B78-B65B-0592D13204CC}"/>
+            </c:ext>
+          </c:extLst>
         </c:ser>
         <c:dLbls>
-          <c:numFmt formatCode="#,##0" sourceLinked="0"/>
-          <c:txPr>
-            <a:bodyPr/>
-            <a:lstStyle/>
-            <a:p>
-              <a:pPr>
-                <a:defRPr b="1" i="0" strike="noStrike" sz="1300" u="none">
-                  <a:solidFill>
-                    <a:srgbClr val="1F2A33"/>
-                  </a:solidFill>
-                  <a:latin typeface="+mn-lt"/>
-                </a:defRPr>
-              </a:pPr>
-            </a:p>
-          </c:txPr>
           <c:showLegendKey val="0"/>
           <c:showVal val="1"/>
           <c:showCatName val="0"/>
           <c:showSerName val="0"/>
           <c:showPercent val="0"/>
           <c:showBubbleSize val="0"/>
-          <c:showLeaderLines val="0"/>
         </c:dLbls>
         <c:gapWidth val="50"/>
-        <c:overlap val="0"/>
         <c:axId val="2094734554"/>
         <c:axId val="2094734552"/>
-        <c:axId val="2094734556"/>
       </c:barChart>
       <c:catAx>
         <c:axId val="2094734554"/>
@@ -651,6 +660,7 @@
         <c:crosses val="autoZero"/>
         <c:auto val="1"/>
         <c:lblAlgn val="ctr"/>
+        <c:lblOffset val="100"/>
         <c:noMultiLvlLbl val="1"/>
       </c:catAx>
       <c:valAx>
@@ -661,35 +671,11 @@
           <c:min val="0"/>
         </c:scaling>
         <c:delete val="1"/>
-        <c:axPos val="b"/>
+        <c:axPos val="t"/>
         <c:numFmt formatCode="General" sourceLinked="0"/>
         <c:majorTickMark val="out"/>
         <c:minorTickMark val="none"/>
         <c:tickLblPos val="low"/>
-        <c:spPr>
-          <a:ln w="12700" cap="flat">
-            <a:solidFill>
-              <a:srgbClr val="888888"/>
-            </a:solidFill>
-            <a:prstDash val="solid"/>
-            <a:round/>
-          </a:ln>
-        </c:spPr>
-        <c:txPr>
-          <a:bodyPr/>
-          <a:lstStyle/>
-          <a:p>
-            <a:pPr>
-              <a:defRPr sz="1200" b="0" i="0" u="none" strike="noStrike">
-                <a:solidFill>
-                  <a:srgbClr val="000000"/>
-                </a:solidFill>
-                <a:latin typeface="+mn-lt"/>
-              </a:defRPr>
-            </a:pPr>
-            <a:endParaRPr lang="en-US"/>
-          </a:p>
-        </c:txPr>
         <c:crossAx val="2094734554"/>
         <c:crosses val="autoZero"/>
         <c:crossBetween val="between"/>
@@ -704,6 +690,7 @@
     </c:plotArea>
     <c:plotVisOnly val="1"/>
     <c:dispBlanksAs val="span"/>
+    <c:showDLblsOverMax val="1"/>
   </c:chart>
   <c:spPr>
     <a:noFill/>
@@ -740,234 +727,10 @@
           <a:chExt cx="0" cy="0"/>
         </a:xfrm>
       </p:grpSpPr>
-      <p:sp>
-        <p:nvSpPr>
-          <p:cNvPr id="2" name="Header Placeholder 1"/>
-          <p:cNvSpPr>
-            <a:spLocks noGrp="1"/>
-          </p:cNvSpPr>
-          <p:nvPr>
-            <p:ph type="hdr" sz="quarter"/>
-          </p:nvPr>
-        </p:nvSpPr>
-        <p:spPr>
-          <a:xfrm>
-            <a:off x="0" y="0"/>
-            <a:ext cx="2971800" cy="458788"/>
-          </a:xfrm>
-          <a:prstGeom prst="rect">
-            <a:avLst/>
-          </a:prstGeom>
-        </p:spPr>
-        <p:txBody>
-          <a:bodyPr vert="horz" lIns="91440" tIns="45720" rIns="91440" bIns="45720" rtlCol="0"/>
-          <a:lstStyle>
-            <a:lvl1pPr algn="l">
-              <a:defRPr sz="1200"/>
-            </a:lvl1pPr>
-          </a:lstStyle>
-          <a:p>
-            <a:endParaRPr lang="en-US"/>
-          </a:p>
-        </p:txBody>
-      </p:sp>
-      <p:sp>
-        <p:nvSpPr>
-          <p:cNvPr id="3" name="Date Placeholder 2"/>
-          <p:cNvSpPr>
-            <a:spLocks noGrp="1"/>
-          </p:cNvSpPr>
-          <p:nvPr>
-            <p:ph type="dt" idx="1"/>
-          </p:nvPr>
-        </p:nvSpPr>
-        <p:spPr>
-          <a:xfrm>
-            <a:off x="3884613" y="0"/>
-            <a:ext cx="2971800" cy="458788"/>
-          </a:xfrm>
-          <a:prstGeom prst="rect">
-            <a:avLst/>
-          </a:prstGeom>
-        </p:spPr>
-        <p:txBody>
-          <a:bodyPr vert="horz" lIns="91440" tIns="45720" rIns="91440" bIns="45720" rtlCol="0"/>
-          <a:lstStyle>
-            <a:lvl1pPr algn="r">
-              <a:defRPr sz="1200"/>
-            </a:lvl1pPr>
-          </a:lstStyle>
-          <a:p>
-            <a:fld id="{5282F153-3F37-0F45-9E97-73ACFA13230C}" type="datetimeFigureOut">
-              <a:rPr lang="en-US"/>
-              <a:t>7/23/19</a:t>
-            </a:fld>
-            <a:endParaRPr lang="en-US"/>
-          </a:p>
-        </p:txBody>
-      </p:sp>
-      <p:sp>
-        <p:nvSpPr>
-          <p:cNvPr id="4" name="Slide Image Placeholder 3"/>
-          <p:cNvSpPr>
-            <a:spLocks noGrp="1" noRot="1" noChangeAspect="1"/>
-          </p:cNvSpPr>
-          <p:nvPr>
-            <p:ph type="sldImg" idx="2"/>
-          </p:nvPr>
-        </p:nvSpPr>
-        <p:spPr>
-          <a:xfrm>
-            <a:off x="685800" y="1143000"/>
-            <a:ext cx="5486400" cy="3086100"/>
-          </a:xfrm>
-          <a:prstGeom prst="rect">
-            <a:avLst/>
-          </a:prstGeom>
-          <a:noFill/>
-          <a:ln w="12700">
-            <a:solidFill>
-              <a:prstClr val="black"/>
-            </a:solidFill>
-          </a:ln>
-        </p:spPr>
-        <p:txBody>
-          <a:bodyPr vert="horz" lIns="91440" tIns="45720" rIns="91440" bIns="45720" rtlCol="0" anchor="ctr"/>
-          <a:lstStyle/>
-          <a:p>
-            <a:endParaRPr lang="en-US"/>
-          </a:p>
-        </p:txBody>
-      </p:sp>
-      <p:sp>
-        <p:nvSpPr>
-          <p:cNvPr id="5" name="Notes Placeholder 4"/>
-          <p:cNvSpPr>
-            <a:spLocks noGrp="1"/>
-          </p:cNvSpPr>
-          <p:nvPr>
-            <p:ph type="body" sz="quarter" idx="3"/>
-          </p:nvPr>
-        </p:nvSpPr>
-        <p:spPr>
-          <a:xfrm>
-            <a:off x="685800" y="4400550"/>
-            <a:ext cx="5486400" cy="3600450"/>
-          </a:xfrm>
-          <a:prstGeom prst="rect">
-            <a:avLst/>
-          </a:prstGeom>
-        </p:spPr>
-        <p:txBody>
-          <a:bodyPr vert="horz" lIns="91440" tIns="45720" rIns="91440" bIns="45720" rtlCol="0"/>
-          <a:lstStyle/>
-          <a:p>
-            <a:pPr lvl="0"/>
-            <a:r>
-              <a:rPr lang="en-US"/>
-              <a:t>Click to edit Master text styles</a:t>
-            </a:r>
-          </a:p>
-          <a:p>
-            <a:pPr lvl="1"/>
-            <a:r>
-              <a:rPr lang="en-US"/>
-              <a:t>Second level</a:t>
-            </a:r>
-          </a:p>
-          <a:p>
-            <a:pPr lvl="2"/>
-            <a:r>
-              <a:rPr lang="en-US"/>
-              <a:t>Third level</a:t>
-            </a:r>
-          </a:p>
-          <a:p>
-            <a:pPr lvl="3"/>
-            <a:r>
-              <a:rPr lang="en-US"/>
-              <a:t>Fourth level</a:t>
-            </a:r>
-          </a:p>
-          <a:p>
-            <a:pPr lvl="4"/>
-            <a:r>
-              <a:rPr lang="en-US"/>
-              <a:t>Fifth level</a:t>
-            </a:r>
-          </a:p>
-        </p:txBody>
-      </p:sp>
-      <p:sp>
-        <p:nvSpPr>
-          <p:cNvPr id="6" name="Footer Placeholder 5"/>
-          <p:cNvSpPr>
-            <a:spLocks noGrp="1"/>
-          </p:cNvSpPr>
-          <p:nvPr>
-            <p:ph type="ftr" sz="quarter" idx="4"/>
-          </p:nvPr>
-        </p:nvSpPr>
-        <p:spPr>
-          <a:xfrm>
-            <a:off x="0" y="8685213"/>
-            <a:ext cx="2971800" cy="458787"/>
-          </a:xfrm>
-          <a:prstGeom prst="rect">
-            <a:avLst/>
-          </a:prstGeom>
-        </p:spPr>
-        <p:txBody>
-          <a:bodyPr vert="horz" lIns="91440" tIns="45720" rIns="91440" bIns="45720" rtlCol="0" anchor="b"/>
-          <a:lstStyle>
-            <a:lvl1pPr algn="l">
-              <a:defRPr sz="1200"/>
-            </a:lvl1pPr>
-          </a:lstStyle>
-          <a:p>
-            <a:endParaRPr lang="en-US"/>
-          </a:p>
-        </p:txBody>
-      </p:sp>
-      <p:sp>
-        <p:nvSpPr>
-          <p:cNvPr id="7" name="Slide Number Placeholder 6"/>
-          <p:cNvSpPr>
-            <a:spLocks noGrp="1"/>
-          </p:cNvSpPr>
-          <p:nvPr>
-            <p:ph type="sldNum" sz="quarter" idx="5"/>
-          </p:nvPr>
-        </p:nvSpPr>
-        <p:spPr>
-          <a:xfrm>
-            <a:off x="3884613" y="8685213"/>
-            <a:ext cx="2971800" cy="458787"/>
-          </a:xfrm>
-          <a:prstGeom prst="rect">
-            <a:avLst/>
-          </a:prstGeom>
-        </p:spPr>
-        <p:txBody>
-          <a:bodyPr vert="horz" lIns="91440" tIns="45720" rIns="91440" bIns="45720" rtlCol="0" anchor="b"/>
-          <a:lstStyle>
-            <a:lvl1pPr algn="r">
-              <a:defRPr sz="1200"/>
-            </a:lvl1pPr>
-          </a:lstStyle>
-          <a:p>
-            <a:fld id="{CE5E9CC1-C706-0F49-92D6-E571CC5EEA8F}" type="slidenum">
-              <a:rPr lang="en-US"/>
-              <a:t>‹#›</a:t>
-            </a:fld>
-            <a:endParaRPr lang="en-US"/>
-          </a:p>
-        </p:txBody>
-      </p:sp>
     </p:spTree>
     <p:extLst>
       <p:ext uri="{BB962C8B-B14F-4D97-AF65-F5344CB8AC3E}">
-        <p14:creationId xmlns:p14="http://schemas.microsoft.com/office/powerpoint/2010/main" val="1024086991"/>
+        <p14:creationId xmlns:p14="http://schemas.microsoft.com/office/powerpoint/2010/main" val="512340947"/>
       </p:ext>
     </p:extLst>
   </p:cSld>
@@ -1111,10 +874,6 @@
           <a:bodyPr/>
           <a:lstStyle/>
           <a:p>
-            <a:r>
-              <a:rPr lang="en-US" dirty="0"/>
-              <a:t/>
-            </a:r>
             <a:endParaRPr lang="en-US" dirty="0"/>
           </a:p>
         </p:txBody>
@@ -1199,10 +958,6 @@
           <a:bodyPr/>
           <a:lstStyle/>
           <a:p>
-            <a:r>
-              <a:rPr lang="en-US" dirty="0"/>
-              <a:t/>
-            </a:r>
             <a:endParaRPr lang="en-US" dirty="0"/>
           </a:p>
         </p:txBody>
@@ -1287,10 +1042,6 @@
           <a:bodyPr/>
           <a:lstStyle/>
           <a:p>
-            <a:r>
-              <a:rPr lang="en-US" dirty="0"/>
-              <a:t/>
-            </a:r>
             <a:endParaRPr lang="en-US" dirty="0"/>
           </a:p>
         </p:txBody>
@@ -1375,10 +1126,6 @@
           <a:bodyPr/>
           <a:lstStyle/>
           <a:p>
-            <a:r>
-              <a:rPr lang="en-US" dirty="0"/>
-              <a:t/>
-            </a:r>
             <a:endParaRPr lang="en-US" dirty="0"/>
           </a:p>
         </p:txBody>
@@ -1463,10 +1210,6 @@
           <a:bodyPr/>
           <a:lstStyle/>
           <a:p>
-            <a:r>
-              <a:rPr lang="en-US" dirty="0"/>
-              <a:t/>
-            </a:r>
             <a:endParaRPr lang="en-US" dirty="0"/>
           </a:p>
         </p:txBody>
@@ -1551,10 +1294,6 @@
           <a:bodyPr/>
           <a:lstStyle/>
           <a:p>
-            <a:r>
-              <a:rPr lang="en-US" dirty="0"/>
-              <a:t/>
-            </a:r>
             <a:endParaRPr lang="en-US" dirty="0"/>
           </a:p>
         </p:txBody>
@@ -1639,10 +1378,6 @@
           <a:bodyPr/>
           <a:lstStyle/>
           <a:p>
-            <a:r>
-              <a:rPr lang="en-US" dirty="0"/>
-              <a:t/>
-            </a:r>
             <a:endParaRPr lang="en-US" dirty="0"/>
           </a:p>
         </p:txBody>
@@ -1727,10 +1462,6 @@
           <a:bodyPr/>
           <a:lstStyle/>
           <a:p>
-            <a:r>
-              <a:rPr lang="en-US" dirty="0"/>
-              <a:t/>
-            </a:r>
             <a:endParaRPr lang="en-US" dirty="0"/>
           </a:p>
         </p:txBody>
@@ -1815,10 +1546,6 @@
           <a:bodyPr/>
           <a:lstStyle/>
           <a:p>
-            <a:r>
-              <a:rPr lang="en-US" dirty="0"/>
-              <a:t/>
-            </a:r>
             <a:endParaRPr lang="en-US" dirty="0"/>
           </a:p>
         </p:txBody>
@@ -1903,10 +1630,6 @@
           <a:bodyPr/>
           <a:lstStyle/>
           <a:p>
-            <a:r>
-              <a:rPr lang="en-US" dirty="0"/>
-              <a:t/>
-            </a:r>
             <a:endParaRPr lang="en-US" dirty="0"/>
           </a:p>
         </p:txBody>
@@ -1991,10 +1714,6 @@
           <a:bodyPr/>
           <a:lstStyle/>
           <a:p>
-            <a:r>
-              <a:rPr lang="en-US" dirty="0"/>
-              <a:t/>
-            </a:r>
             <a:endParaRPr lang="en-US" dirty="0"/>
           </a:p>
         </p:txBody>
@@ -2073,6 +1792,7 @@
         <a:solidFill>
           <a:srgbClr val="FFFFFF"/>
         </a:solidFill>
+        <a:effectLst/>
       </p:bgPr>
     </p:bg>
     <p:spTree>
@@ -2105,6 +1825,7 @@
         <a:solidFill>
           <a:srgbClr val="FFFFFF"/>
         </a:solidFill>
+        <a:effectLst/>
       </p:bgPr>
     </p:bg>
     <p:spTree>
@@ -2124,9 +1845,11 @@
       <p:sp>
         <p:nvSpPr>
           <p:cNvPr id="2" name="Text 0"/>
-          <p:cNvSpPr/>
+          <p:cNvSpPr>
+            <a:spLocks noGrp="1"/>
+          </p:cNvSpPr>
           <p:nvPr>
-            <p:ph idx="100" type="title" hasCustomPrompt="1"/>
+            <p:ph type="title" idx="100" hasCustomPrompt="1"/>
           </p:nvPr>
         </p:nvSpPr>
         <p:spPr>
@@ -2143,7 +1866,7 @@
         <p:txBody>
           <a:bodyPr wrap="square" rtlCol="0"/>
           <a:lstStyle>
-            <a:lvl1pPr algn="l" indent="0" marL="0">
+            <a:lvl1pPr marL="0" indent="0" algn="l">
               <a:buNone/>
               <a:defRPr lang="en-US" sz="3400" b="1" dirty="0">
                 <a:solidFill>
@@ -2153,7 +1876,7 @@
             </a:lvl1pPr>
           </a:lstStyle>
           <a:p>
-            <a:pPr algn="l" indent="0" marL="0">
+            <a:pPr marL="0" indent="0" algn="l">
               <a:buNone/>
             </a:pPr>
             <a:endParaRPr lang="en-US" sz="3400" dirty="0"/>
@@ -2180,7 +1903,7 @@
           </a:prstGeom>
           <a:extLst>
             <a:ext uri="{C572A759-6A51-4108-AA02-DFA0A04FC94B}">
-              <ma14:wrappingTextBoxFlag xmlns:ma14="http://schemas.microsoft.com/office/mac/drawingml/2011/main" val="0"/>
+              <ma14:wrappingTextBoxFlag xmlns:ma14="http://schemas.microsoft.com/office/mac/drawingml/2011/main" xmlns="" val="0"/>
             </a:ext>
           </a:extLst>
         </p:spPr>
@@ -2198,8 +1921,8 @@
           <a:p>
             <a:pPr algn="r"/>
             <a:fld id="{F7021451-1387-4CA6-816F-3879F97B5CBC}" type="slidenum">
-              <a:rPr b="0" lang="en-US"/>
-              <a:t>1003</a:t>
+              <a:rPr lang="en-US" b="0"/>
+              <a:t>‹Nº›</a:t>
             </a:fld>
             <a:endParaRPr lang="en-US"/>
           </a:p>
@@ -2216,6 +1939,11 @@
 <file path=ppt/slideMasters/slideMaster1.xml><?xml version="1.0" encoding="utf-8"?>
 <p:sldMaster xmlns:a="http://schemas.openxmlformats.org/drawingml/2006/main" xmlns:r="http://schemas.openxmlformats.org/officeDocument/2006/relationships" xmlns:p="http://schemas.openxmlformats.org/presentationml/2006/main">
   <p:cSld>
+    <p:bg>
+      <p:bgRef idx="1001">
+        <a:schemeClr val="bg1"/>
+      </p:bgRef>
+    </p:bg>
     <p:spTree>
       <p:nvGrpSpPr>
         <p:cNvPr id="1" name=""/>
@@ -2250,7 +1978,7 @@
           </a:prstGeom>
           <a:extLst>
             <a:ext uri="{C572A759-6A51-4108-AA02-DFA0A04FC94B}">
-              <ma14:wrappingTextBoxFlag xmlns:ma14="http://schemas.microsoft.com/office/mac/drawingml/2011/main" val="0"/>
+              <ma14:wrappingTextBoxFlag xmlns:ma14="http://schemas.microsoft.com/office/mac/drawingml/2011/main" xmlns="" val="0"/>
             </a:ext>
           </a:extLst>
         </p:spPr>
@@ -2268,8 +1996,8 @@
           <a:p>
             <a:pPr algn="r"/>
             <a:fld id="{F7021451-1387-4CA6-816F-3879F97B5CBC}" type="slidenum">
-              <a:rPr b="0" lang="en-US"/>
-              <a:t>null</a:t>
+              <a:rPr lang="en-US" b="0"/>
+              <a:t>‹Nº›</a:t>
             </a:fld>
             <a:endParaRPr lang="en-US"/>
           </a:p>
@@ -2562,7 +2290,7 @@
         </p:nvSpPr>
         <p:spPr>
           <a:xfrm>
-            <a:off x="6309360" y="640080"/>
+            <a:off x="5806440" y="594360"/>
             <a:ext cx="3291840" cy="3291840"/>
           </a:xfrm>
           <a:prstGeom prst="ellipse">
@@ -2578,6 +2306,13 @@
             <a:prstDash val="solid"/>
           </a:ln>
         </p:spPr>
+        <p:txBody>
+          <a:bodyPr/>
+          <a:lstStyle/>
+          <a:p>
+            <a:endParaRPr lang="es-GT"/>
+          </a:p>
+        </p:txBody>
       </p:sp>
       <p:sp>
         <p:nvSpPr>
@@ -2603,6 +2338,13 @@
             <a:prstDash val="solid"/>
           </a:ln>
         </p:spPr>
+        <p:txBody>
+          <a:bodyPr/>
+          <a:lstStyle/>
+          <a:p>
+            <a:endParaRPr lang="es-GT"/>
+          </a:p>
+        </p:txBody>
       </p:sp>
       <p:sp>
         <p:nvSpPr>
@@ -2625,7 +2367,7 @@
           <a:bodyPr wrap="square" lIns="0" tIns="0" rIns="0" bIns="0" rtlCol="0" anchor="ctr"/>
           <a:lstStyle/>
           <a:p>
-            <a:pPr indent="0" marL="0">
+            <a:pPr marL="0" indent="0">
               <a:buNone/>
             </a:pPr>
             <a:r>
@@ -2664,7 +2406,7 @@
           <a:bodyPr wrap="square" lIns="0" tIns="0" rIns="0" bIns="0" rtlCol="0" anchor="t"/>
           <a:lstStyle/>
           <a:p>
-            <a:pPr indent="0" marL="0">
+            <a:pPr marL="0" indent="0">
               <a:buNone/>
             </a:pPr>
             <a:r>
@@ -2700,7 +2442,7 @@
           <a:bodyPr wrap="square" lIns="0" tIns="0" rIns="0" bIns="0" rtlCol="0" anchor="t"/>
           <a:lstStyle/>
           <a:p>
-            <a:pPr indent="0" marL="0">
+            <a:pPr marL="0" indent="0">
               <a:spcAft>
                 <a:spcPts val="600"/>
               </a:spcAft>
@@ -2717,7 +2459,7 @@
             <a:endParaRPr lang="en-US" sz="1600" dirty="0"/>
           </a:p>
           <a:p>
-            <a:pPr indent="0" marL="0">
+            <a:pPr marL="0" indent="0">
               <a:spcAft>
                 <a:spcPts val="600"/>
               </a:spcAft>
@@ -2763,9 +2505,11 @@
       <p:sp>
         <p:nvSpPr>
           <p:cNvPr id="2" name="Text 0"/>
-          <p:cNvSpPr/>
+          <p:cNvSpPr>
+            <a:spLocks noGrp="1"/>
+          </p:cNvSpPr>
           <p:nvPr>
-            <p:ph idx="100" type="title" hasCustomPrompt="1"/>
+            <p:ph type="title" idx="100" hasCustomPrompt="1"/>
           </p:nvPr>
         </p:nvSpPr>
         <p:spPr>
@@ -2783,7 +2527,7 @@
           <a:bodyPr wrap="square" lIns="0" tIns="0" rIns="0" bIns="0" rtlCol="0" anchor="ctr"/>
           <a:lstStyle/>
           <a:p>
-            <a:pPr algn="l" indent="0" marL="0">
+            <a:pPr marL="0" indent="0" algn="l">
               <a:buNone/>
             </a:pPr>
             <a:r>
@@ -2795,42 +2539,6 @@
               <a:t>Verificación de inferencia</a:t>
             </a:r>
             <a:endParaRPr lang="en-US" sz="3400" dirty="0"/>
-          </a:p>
-        </p:txBody>
-      </p:sp>
-      <p:sp>
-        <p:nvSpPr>
-          <p:cNvPr id="3" name="Text 1"/>
-          <p:cNvSpPr txBox="1"/>
-          <p:nvPr/>
-        </p:nvSpPr>
-        <p:spPr>
-          <a:xfrm>
-            <a:off x="548640" y="4754880"/>
-            <a:ext cx="7498080" cy="274320"/>
-          </a:xfrm>
-          <a:prstGeom prst="rect">
-            <a:avLst/>
-          </a:prstGeom>
-          <a:noFill/>
-          <a:ln/>
-        </p:spPr>
-        <p:txBody>
-          <a:bodyPr wrap="square" lIns="0" tIns="0" rIns="0" bIns="0" rtlCol="0" anchor="ctr"/>
-          <a:lstStyle/>
-          <a:p>
-            <a:pPr indent="0" marL="0">
-              <a:buNone/>
-            </a:pPr>
-            <a:r>
-              <a:rPr lang="en-US" sz="1000" dirty="0">
-                <a:solidFill>
-                  <a:schemeClr val="accent3"/>
-                </a:solidFill>
-              </a:rPr>
-              <a:t>Fuente: README.md, BITACORA.md</a:t>
-            </a:r>
-            <a:endParaRPr lang="en-US" sz="1000" dirty="0"/>
           </a:p>
         </p:txBody>
       </p:sp>
@@ -2860,6 +2568,13 @@
             <a:prstDash val="solid"/>
           </a:ln>
         </p:spPr>
+        <p:txBody>
+          <a:bodyPr/>
+          <a:lstStyle/>
+          <a:p>
+            <a:endParaRPr lang="es-GT"/>
+          </a:p>
+        </p:txBody>
       </p:sp>
       <p:sp>
         <p:nvSpPr>
@@ -2882,7 +2597,7 @@
           <a:bodyPr wrap="square" lIns="0" tIns="0" rIns="0" bIns="0" rtlCol="0" anchor="ctr"/>
           <a:lstStyle/>
           <a:p>
-            <a:pPr algn="l" indent="0" marL="0">
+            <a:pPr marL="0" indent="0" algn="l">
               <a:buNone/>
             </a:pPr>
             <a:r>
@@ -2921,7 +2636,7 @@
           <a:bodyPr wrap="square" lIns="0" tIns="0" rIns="0" bIns="0" rtlCol="0" anchor="t"/>
           <a:lstStyle/>
           <a:p>
-            <a:pPr algn="l" indent="0" marL="0">
+            <a:pPr marL="0" indent="0" algn="l">
               <a:buNone/>
             </a:pPr>
             <a:r>
@@ -2962,6 +2677,13 @@
             <a:prstDash val="solid"/>
           </a:ln>
         </p:spPr>
+        <p:txBody>
+          <a:bodyPr/>
+          <a:lstStyle/>
+          <a:p>
+            <a:endParaRPr lang="es-GT"/>
+          </a:p>
+        </p:txBody>
       </p:sp>
       <p:sp>
         <p:nvSpPr>
@@ -2984,7 +2706,7 @@
           <a:bodyPr wrap="square" lIns="0" tIns="0" rIns="0" bIns="0" rtlCol="0" anchor="ctr"/>
           <a:lstStyle/>
           <a:p>
-            <a:pPr algn="l" indent="0" marL="0">
+            <a:pPr marL="0" indent="0" algn="l">
               <a:buNone/>
             </a:pPr>
             <a:r>
@@ -3023,7 +2745,7 @@
           <a:bodyPr wrap="square" lIns="0" tIns="0" rIns="0" bIns="0" rtlCol="0" anchor="t"/>
           <a:lstStyle/>
           <a:p>
-            <a:pPr algn="l" indent="0" marL="0">
+            <a:pPr marL="0" indent="0" algn="l">
               <a:buNone/>
             </a:pPr>
             <a:r>
@@ -3064,6 +2786,13 @@
             <a:prstDash val="solid"/>
           </a:ln>
         </p:spPr>
+        <p:txBody>
+          <a:bodyPr/>
+          <a:lstStyle/>
+          <a:p>
+            <a:endParaRPr lang="es-GT"/>
+          </a:p>
+        </p:txBody>
       </p:sp>
       <p:sp>
         <p:nvSpPr>
@@ -3086,7 +2815,7 @@
           <a:bodyPr wrap="square" lIns="0" tIns="0" rIns="0" bIns="0" rtlCol="0" anchor="ctr"/>
           <a:lstStyle/>
           <a:p>
-            <a:pPr algn="l" indent="0" marL="0">
+            <a:pPr marL="0" indent="0" algn="l">
               <a:buNone/>
             </a:pPr>
             <a:r>
@@ -3125,7 +2854,7 @@
           <a:bodyPr wrap="square" lIns="0" tIns="0" rIns="0" bIns="0" rtlCol="0" anchor="t"/>
           <a:lstStyle/>
           <a:p>
-            <a:pPr algn="l" indent="0" marL="0">
+            <a:pPr marL="0" indent="0" algn="l">
               <a:buNone/>
             </a:pPr>
             <a:r>
@@ -3166,6 +2895,13 @@
             <a:prstDash val="solid"/>
           </a:ln>
         </p:spPr>
+        <p:txBody>
+          <a:bodyPr/>
+          <a:lstStyle/>
+          <a:p>
+            <a:endParaRPr lang="es-GT"/>
+          </a:p>
+        </p:txBody>
       </p:sp>
       <p:sp>
         <p:nvSpPr>
@@ -3188,7 +2924,7 @@
           <a:bodyPr wrap="square" lIns="0" tIns="0" rIns="0" bIns="0" rtlCol="0" anchor="ctr"/>
           <a:lstStyle/>
           <a:p>
-            <a:pPr algn="ctr" indent="0" marL="0">
+            <a:pPr marL="0" indent="0" algn="ctr">
               <a:buNone/>
             </a:pPr>
             <a:r>
@@ -3229,6 +2965,13 @@
             <a:prstDash val="solid"/>
           </a:ln>
         </p:spPr>
+        <p:txBody>
+          <a:bodyPr/>
+          <a:lstStyle/>
+          <a:p>
+            <a:endParaRPr lang="es-GT"/>
+          </a:p>
+        </p:txBody>
       </p:sp>
       <p:sp>
         <p:nvSpPr>
@@ -3251,7 +2994,7 @@
           <a:bodyPr wrap="square" lIns="0" tIns="0" rIns="0" bIns="0" rtlCol="0" anchor="ctr"/>
           <a:lstStyle/>
           <a:p>
-            <a:pPr algn="ctr" indent="0" marL="0">
+            <a:pPr marL="0" indent="0" algn="ctr">
               <a:buNone/>
             </a:pPr>
             <a:r>
@@ -3292,6 +3035,13 @@
             <a:prstDash val="solid"/>
           </a:ln>
         </p:spPr>
+        <p:txBody>
+          <a:bodyPr/>
+          <a:lstStyle/>
+          <a:p>
+            <a:endParaRPr lang="es-GT"/>
+          </a:p>
+        </p:txBody>
       </p:sp>
       <p:sp>
         <p:nvSpPr>
@@ -3314,7 +3064,7 @@
           <a:bodyPr wrap="square" lIns="0" tIns="0" rIns="0" bIns="0" rtlCol="0" anchor="ctr"/>
           <a:lstStyle/>
           <a:p>
-            <a:pPr algn="ctr" indent="0" marL="0">
+            <a:pPr marL="0" indent="0" algn="ctr">
               <a:buNone/>
             </a:pPr>
             <a:r>
@@ -3355,6 +3105,13 @@
             <a:prstDash val="solid"/>
           </a:ln>
         </p:spPr>
+        <p:txBody>
+          <a:bodyPr/>
+          <a:lstStyle/>
+          <a:p>
+            <a:endParaRPr lang="es-GT"/>
+          </a:p>
+        </p:txBody>
       </p:sp>
       <p:sp>
         <p:nvSpPr>
@@ -3377,7 +3134,7 @@
           <a:bodyPr wrap="square" lIns="0" tIns="0" rIns="0" bIns="0" rtlCol="0" anchor="ctr"/>
           <a:lstStyle/>
           <a:p>
-            <a:pPr algn="ctr" indent="0" marL="0">
+            <a:pPr marL="0" indent="0" algn="ctr">
               <a:buNone/>
             </a:pPr>
             <a:r>
@@ -3413,7 +3170,7 @@
           <a:bodyPr wrap="square" lIns="0" tIns="0" rIns="0" bIns="0" rtlCol="0" anchor="ctr"/>
           <a:lstStyle/>
           <a:p>
-            <a:pPr indent="0" marL="0">
+            <a:pPr marL="0" indent="0">
               <a:buNone/>
             </a:pPr>
             <a:r>
@@ -3448,7 +3205,7 @@
           </a:prstGeom>
           <a:extLst>
             <a:ext uri="{C572A759-6A51-4108-AA02-DFA0A04FC94B}">
-              <ma14:wrappingTextBoxFlag xmlns:ma14="http://schemas.microsoft.com/office/mac/drawingml/2011/main" val="0"/>
+              <ma14:wrappingTextBoxFlag xmlns:ma14="http://schemas.microsoft.com/office/mac/drawingml/2011/main" xmlns="" val="0"/>
             </a:ext>
           </a:extLst>
         </p:spPr>
@@ -3466,7 +3223,7 @@
           <a:p>
             <a:pPr algn="r"/>
             <a:fld id="{F7021451-1387-4CA6-816F-3879F97B5CBC}" type="slidenum">
-              <a:rPr b="0" lang="en-US"/>
+              <a:rPr lang="en-US" b="0"/>
               <a:t>10</a:t>
             </a:fld>
             <a:endParaRPr lang="en-US"/>
@@ -3501,9 +3258,11 @@
       <p:sp>
         <p:nvSpPr>
           <p:cNvPr id="2" name="Text 0"/>
-          <p:cNvSpPr/>
+          <p:cNvSpPr>
+            <a:spLocks noGrp="1"/>
+          </p:cNvSpPr>
           <p:nvPr>
-            <p:ph idx="100" type="title" hasCustomPrompt="1"/>
+            <p:ph type="title" idx="100" hasCustomPrompt="1"/>
           </p:nvPr>
         </p:nvSpPr>
         <p:spPr>
@@ -3521,7 +3280,7 @@
           <a:bodyPr wrap="square" lIns="0" tIns="0" rIns="0" bIns="0" rtlCol="0" anchor="ctr"/>
           <a:lstStyle/>
           <a:p>
-            <a:pPr algn="l" indent="0" marL="0">
+            <a:pPr marL="0" indent="0" algn="l">
               <a:buNone/>
             </a:pPr>
             <a:r>
@@ -3533,42 +3292,6 @@
               <a:t>Conclusiones y predicción</a:t>
             </a:r>
             <a:endParaRPr lang="en-US" sz="3400" dirty="0"/>
-          </a:p>
-        </p:txBody>
-      </p:sp>
-      <p:sp>
-        <p:nvSpPr>
-          <p:cNvPr id="3" name="Text 1"/>
-          <p:cNvSpPr txBox="1"/>
-          <p:nvPr/>
-        </p:nvSpPr>
-        <p:spPr>
-          <a:xfrm>
-            <a:off x="548640" y="4754880"/>
-            <a:ext cx="7498080" cy="274320"/>
-          </a:xfrm>
-          <a:prstGeom prst="rect">
-            <a:avLst/>
-          </a:prstGeom>
-          <a:noFill/>
-          <a:ln/>
-        </p:spPr>
-        <p:txBody>
-          <a:bodyPr wrap="square" lIns="0" tIns="0" rIns="0" bIns="0" rtlCol="0" anchor="ctr"/>
-          <a:lstStyle/>
-          <a:p>
-            <a:pPr indent="0" marL="0">
-              <a:buNone/>
-            </a:pPr>
-            <a:r>
-              <a:rPr lang="en-US" sz="1000" dirty="0">
-                <a:solidFill>
-                  <a:schemeClr val="accent3"/>
-                </a:solidFill>
-              </a:rPr>
-              <a:t>Fuente: README.md, resultados/lora_r8.json</a:t>
-            </a:r>
-            <a:endParaRPr lang="en-US" sz="1000" dirty="0"/>
           </a:p>
         </p:txBody>
       </p:sp>
@@ -3598,6 +3321,13 @@
             <a:prstDash val="solid"/>
           </a:ln>
         </p:spPr>
+        <p:txBody>
+          <a:bodyPr/>
+          <a:lstStyle/>
+          <a:p>
+            <a:endParaRPr lang="es-GT"/>
+          </a:p>
+        </p:txBody>
       </p:sp>
       <p:sp>
         <p:nvSpPr>
@@ -3620,7 +3350,7 @@
           <a:bodyPr wrap="square" lIns="0" tIns="0" rIns="0" bIns="0" rtlCol="0" anchor="ctr"/>
           <a:lstStyle/>
           <a:p>
-            <a:pPr algn="l" indent="0" marL="0">
+            <a:pPr marL="0" indent="0" algn="l">
               <a:buNone/>
             </a:pPr>
             <a:r>
@@ -3659,7 +3389,7 @@
           <a:bodyPr wrap="square" lIns="0" tIns="0" rIns="0" bIns="0" rtlCol="0" anchor="t"/>
           <a:lstStyle/>
           <a:p>
-            <a:pPr algn="l" indent="0" marL="0">
+            <a:pPr marL="0" indent="0" algn="l">
               <a:buNone/>
             </a:pPr>
             <a:r>
@@ -3700,6 +3430,13 @@
             <a:prstDash val="solid"/>
           </a:ln>
         </p:spPr>
+        <p:txBody>
+          <a:bodyPr/>
+          <a:lstStyle/>
+          <a:p>
+            <a:endParaRPr lang="es-GT"/>
+          </a:p>
+        </p:txBody>
       </p:sp>
       <p:sp>
         <p:nvSpPr>
@@ -3722,7 +3459,7 @@
           <a:bodyPr wrap="square" lIns="0" tIns="0" rIns="0" bIns="0" rtlCol="0" anchor="ctr"/>
           <a:lstStyle/>
           <a:p>
-            <a:pPr algn="l" indent="0" marL="0">
+            <a:pPr marL="0" indent="0" algn="l">
               <a:buNone/>
             </a:pPr>
             <a:r>
@@ -3761,7 +3498,7 @@
           <a:bodyPr wrap="square" lIns="0" tIns="0" rIns="0" bIns="0" rtlCol="0" anchor="t"/>
           <a:lstStyle/>
           <a:p>
-            <a:pPr algn="l" indent="0" marL="0">
+            <a:pPr marL="0" indent="0" algn="l">
               <a:buNone/>
             </a:pPr>
             <a:r>
@@ -3802,6 +3539,13 @@
             <a:prstDash val="solid"/>
           </a:ln>
         </p:spPr>
+        <p:txBody>
+          <a:bodyPr/>
+          <a:lstStyle/>
+          <a:p>
+            <a:endParaRPr lang="es-GT"/>
+          </a:p>
+        </p:txBody>
       </p:sp>
       <p:sp>
         <p:nvSpPr>
@@ -3824,7 +3568,7 @@
           <a:bodyPr wrap="square" lIns="0" tIns="0" rIns="0" bIns="0" rtlCol="0" anchor="ctr"/>
           <a:lstStyle/>
           <a:p>
-            <a:pPr algn="l" indent="0" marL="0">
+            <a:pPr marL="0" indent="0" algn="l">
               <a:buNone/>
             </a:pPr>
             <a:r>
@@ -3863,7 +3607,7 @@
           <a:bodyPr wrap="square" lIns="0" tIns="0" rIns="0" bIns="0" rtlCol="0" anchor="t"/>
           <a:lstStyle/>
           <a:p>
-            <a:pPr algn="l" indent="0" marL="0">
+            <a:pPr marL="0" indent="0" algn="l">
               <a:buNone/>
             </a:pPr>
             <a:r>
@@ -3904,6 +3648,13 @@
             <a:prstDash val="solid"/>
           </a:ln>
         </p:spPr>
+        <p:txBody>
+          <a:bodyPr/>
+          <a:lstStyle/>
+          <a:p>
+            <a:endParaRPr lang="es-GT"/>
+          </a:p>
+        </p:txBody>
       </p:sp>
       <p:sp>
         <p:nvSpPr>
@@ -3926,7 +3677,7 @@
           <a:bodyPr wrap="square" lIns="0" tIns="0" rIns="0" bIns="0" rtlCol="0" anchor="ctr"/>
           <a:lstStyle/>
           <a:p>
-            <a:pPr algn="l" indent="0" marL="0">
+            <a:pPr marL="0" indent="0" algn="l">
               <a:buNone/>
             </a:pPr>
             <a:r>
@@ -3965,7 +3716,7 @@
           <a:bodyPr wrap="square" lIns="0" tIns="0" rIns="0" bIns="0" rtlCol="0" anchor="t"/>
           <a:lstStyle/>
           <a:p>
-            <a:pPr algn="l" indent="0" marL="0">
+            <a:pPr marL="0" indent="0" algn="l">
               <a:buNone/>
             </a:pPr>
             <a:r>
@@ -4001,7 +3752,7 @@
           <a:bodyPr wrap="square" lIns="0" tIns="0" rIns="0" bIns="0" rtlCol="0" anchor="ctr"/>
           <a:lstStyle/>
           <a:p>
-            <a:pPr indent="0" marL="0">
+            <a:pPr marL="0" indent="0">
               <a:buNone/>
             </a:pPr>
             <a:r>
@@ -4037,7 +3788,7 @@
           <a:bodyPr wrap="square" lIns="0" tIns="0" rIns="0" bIns="0" rtlCol="0" anchor="ctr"/>
           <a:lstStyle/>
           <a:p>
-            <a:pPr indent="0" marL="0">
+            <a:pPr marL="0" indent="0">
               <a:buNone/>
             </a:pPr>
             <a:r>
@@ -4078,6 +3829,13 @@
             <a:prstDash val="solid"/>
           </a:ln>
         </p:spPr>
+        <p:txBody>
+          <a:bodyPr/>
+          <a:lstStyle/>
+          <a:p>
+            <a:endParaRPr lang="es-GT"/>
+          </a:p>
+        </p:txBody>
       </p:sp>
       <p:sp>
         <p:nvSpPr>
@@ -4100,7 +3858,7 @@
           <a:bodyPr wrap="square" lIns="0" tIns="0" rIns="0" bIns="0" rtlCol="0" anchor="ctr"/>
           <a:lstStyle/>
           <a:p>
-            <a:pPr indent="0" marL="0">
+            <a:pPr marL="0" indent="0">
               <a:buNone/>
             </a:pPr>
             <a:r>
@@ -4141,6 +3899,13 @@
             <a:prstDash val="solid"/>
           </a:ln>
         </p:spPr>
+        <p:txBody>
+          <a:bodyPr/>
+          <a:lstStyle/>
+          <a:p>
+            <a:endParaRPr lang="es-GT"/>
+          </a:p>
+        </p:txBody>
       </p:sp>
       <p:sp>
         <p:nvSpPr>
@@ -4163,7 +3928,7 @@
           <a:bodyPr wrap="square" lIns="0" tIns="0" rIns="0" bIns="0" rtlCol="0" anchor="ctr"/>
           <a:lstStyle/>
           <a:p>
-            <a:pPr indent="0" marL="0">
+            <a:pPr marL="0" indent="0">
               <a:buNone/>
             </a:pPr>
             <a:r>
@@ -4204,6 +3969,13 @@
             <a:prstDash val="solid"/>
           </a:ln>
         </p:spPr>
+        <p:txBody>
+          <a:bodyPr/>
+          <a:lstStyle/>
+          <a:p>
+            <a:endParaRPr lang="es-GT"/>
+          </a:p>
+        </p:txBody>
       </p:sp>
       <p:sp>
         <p:nvSpPr>
@@ -4226,7 +3998,7 @@
           <a:bodyPr wrap="square" lIns="0" tIns="0" rIns="0" bIns="0" rtlCol="0" anchor="ctr"/>
           <a:lstStyle/>
           <a:p>
-            <a:pPr indent="0" marL="0">
+            <a:pPr marL="0" indent="0">
               <a:buNone/>
             </a:pPr>
             <a:r>
@@ -4261,7 +4033,7 @@
           </a:prstGeom>
           <a:extLst>
             <a:ext uri="{C572A759-6A51-4108-AA02-DFA0A04FC94B}">
-              <ma14:wrappingTextBoxFlag xmlns:ma14="http://schemas.microsoft.com/office/mac/drawingml/2011/main" val="0"/>
+              <ma14:wrappingTextBoxFlag xmlns:ma14="http://schemas.microsoft.com/office/mac/drawingml/2011/main" xmlns="" val="0"/>
             </a:ext>
           </a:extLst>
         </p:spPr>
@@ -4279,7 +4051,7 @@
           <a:p>
             <a:pPr algn="r"/>
             <a:fld id="{F7021451-1387-4CA6-816F-3879F97B5CBC}" type="slidenum">
-              <a:rPr b="0" lang="en-US"/>
+              <a:rPr lang="en-US" b="0"/>
               <a:t>11</a:t>
             </a:fld>
             <a:endParaRPr lang="en-US"/>
@@ -4314,9 +4086,11 @@
       <p:sp>
         <p:nvSpPr>
           <p:cNvPr id="2" name="Text 0"/>
-          <p:cNvSpPr/>
+          <p:cNvSpPr>
+            <a:spLocks noGrp="1"/>
+          </p:cNvSpPr>
           <p:nvPr>
-            <p:ph idx="100" type="title" hasCustomPrompt="1"/>
+            <p:ph type="title" idx="100" hasCustomPrompt="1"/>
           </p:nvPr>
         </p:nvSpPr>
         <p:spPr>
@@ -4334,7 +4108,7 @@
           <a:bodyPr wrap="square" lIns="0" tIns="0" rIns="0" bIns="0" rtlCol="0" anchor="ctr"/>
           <a:lstStyle/>
           <a:p>
-            <a:pPr algn="l" indent="0" marL="0">
+            <a:pPr marL="0" indent="0" algn="l">
               <a:buNone/>
             </a:pPr>
             <a:r>
@@ -4346,42 +4120,6 @@
               <a:t>Objetivo y funcionamiento</a:t>
             </a:r>
             <a:endParaRPr lang="en-US" sz="3400" dirty="0"/>
-          </a:p>
-        </p:txBody>
-      </p:sp>
-      <p:sp>
-        <p:nvSpPr>
-          <p:cNvPr id="3" name="Text 1"/>
-          <p:cNvSpPr txBox="1"/>
-          <p:nvPr/>
-        </p:nvSpPr>
-        <p:spPr>
-          <a:xfrm>
-            <a:off x="548640" y="4754880"/>
-            <a:ext cx="7498080" cy="274320"/>
-          </a:xfrm>
-          <a:prstGeom prst="rect">
-            <a:avLst/>
-          </a:prstGeom>
-          <a:noFill/>
-          <a:ln/>
-        </p:spPr>
-        <p:txBody>
-          <a:bodyPr wrap="square" lIns="0" tIns="0" rIns="0" bIns="0" rtlCol="0" anchor="ctr"/>
-          <a:lstStyle/>
-          <a:p>
-            <a:pPr indent="0" marL="0">
-              <a:buNone/>
-            </a:pPr>
-            <a:r>
-              <a:rPr lang="en-US" sz="1000" dirty="0">
-                <a:solidFill>
-                  <a:schemeClr val="accent3"/>
-                </a:solidFill>
-              </a:rPr>
-              <a:t>Fuente: solucion.py, config.json</a:t>
-            </a:r>
-            <a:endParaRPr lang="en-US" sz="1000" dirty="0"/>
           </a:p>
         </p:txBody>
       </p:sp>
@@ -4411,6 +4149,13 @@
             <a:prstDash val="solid"/>
           </a:ln>
         </p:spPr>
+        <p:txBody>
+          <a:bodyPr/>
+          <a:lstStyle/>
+          <a:p>
+            <a:endParaRPr lang="es-GT"/>
+          </a:p>
+        </p:txBody>
       </p:sp>
       <p:sp>
         <p:nvSpPr>
@@ -4433,7 +4178,7 @@
           <a:bodyPr wrap="square" lIns="0" tIns="0" rIns="0" bIns="0" rtlCol="0" anchor="ctr"/>
           <a:lstStyle/>
           <a:p>
-            <a:pPr algn="ctr" indent="0" marL="0">
+            <a:pPr marL="0" indent="0" algn="ctr">
               <a:buNone/>
             </a:pPr>
             <a:r>
@@ -4469,7 +4214,7 @@
           <a:bodyPr wrap="square" lIns="0" tIns="0" rIns="0" bIns="0" rtlCol="0" anchor="ctr"/>
           <a:lstStyle/>
           <a:p>
-            <a:pPr algn="ctr" indent="0" marL="0">
+            <a:pPr marL="0" indent="0" algn="ctr">
               <a:buNone/>
             </a:pPr>
             <a:r>
@@ -4510,6 +4255,13 @@
             <a:prstDash val="solid"/>
           </a:ln>
         </p:spPr>
+        <p:txBody>
+          <a:bodyPr/>
+          <a:lstStyle/>
+          <a:p>
+            <a:endParaRPr lang="es-GT"/>
+          </a:p>
+        </p:txBody>
       </p:sp>
       <p:sp>
         <p:nvSpPr>
@@ -4532,7 +4284,7 @@
           <a:bodyPr wrap="square" lIns="0" tIns="0" rIns="0" bIns="0" rtlCol="0" anchor="ctr"/>
           <a:lstStyle/>
           <a:p>
-            <a:pPr algn="ctr" indent="0" marL="0">
+            <a:pPr marL="0" indent="0" algn="ctr">
               <a:buNone/>
             </a:pPr>
             <a:r>
@@ -4568,7 +4320,7 @@
           <a:bodyPr wrap="square" lIns="0" tIns="0" rIns="0" bIns="0" rtlCol="0" anchor="ctr"/>
           <a:lstStyle/>
           <a:p>
-            <a:pPr algn="ctr" indent="0" marL="0">
+            <a:pPr marL="0" indent="0" algn="ctr">
               <a:buNone/>
             </a:pPr>
             <a:r>
@@ -4609,6 +4361,13 @@
             <a:prstDash val="solid"/>
           </a:ln>
         </p:spPr>
+        <p:txBody>
+          <a:bodyPr/>
+          <a:lstStyle/>
+          <a:p>
+            <a:endParaRPr lang="es-GT"/>
+          </a:p>
+        </p:txBody>
       </p:sp>
       <p:sp>
         <p:nvSpPr>
@@ -4631,7 +4390,7 @@
           <a:bodyPr wrap="square" lIns="0" tIns="0" rIns="0" bIns="0" rtlCol="0" anchor="ctr"/>
           <a:lstStyle/>
           <a:p>
-            <a:pPr algn="ctr" indent="0" marL="0">
+            <a:pPr marL="0" indent="0" algn="ctr">
               <a:buNone/>
             </a:pPr>
             <a:r>
@@ -4667,7 +4426,7 @@
           <a:bodyPr wrap="square" lIns="0" tIns="0" rIns="0" bIns="0" rtlCol="0" anchor="ctr"/>
           <a:lstStyle/>
           <a:p>
-            <a:pPr algn="ctr" indent="0" marL="0">
+            <a:pPr marL="0" indent="0" algn="ctr">
               <a:buNone/>
             </a:pPr>
             <a:r>
@@ -4708,6 +4467,13 @@
             <a:prstDash val="solid"/>
           </a:ln>
         </p:spPr>
+        <p:txBody>
+          <a:bodyPr/>
+          <a:lstStyle/>
+          <a:p>
+            <a:endParaRPr lang="es-GT"/>
+          </a:p>
+        </p:txBody>
       </p:sp>
       <p:sp>
         <p:nvSpPr>
@@ -4730,7 +4496,7 @@
           <a:bodyPr wrap="square" lIns="0" tIns="0" rIns="0" bIns="0" rtlCol="0" anchor="ctr"/>
           <a:lstStyle/>
           <a:p>
-            <a:pPr algn="ctr" indent="0" marL="0">
+            <a:pPr marL="0" indent="0" algn="ctr">
               <a:buNone/>
             </a:pPr>
             <a:r>
@@ -4771,6 +4537,13 @@
             <a:prstDash val="solid"/>
           </a:ln>
         </p:spPr>
+        <p:txBody>
+          <a:bodyPr/>
+          <a:lstStyle/>
+          <a:p>
+            <a:endParaRPr lang="es-GT"/>
+          </a:p>
+        </p:txBody>
       </p:sp>
       <p:sp>
         <p:nvSpPr>
@@ -4793,7 +4566,7 @@
           <a:bodyPr wrap="square" lIns="0" tIns="0" rIns="0" bIns="0" rtlCol="0" anchor="ctr"/>
           <a:lstStyle/>
           <a:p>
-            <a:pPr indent="0" marL="0">
+            <a:pPr marL="0" indent="0">
               <a:buNone/>
             </a:pPr>
             <a:r>
@@ -4807,7 +4580,7 @@
             <a:endParaRPr lang="en-US" sz="1400" dirty="0"/>
           </a:p>
           <a:p>
-            <a:pPr indent="0" marL="0">
+            <a:pPr marL="0" indent="0">
               <a:buNone/>
             </a:pPr>
             <a:r>
@@ -4848,6 +4621,13 @@
             <a:prstDash val="solid"/>
           </a:ln>
         </p:spPr>
+        <p:txBody>
+          <a:bodyPr/>
+          <a:lstStyle/>
+          <a:p>
+            <a:endParaRPr lang="es-GT"/>
+          </a:p>
+        </p:txBody>
       </p:sp>
       <p:sp>
         <p:nvSpPr>
@@ -4870,7 +4650,7 @@
           <a:bodyPr wrap="square" lIns="0" tIns="0" rIns="0" bIns="0" rtlCol="0" anchor="ctr"/>
           <a:lstStyle/>
           <a:p>
-            <a:pPr indent="0" marL="0">
+            <a:pPr marL="0" indent="0">
               <a:buNone/>
             </a:pPr>
             <a:r>
@@ -4884,7 +4664,7 @@
             <a:endParaRPr lang="en-US" sz="1400" dirty="0"/>
           </a:p>
           <a:p>
-            <a:pPr indent="0" marL="0">
+            <a:pPr marL="0" indent="0">
               <a:buNone/>
             </a:pPr>
             <a:r>
@@ -4925,6 +4705,13 @@
             <a:prstDash val="solid"/>
           </a:ln>
         </p:spPr>
+        <p:txBody>
+          <a:bodyPr/>
+          <a:lstStyle/>
+          <a:p>
+            <a:endParaRPr lang="es-GT"/>
+          </a:p>
+        </p:txBody>
       </p:sp>
       <p:sp>
         <p:nvSpPr>
@@ -4947,7 +4734,7 @@
           <a:bodyPr wrap="square" lIns="0" tIns="0" rIns="0" bIns="0" rtlCol="0" anchor="ctr"/>
           <a:lstStyle/>
           <a:p>
-            <a:pPr indent="0" marL="0">
+            <a:pPr marL="0" indent="0">
               <a:buNone/>
             </a:pPr>
             <a:r>
@@ -4961,7 +4748,7 @@
             <a:endParaRPr lang="en-US" sz="1400" dirty="0"/>
           </a:p>
           <a:p>
-            <a:pPr indent="0" marL="0">
+            <a:pPr marL="0" indent="0">
               <a:buNone/>
             </a:pPr>
             <a:r>
@@ -5002,6 +4789,13 @@
             <a:prstDash val="solid"/>
           </a:ln>
         </p:spPr>
+        <p:txBody>
+          <a:bodyPr/>
+          <a:lstStyle/>
+          <a:p>
+            <a:endParaRPr lang="es-GT"/>
+          </a:p>
+        </p:txBody>
       </p:sp>
       <p:sp>
         <p:nvSpPr>
@@ -5024,7 +4818,7 @@
           <a:bodyPr wrap="square" lIns="0" tIns="0" rIns="0" bIns="0" rtlCol="0" anchor="ctr"/>
           <a:lstStyle/>
           <a:p>
-            <a:pPr indent="0" marL="0">
+            <a:pPr marL="0" indent="0">
               <a:buNone/>
             </a:pPr>
             <a:r>
@@ -5038,7 +4832,7 @@
             <a:endParaRPr lang="en-US" sz="1400" dirty="0"/>
           </a:p>
           <a:p>
-            <a:pPr indent="0" marL="0">
+            <a:pPr marL="0" indent="0">
               <a:buNone/>
             </a:pPr>
             <a:r>
@@ -5073,7 +4867,7 @@
           </a:prstGeom>
           <a:extLst>
             <a:ext uri="{C572A759-6A51-4108-AA02-DFA0A04FC94B}">
-              <ma14:wrappingTextBoxFlag xmlns:ma14="http://schemas.microsoft.com/office/mac/drawingml/2011/main" val="0"/>
+              <ma14:wrappingTextBoxFlag xmlns:ma14="http://schemas.microsoft.com/office/mac/drawingml/2011/main" xmlns="" val="0"/>
             </a:ext>
           </a:extLst>
         </p:spPr>
@@ -5091,7 +4885,7 @@
           <a:p>
             <a:pPr algn="r"/>
             <a:fld id="{F7021451-1387-4CA6-816F-3879F97B5CBC}" type="slidenum">
-              <a:rPr b="0" lang="en-US"/>
+              <a:rPr lang="en-US" b="0"/>
               <a:t>2</a:t>
             </a:fld>
             <a:endParaRPr lang="en-US"/>
@@ -5126,9 +4920,11 @@
       <p:sp>
         <p:nvSpPr>
           <p:cNvPr id="2" name="Text 0"/>
-          <p:cNvSpPr/>
+          <p:cNvSpPr>
+            <a:spLocks noGrp="1"/>
+          </p:cNvSpPr>
           <p:nvPr>
-            <p:ph idx="100" type="title" hasCustomPrompt="1"/>
+            <p:ph type="title" idx="100" hasCustomPrompt="1"/>
           </p:nvPr>
         </p:nvSpPr>
         <p:spPr>
@@ -5146,7 +4942,7 @@
           <a:bodyPr wrap="square" lIns="0" tIns="0" rIns="0" bIns="0" rtlCol="0" anchor="ctr"/>
           <a:lstStyle/>
           <a:p>
-            <a:pPr algn="l" indent="0" marL="0">
+            <a:pPr marL="0" indent="0" algn="l">
               <a:buNone/>
             </a:pPr>
             <a:r>
@@ -5158,42 +4954,6 @@
               <a:t>Datos y separación de esquemas</a:t>
             </a:r>
             <a:endParaRPr lang="en-US" sz="3400" dirty="0"/>
-          </a:p>
-        </p:txBody>
-      </p:sp>
-      <p:sp>
-        <p:nvSpPr>
-          <p:cNvPr id="3" name="Text 1"/>
-          <p:cNvSpPr txBox="1"/>
-          <p:nvPr/>
-        </p:nvSpPr>
-        <p:spPr>
-          <a:xfrm>
-            <a:off x="548640" y="4754880"/>
-            <a:ext cx="7498080" cy="274320"/>
-          </a:xfrm>
-          <a:prstGeom prst="rect">
-            <a:avLst/>
-          </a:prstGeom>
-          <a:noFill/>
-          <a:ln/>
-        </p:spPr>
-        <p:txBody>
-          <a:bodyPr wrap="square" lIns="0" tIns="0" rIns="0" bIns="0" rtlCol="0" anchor="ctr"/>
-          <a:lstStyle/>
-          <a:p>
-            <a:pPr indent="0" marL="0">
-              <a:buNone/>
-            </a:pPr>
-            <a:r>
-              <a:rPr lang="en-US" sz="1000" dirty="0">
-                <a:solidFill>
-                  <a:schemeClr val="accent3"/>
-                </a:solidFill>
-              </a:rPr>
-              <a:t>Fuente: datos/reporte_datos.json, datos/validacion/preguntas.jsonl</a:t>
-            </a:r>
-            <a:endParaRPr lang="en-US" sz="1000" dirty="0"/>
           </a:p>
         </p:txBody>
       </p:sp>
@@ -5223,6 +4983,13 @@
             <a:prstDash val="solid"/>
           </a:ln>
         </p:spPr>
+        <p:txBody>
+          <a:bodyPr/>
+          <a:lstStyle/>
+          <a:p>
+            <a:endParaRPr lang="es-GT"/>
+          </a:p>
+        </p:txBody>
       </p:sp>
       <p:sp>
         <p:nvSpPr>
@@ -5245,7 +5012,7 @@
           <a:bodyPr wrap="square" lIns="0" tIns="0" rIns="0" bIns="0" rtlCol="0" anchor="ctr"/>
           <a:lstStyle/>
           <a:p>
-            <a:pPr algn="l" indent="0" marL="0">
+            <a:pPr marL="0" indent="0" algn="l">
               <a:buNone/>
             </a:pPr>
             <a:r>
@@ -5284,7 +5051,7 @@
           <a:bodyPr wrap="square" lIns="0" tIns="0" rIns="0" bIns="0" rtlCol="0" anchor="t"/>
           <a:lstStyle/>
           <a:p>
-            <a:pPr algn="l" indent="0" marL="0">
+            <a:pPr marL="0" indent="0" algn="l">
               <a:buNone/>
             </a:pPr>
             <a:r>
@@ -5325,6 +5092,13 @@
             <a:prstDash val="solid"/>
           </a:ln>
         </p:spPr>
+        <p:txBody>
+          <a:bodyPr/>
+          <a:lstStyle/>
+          <a:p>
+            <a:endParaRPr lang="es-GT"/>
+          </a:p>
+        </p:txBody>
       </p:sp>
       <p:sp>
         <p:nvSpPr>
@@ -5347,7 +5121,7 @@
           <a:bodyPr wrap="square" lIns="0" tIns="0" rIns="0" bIns="0" rtlCol="0" anchor="ctr"/>
           <a:lstStyle/>
           <a:p>
-            <a:pPr algn="l" indent="0" marL="0">
+            <a:pPr marL="0" indent="0" algn="l">
               <a:buNone/>
             </a:pPr>
             <a:r>
@@ -5386,7 +5160,7 @@
           <a:bodyPr wrap="square" lIns="0" tIns="0" rIns="0" bIns="0" rtlCol="0" anchor="t"/>
           <a:lstStyle/>
           <a:p>
-            <a:pPr algn="l" indent="0" marL="0">
+            <a:pPr marL="0" indent="0" algn="l">
               <a:buNone/>
             </a:pPr>
             <a:r>
@@ -5427,6 +5201,13 @@
             <a:prstDash val="solid"/>
           </a:ln>
         </p:spPr>
+        <p:txBody>
+          <a:bodyPr/>
+          <a:lstStyle/>
+          <a:p>
+            <a:endParaRPr lang="es-GT"/>
+          </a:p>
+        </p:txBody>
       </p:sp>
       <p:sp>
         <p:nvSpPr>
@@ -5449,7 +5230,7 @@
           <a:bodyPr wrap="square" lIns="0" tIns="0" rIns="0" bIns="0" rtlCol="0" anchor="ctr"/>
           <a:lstStyle/>
           <a:p>
-            <a:pPr algn="l" indent="0" marL="0">
+            <a:pPr marL="0" indent="0" algn="l">
               <a:buNone/>
             </a:pPr>
             <a:r>
@@ -5488,7 +5269,7 @@
           <a:bodyPr wrap="square" lIns="0" tIns="0" rIns="0" bIns="0" rtlCol="0" anchor="t"/>
           <a:lstStyle/>
           <a:p>
-            <a:pPr algn="l" indent="0" marL="0">
+            <a:pPr marL="0" indent="0" algn="l">
               <a:buNone/>
             </a:pPr>
             <a:r>
@@ -5505,7 +5286,7 @@
       </p:sp>
       <p:graphicFrame>
         <p:nvGraphicFramePr>
-          <p:cNvPr id="4" name="Tabla de niveles"/>
+          <p:cNvPr id="13" name="Tabla de niveles"/>
           <p:cNvGraphicFramePr>
             <a:graphicFrameLocks noGrp="1"/>
           </p:cNvGraphicFramePr>
@@ -5519,16 +5300,34 @@
         </p:nvGraphicFramePr>
         <p:xfrm>
           <a:off x="548640" y="2651760"/>
-          <a:ext cx="4023360" cy="914400"/>
+          <a:ext cx="4023360" cy="1645920"/>
         </p:xfrm>
         <a:graphic>
           <a:graphicData uri="http://schemas.openxmlformats.org/drawingml/2006/table">
             <a:tbl>
               <a:tblPr/>
               <a:tblGrid>
-                <a:gridCol w="1463040"/>
-                <a:gridCol w="1371600"/>
-                <a:gridCol w="1188720"/>
+                <a:gridCol w="1463040">
+                  <a:extLst>
+                    <a:ext uri="{9D8B030D-6E8A-4147-A177-3AD203B41FA5}">
+                      <a16:colId xmlns:a16="http://schemas.microsoft.com/office/drawing/2014/main" val="20000"/>
+                    </a:ext>
+                  </a:extLst>
+                </a:gridCol>
+                <a:gridCol w="1371600">
+                  <a:extLst>
+                    <a:ext uri="{9D8B030D-6E8A-4147-A177-3AD203B41FA5}">
+                      <a16:colId xmlns:a16="http://schemas.microsoft.com/office/drawing/2014/main" val="20001"/>
+                    </a:ext>
+                  </a:extLst>
+                </a:gridCol>
+                <a:gridCol w="1188720">
+                  <a:extLst>
+                    <a:ext uri="{9D8B030D-6E8A-4147-A177-3AD203B41FA5}">
+                      <a16:colId xmlns:a16="http://schemas.microsoft.com/office/drawing/2014/main" val="20002"/>
+                    </a:ext>
+                  </a:extLst>
+                </a:gridCol>
               </a:tblGrid>
               <a:tr h="411480">
                 <a:tc>
@@ -5536,7 +5335,7 @@
                     <a:bodyPr/>
                     <a:lstStyle/>
                     <a:p>
-                      <a:pPr algn="l" indent="0" marL="0">
+                      <a:pPr marL="0" indent="0" algn="l">
                         <a:buNone/>
                       </a:pPr>
                       <a:r>
@@ -5550,7 +5349,7 @@
                       <a:endParaRPr lang="en-US" sz="1400" dirty="0"/>
                     </a:p>
                   </a:txBody>
-                  <a:tcPr marL="91440" marR="91440" marT="0" marB="0" anchor="ctr">
+                  <a:tcPr marT="0" marB="0" anchor="ctr">
                     <a:lnL w="0" cap="flat" cmpd="sng" algn="ctr">
                       <a:noFill/>
                     </a:lnL>
@@ -5579,7 +5378,7 @@
                     <a:bodyPr/>
                     <a:lstStyle/>
                     <a:p>
-                      <a:pPr algn="ctr" indent="0" marL="0">
+                      <a:pPr marL="0" indent="0" algn="ctr">
                         <a:buNone/>
                       </a:pPr>
                       <a:r>
@@ -5593,7 +5392,7 @@
                       <a:endParaRPr lang="en-US" sz="1400" dirty="0"/>
                     </a:p>
                   </a:txBody>
-                  <a:tcPr marL="91440" marR="91440" marT="0" marB="0" anchor="ctr">
+                  <a:tcPr marT="0" marB="0" anchor="ctr">
                     <a:lnL w="0" cap="flat" cmpd="sng" algn="ctr">
                       <a:noFill/>
                     </a:lnL>
@@ -5622,7 +5421,7 @@
                     <a:bodyPr/>
                     <a:lstStyle/>
                     <a:p>
-                      <a:pPr algn="ctr" indent="0" marL="0">
+                      <a:pPr marL="0" indent="0" algn="ctr">
                         <a:buNone/>
                       </a:pPr>
                       <a:r>
@@ -5636,7 +5435,7 @@
                       <a:endParaRPr lang="en-US" sz="1400" dirty="0"/>
                     </a:p>
                   </a:txBody>
-                  <a:tcPr marL="91440" marR="91440" marT="0" marB="0" anchor="ctr">
+                  <a:tcPr marT="0" marB="0" anchor="ctr">
                     <a:lnL w="0" cap="flat" cmpd="sng" algn="ctr">
                       <a:noFill/>
                     </a:lnL>
@@ -5660,6 +5459,11 @@
                     </a:solidFill>
                   </a:tcPr>
                 </a:tc>
+                <a:extLst>
+                  <a:ext uri="{0D108BD9-81ED-4DB2-BD59-A6C34878D82A}">
+                    <a16:rowId xmlns:a16="http://schemas.microsoft.com/office/drawing/2014/main" val="10000"/>
+                  </a:ext>
+                </a:extLst>
               </a:tr>
               <a:tr h="411480">
                 <a:tc>
@@ -5667,7 +5471,7 @@
                     <a:bodyPr/>
                     <a:lstStyle/>
                     <a:p>
-                      <a:pPr algn="l" indent="0" marL="0">
+                      <a:pPr marL="0" indent="0" algn="l">
                         <a:buNone/>
                       </a:pPr>
                       <a:r>
@@ -5681,15 +5485,21 @@
                       <a:endParaRPr lang="en-US" sz="1400" dirty="0"/>
                     </a:p>
                   </a:txBody>
-                  <a:tcPr marL="91440" marR="91440" marT="0" marB="0" anchor="ctr">
+                  <a:tcPr marT="0" marB="0" anchor="ctr">
                     <a:lnL w="0" cap="flat" cmpd="sng" algn="ctr">
                       <a:noFill/>
                     </a:lnL>
                     <a:lnR w="0" cap="flat" cmpd="sng" algn="ctr">
                       <a:noFill/>
                     </a:lnR>
-                    <a:lnT w="0" cap="flat" cmpd="sng" algn="ctr">
-                      <a:noFill/>
+                    <a:lnT w="19050" cap="flat" cmpd="sng" algn="ctr">
+                      <a:solidFill>
+                        <a:srgbClr val="007F92"/>
+                      </a:solidFill>
+                      <a:prstDash val="solid"/>
+                      <a:round/>
+                      <a:headEnd type="none" w="med" len="med"/>
+                      <a:tailEnd type="none" w="med" len="med"/>
                     </a:lnT>
                     <a:lnB w="6350" cap="flat" cmpd="sng" algn="ctr">
                       <a:solidFill>
@@ -5710,7 +5520,7 @@
                     <a:bodyPr/>
                     <a:lstStyle/>
                     <a:p>
-                      <a:pPr algn="ctr" indent="0" marL="0">
+                      <a:pPr marL="0" indent="0" algn="ctr">
                         <a:buNone/>
                       </a:pPr>
                       <a:r>
@@ -5724,15 +5534,21 @@
                       <a:endParaRPr lang="en-US" sz="1400" dirty="0"/>
                     </a:p>
                   </a:txBody>
-                  <a:tcPr marL="91440" marR="91440" marT="0" marB="0" anchor="ctr">
+                  <a:tcPr marT="0" marB="0" anchor="ctr">
                     <a:lnL w="0" cap="flat" cmpd="sng" algn="ctr">
                       <a:noFill/>
                     </a:lnL>
                     <a:lnR w="0" cap="flat" cmpd="sng" algn="ctr">
                       <a:noFill/>
                     </a:lnR>
-                    <a:lnT w="0" cap="flat" cmpd="sng" algn="ctr">
-                      <a:noFill/>
+                    <a:lnT w="19050" cap="flat" cmpd="sng" algn="ctr">
+                      <a:solidFill>
+                        <a:srgbClr val="007F92"/>
+                      </a:solidFill>
+                      <a:prstDash val="solid"/>
+                      <a:round/>
+                      <a:headEnd type="none" w="med" len="med"/>
+                      <a:tailEnd type="none" w="med" len="med"/>
                     </a:lnT>
                     <a:lnB w="6350" cap="flat" cmpd="sng" algn="ctr">
                       <a:solidFill>
@@ -5753,7 +5569,7 @@
                     <a:bodyPr/>
                     <a:lstStyle/>
                     <a:p>
-                      <a:pPr algn="ctr" indent="0" marL="0">
+                      <a:pPr marL="0" indent="0" algn="ctr">
                         <a:buNone/>
                       </a:pPr>
                       <a:r>
@@ -5767,15 +5583,21 @@
                       <a:endParaRPr lang="en-US" sz="1400" dirty="0"/>
                     </a:p>
                   </a:txBody>
-                  <a:tcPr marL="91440" marR="91440" marT="0" marB="0" anchor="ctr">
+                  <a:tcPr marT="0" marB="0" anchor="ctr">
                     <a:lnL w="0" cap="flat" cmpd="sng" algn="ctr">
                       <a:noFill/>
                     </a:lnL>
                     <a:lnR w="0" cap="flat" cmpd="sng" algn="ctr">
                       <a:noFill/>
                     </a:lnR>
-                    <a:lnT w="0" cap="flat" cmpd="sng" algn="ctr">
-                      <a:noFill/>
+                    <a:lnT w="19050" cap="flat" cmpd="sng" algn="ctr">
+                      <a:solidFill>
+                        <a:srgbClr val="007F92"/>
+                      </a:solidFill>
+                      <a:prstDash val="solid"/>
+                      <a:round/>
+                      <a:headEnd type="none" w="med" len="med"/>
+                      <a:tailEnd type="none" w="med" len="med"/>
                     </a:lnT>
                     <a:lnB w="6350" cap="flat" cmpd="sng" algn="ctr">
                       <a:solidFill>
@@ -5791,6 +5613,11 @@
                     </a:solidFill>
                   </a:tcPr>
                 </a:tc>
+                <a:extLst>
+                  <a:ext uri="{0D108BD9-81ED-4DB2-BD59-A6C34878D82A}">
+                    <a16:rowId xmlns:a16="http://schemas.microsoft.com/office/drawing/2014/main" val="10001"/>
+                  </a:ext>
+                </a:extLst>
               </a:tr>
               <a:tr h="411480">
                 <a:tc>
@@ -5798,7 +5625,7 @@
                     <a:bodyPr/>
                     <a:lstStyle/>
                     <a:p>
-                      <a:pPr algn="l" indent="0" marL="0">
+                      <a:pPr marL="0" indent="0" algn="l">
                         <a:buNone/>
                       </a:pPr>
                       <a:r>
@@ -5812,15 +5639,21 @@
                       <a:endParaRPr lang="en-US" sz="1400" dirty="0"/>
                     </a:p>
                   </a:txBody>
-                  <a:tcPr marL="91440" marR="91440" marT="0" marB="0" anchor="ctr">
+                  <a:tcPr marT="0" marB="0" anchor="ctr">
                     <a:lnL w="0" cap="flat" cmpd="sng" algn="ctr">
                       <a:noFill/>
                     </a:lnL>
                     <a:lnR w="0" cap="flat" cmpd="sng" algn="ctr">
                       <a:noFill/>
                     </a:lnR>
-                    <a:lnT w="0" cap="flat" cmpd="sng" algn="ctr">
-                      <a:noFill/>
+                    <a:lnT w="6350" cap="flat" cmpd="sng" algn="ctr">
+                      <a:solidFill>
+                        <a:srgbClr val="C9D6DB"/>
+                      </a:solidFill>
+                      <a:prstDash val="solid"/>
+                      <a:round/>
+                      <a:headEnd type="none" w="med" len="med"/>
+                      <a:tailEnd type="none" w="med" len="med"/>
                     </a:lnT>
                     <a:lnB w="6350" cap="flat" cmpd="sng" algn="ctr">
                       <a:solidFill>
@@ -5841,7 +5674,7 @@
                     <a:bodyPr/>
                     <a:lstStyle/>
                     <a:p>
-                      <a:pPr algn="ctr" indent="0" marL="0">
+                      <a:pPr marL="0" indent="0" algn="ctr">
                         <a:buNone/>
                       </a:pPr>
                       <a:r>
@@ -5855,15 +5688,21 @@
                       <a:endParaRPr lang="en-US" sz="1400" dirty="0"/>
                     </a:p>
                   </a:txBody>
-                  <a:tcPr marL="91440" marR="91440" marT="0" marB="0" anchor="ctr">
+                  <a:tcPr marT="0" marB="0" anchor="ctr">
                     <a:lnL w="0" cap="flat" cmpd="sng" algn="ctr">
                       <a:noFill/>
                     </a:lnL>
                     <a:lnR w="0" cap="flat" cmpd="sng" algn="ctr">
                       <a:noFill/>
                     </a:lnR>
-                    <a:lnT w="0" cap="flat" cmpd="sng" algn="ctr">
-                      <a:noFill/>
+                    <a:lnT w="6350" cap="flat" cmpd="sng" algn="ctr">
+                      <a:solidFill>
+                        <a:srgbClr val="C9D6DB"/>
+                      </a:solidFill>
+                      <a:prstDash val="solid"/>
+                      <a:round/>
+                      <a:headEnd type="none" w="med" len="med"/>
+                      <a:tailEnd type="none" w="med" len="med"/>
                     </a:lnT>
                     <a:lnB w="6350" cap="flat" cmpd="sng" algn="ctr">
                       <a:solidFill>
@@ -5884,7 +5723,7 @@
                     <a:bodyPr/>
                     <a:lstStyle/>
                     <a:p>
-                      <a:pPr algn="ctr" indent="0" marL="0">
+                      <a:pPr marL="0" indent="0" algn="ctr">
                         <a:buNone/>
                       </a:pPr>
                       <a:r>
@@ -5898,15 +5737,21 @@
                       <a:endParaRPr lang="en-US" sz="1400" dirty="0"/>
                     </a:p>
                   </a:txBody>
-                  <a:tcPr marL="91440" marR="91440" marT="0" marB="0" anchor="ctr">
+                  <a:tcPr marT="0" marB="0" anchor="ctr">
                     <a:lnL w="0" cap="flat" cmpd="sng" algn="ctr">
                       <a:noFill/>
                     </a:lnL>
                     <a:lnR w="0" cap="flat" cmpd="sng" algn="ctr">
                       <a:noFill/>
                     </a:lnR>
-                    <a:lnT w="0" cap="flat" cmpd="sng" algn="ctr">
-                      <a:noFill/>
+                    <a:lnT w="6350" cap="flat" cmpd="sng" algn="ctr">
+                      <a:solidFill>
+                        <a:srgbClr val="C9D6DB"/>
+                      </a:solidFill>
+                      <a:prstDash val="solid"/>
+                      <a:round/>
+                      <a:headEnd type="none" w="med" len="med"/>
+                      <a:tailEnd type="none" w="med" len="med"/>
                     </a:lnT>
                     <a:lnB w="6350" cap="flat" cmpd="sng" algn="ctr">
                       <a:solidFill>
@@ -5922,6 +5767,11 @@
                     </a:solidFill>
                   </a:tcPr>
                 </a:tc>
+                <a:extLst>
+                  <a:ext uri="{0D108BD9-81ED-4DB2-BD59-A6C34878D82A}">
+                    <a16:rowId xmlns:a16="http://schemas.microsoft.com/office/drawing/2014/main" val="10002"/>
+                  </a:ext>
+                </a:extLst>
               </a:tr>
               <a:tr h="411480">
                 <a:tc>
@@ -5929,7 +5779,7 @@
                     <a:bodyPr/>
                     <a:lstStyle/>
                     <a:p>
-                      <a:pPr algn="l" indent="0" marL="0">
+                      <a:pPr marL="0" indent="0" algn="l">
                         <a:buNone/>
                       </a:pPr>
                       <a:r>
@@ -5943,15 +5793,21 @@
                       <a:endParaRPr lang="en-US" sz="1400" dirty="0"/>
                     </a:p>
                   </a:txBody>
-                  <a:tcPr marL="91440" marR="91440" marT="0" marB="0" anchor="ctr">
+                  <a:tcPr marT="0" marB="0" anchor="ctr">
                     <a:lnL w="0" cap="flat" cmpd="sng" algn="ctr">
                       <a:noFill/>
                     </a:lnL>
                     <a:lnR w="0" cap="flat" cmpd="sng" algn="ctr">
                       <a:noFill/>
                     </a:lnR>
-                    <a:lnT w="0" cap="flat" cmpd="sng" algn="ctr">
-                      <a:noFill/>
+                    <a:lnT w="6350" cap="flat" cmpd="sng" algn="ctr">
+                      <a:solidFill>
+                        <a:srgbClr val="C9D6DB"/>
+                      </a:solidFill>
+                      <a:prstDash val="solid"/>
+                      <a:round/>
+                      <a:headEnd type="none" w="med" len="med"/>
+                      <a:tailEnd type="none" w="med" len="med"/>
                     </a:lnT>
                     <a:lnB w="6350" cap="flat" cmpd="sng" algn="ctr">
                       <a:solidFill>
@@ -5972,7 +5828,7 @@
                     <a:bodyPr/>
                     <a:lstStyle/>
                     <a:p>
-                      <a:pPr algn="ctr" indent="0" marL="0">
+                      <a:pPr marL="0" indent="0" algn="ctr">
                         <a:buNone/>
                       </a:pPr>
                       <a:r>
@@ -5986,15 +5842,21 @@
                       <a:endParaRPr lang="en-US" sz="1400" dirty="0"/>
                     </a:p>
                   </a:txBody>
-                  <a:tcPr marL="91440" marR="91440" marT="0" marB="0" anchor="ctr">
+                  <a:tcPr marT="0" marB="0" anchor="ctr">
                     <a:lnL w="0" cap="flat" cmpd="sng" algn="ctr">
                       <a:noFill/>
                     </a:lnL>
                     <a:lnR w="0" cap="flat" cmpd="sng" algn="ctr">
                       <a:noFill/>
                     </a:lnR>
-                    <a:lnT w="0" cap="flat" cmpd="sng" algn="ctr">
-                      <a:noFill/>
+                    <a:lnT w="6350" cap="flat" cmpd="sng" algn="ctr">
+                      <a:solidFill>
+                        <a:srgbClr val="C9D6DB"/>
+                      </a:solidFill>
+                      <a:prstDash val="solid"/>
+                      <a:round/>
+                      <a:headEnd type="none" w="med" len="med"/>
+                      <a:tailEnd type="none" w="med" len="med"/>
                     </a:lnT>
                     <a:lnB w="6350" cap="flat" cmpd="sng" algn="ctr">
                       <a:solidFill>
@@ -6015,7 +5877,7 @@
                     <a:bodyPr/>
                     <a:lstStyle/>
                     <a:p>
-                      <a:pPr algn="ctr" indent="0" marL="0">
+                      <a:pPr marL="0" indent="0" algn="ctr">
                         <a:buNone/>
                       </a:pPr>
                       <a:r>
@@ -6029,15 +5891,21 @@
                       <a:endParaRPr lang="en-US" sz="1400" dirty="0"/>
                     </a:p>
                   </a:txBody>
-                  <a:tcPr marL="91440" marR="91440" marT="0" marB="0" anchor="ctr">
+                  <a:tcPr marT="0" marB="0" anchor="ctr">
                     <a:lnL w="0" cap="flat" cmpd="sng" algn="ctr">
                       <a:noFill/>
                     </a:lnL>
                     <a:lnR w="0" cap="flat" cmpd="sng" algn="ctr">
                       <a:noFill/>
                     </a:lnR>
-                    <a:lnT w="0" cap="flat" cmpd="sng" algn="ctr">
-                      <a:noFill/>
+                    <a:lnT w="6350" cap="flat" cmpd="sng" algn="ctr">
+                      <a:solidFill>
+                        <a:srgbClr val="C9D6DB"/>
+                      </a:solidFill>
+                      <a:prstDash val="solid"/>
+                      <a:round/>
+                      <a:headEnd type="none" w="med" len="med"/>
+                      <a:tailEnd type="none" w="med" len="med"/>
                     </a:lnT>
                     <a:lnB w="6350" cap="flat" cmpd="sng" algn="ctr">
                       <a:solidFill>
@@ -6053,6 +5921,11 @@
                     </a:solidFill>
                   </a:tcPr>
                 </a:tc>
+                <a:extLst>
+                  <a:ext uri="{0D108BD9-81ED-4DB2-BD59-A6C34878D82A}">
+                    <a16:rowId xmlns:a16="http://schemas.microsoft.com/office/drawing/2014/main" val="10003"/>
+                  </a:ext>
+                </a:extLst>
               </a:tr>
             </a:tbl>
           </a:graphicData>
@@ -6154,7 +6027,7 @@
           </a:prstGeom>
           <a:extLst>
             <a:ext uri="{C572A759-6A51-4108-AA02-DFA0A04FC94B}">
-              <ma14:wrappingTextBoxFlag xmlns:ma14="http://schemas.microsoft.com/office/mac/drawingml/2011/main" val="0"/>
+              <ma14:wrappingTextBoxFlag xmlns:ma14="http://schemas.microsoft.com/office/mac/drawingml/2011/main" xmlns="" val="0"/>
             </a:ext>
           </a:extLst>
         </p:spPr>
@@ -6172,7 +6045,7 @@
           <a:p>
             <a:pPr algn="r"/>
             <a:fld id="{F7021451-1387-4CA6-816F-3879F97B5CBC}" type="slidenum">
-              <a:rPr b="0" lang="en-US"/>
+              <a:rPr lang="en-US" b="0"/>
               <a:t>3</a:t>
             </a:fld>
             <a:endParaRPr lang="en-US"/>
@@ -6207,9 +6080,11 @@
       <p:sp>
         <p:nvSpPr>
           <p:cNvPr id="2" name="Text 0"/>
-          <p:cNvSpPr/>
+          <p:cNvSpPr>
+            <a:spLocks noGrp="1"/>
+          </p:cNvSpPr>
           <p:nvPr>
-            <p:ph idx="100" type="title" hasCustomPrompt="1"/>
+            <p:ph type="title" idx="100" hasCustomPrompt="1"/>
           </p:nvPr>
         </p:nvSpPr>
         <p:spPr>
@@ -6227,7 +6102,7 @@
           <a:bodyPr wrap="square" lIns="0" tIns="0" rIns="0" bIns="0" rtlCol="0" anchor="ctr"/>
           <a:lstStyle/>
           <a:p>
-            <a:pPr algn="l" indent="0" marL="0">
+            <a:pPr marL="0" indent="0" algn="l">
               <a:buNone/>
             </a:pPr>
             <a:r>
@@ -6239,42 +6114,6 @@
               <a:t>Cómo se mide la exactitud</a:t>
             </a:r>
             <a:endParaRPr lang="en-US" sz="3400" dirty="0"/>
-          </a:p>
-        </p:txBody>
-      </p:sp>
-      <p:sp>
-        <p:nvSpPr>
-          <p:cNvPr id="3" name="Text 1"/>
-          <p:cNvSpPr txBox="1"/>
-          <p:nvPr/>
-        </p:nvSpPr>
-        <p:spPr>
-          <a:xfrm>
-            <a:off x="548640" y="4754880"/>
-            <a:ext cx="7498080" cy="274320"/>
-          </a:xfrm>
-          <a:prstGeom prst="rect">
-            <a:avLst/>
-          </a:prstGeom>
-          <a:noFill/>
-          <a:ln/>
-        </p:spPr>
-        <p:txBody>
-          <a:bodyPr wrap="square" lIns="0" tIns="0" rIns="0" bIns="0" rtlCol="0" anchor="ctr"/>
-          <a:lstStyle/>
-          <a:p>
-            <a:pPr indent="0" marL="0">
-              <a:buNone/>
-            </a:pPr>
-            <a:r>
-              <a:rPr lang="en-US" sz="1000" dirty="0">
-                <a:solidFill>
-                  <a:schemeClr val="accent3"/>
-                </a:solidFill>
-              </a:rPr>
-              <a:t>Fuente: evaluador.py, resultados/oraculo.json</a:t>
-            </a:r>
-            <a:endParaRPr lang="en-US" sz="1000" dirty="0"/>
           </a:p>
         </p:txBody>
       </p:sp>
@@ -6304,6 +6143,13 @@
             <a:prstDash val="solid"/>
           </a:ln>
         </p:spPr>
+        <p:txBody>
+          <a:bodyPr/>
+          <a:lstStyle/>
+          <a:p>
+            <a:endParaRPr lang="es-GT"/>
+          </a:p>
+        </p:txBody>
       </p:sp>
       <p:sp>
         <p:nvSpPr>
@@ -6326,7 +6172,7 @@
           <a:bodyPr wrap="square" lIns="0" tIns="0" rIns="0" bIns="0" rtlCol="0" anchor="ctr"/>
           <a:lstStyle/>
           <a:p>
-            <a:pPr indent="0" marL="0">
+            <a:pPr marL="0" indent="0">
               <a:buNone/>
             </a:pPr>
             <a:r>
@@ -6340,9 +6186,6 @@
               </a:rPr>
               <a:t>EX = </a:t>
             </a:r>
-            <a:pPr indent="0" marL="0">
-              <a:buNone/>
-            </a:pPr>
             <a:r>
               <a:rPr lang="en-US" sz="1700" b="1" dirty="0">
                 <a:solidFill>
@@ -6478,6 +6321,13 @@
             <a:prstDash val="solid"/>
           </a:ln>
         </p:spPr>
+        <p:txBody>
+          <a:bodyPr/>
+          <a:lstStyle/>
+          <a:p>
+            <a:endParaRPr lang="es-GT"/>
+          </a:p>
+        </p:txBody>
       </p:sp>
       <p:sp>
         <p:nvSpPr>
@@ -6500,7 +6350,7 @@
           <a:bodyPr wrap="square" lIns="0" tIns="0" rIns="0" bIns="0" rtlCol="0" anchor="ctr"/>
           <a:lstStyle/>
           <a:p>
-            <a:pPr algn="ctr" indent="0" marL="0">
+            <a:pPr marL="0" indent="0" algn="ctr">
               <a:buNone/>
             </a:pPr>
             <a:r>
@@ -6539,7 +6389,7 @@
           <a:bodyPr wrap="square" lIns="0" tIns="0" rIns="0" bIns="0" rtlCol="0" anchor="ctr"/>
           <a:lstStyle/>
           <a:p>
-            <a:pPr algn="ctr" indent="0" marL="0">
+            <a:pPr marL="0" indent="0" algn="ctr">
               <a:buNone/>
             </a:pPr>
             <a:r>
@@ -6575,7 +6425,7 @@
           <a:bodyPr wrap="square" lIns="0" tIns="0" rIns="0" bIns="0" rtlCol="0" anchor="t"/>
           <a:lstStyle/>
           <a:p>
-            <a:pPr algn="ctr" indent="0" marL="0">
+            <a:pPr marL="0" indent="0" algn="ctr">
               <a:buNone/>
             </a:pPr>
             <a:r>
@@ -6610,7 +6460,7 @@
           </a:prstGeom>
           <a:extLst>
             <a:ext uri="{C572A759-6A51-4108-AA02-DFA0A04FC94B}">
-              <ma14:wrappingTextBoxFlag xmlns:ma14="http://schemas.microsoft.com/office/mac/drawingml/2011/main" val="0"/>
+              <ma14:wrappingTextBoxFlag xmlns:ma14="http://schemas.microsoft.com/office/mac/drawingml/2011/main" xmlns="" val="0"/>
             </a:ext>
           </a:extLst>
         </p:spPr>
@@ -6628,7 +6478,7 @@
           <a:p>
             <a:pPr algn="r"/>
             <a:fld id="{F7021451-1387-4CA6-816F-3879F97B5CBC}" type="slidenum">
-              <a:rPr b="0" lang="en-US"/>
+              <a:rPr lang="en-US" b="0"/>
               <a:t>4</a:t>
             </a:fld>
             <a:endParaRPr lang="en-US"/>
@@ -6663,9 +6513,11 @@
       <p:sp>
         <p:nvSpPr>
           <p:cNvPr id="2" name="Text 0"/>
-          <p:cNvSpPr/>
+          <p:cNvSpPr>
+            <a:spLocks noGrp="1"/>
+          </p:cNvSpPr>
           <p:nvPr>
-            <p:ph idx="100" type="title" hasCustomPrompt="1"/>
+            <p:ph type="title" idx="100" hasCustomPrompt="1"/>
           </p:nvPr>
         </p:nvSpPr>
         <p:spPr>
@@ -6683,7 +6535,7 @@
           <a:bodyPr wrap="square" lIns="0" tIns="0" rIns="0" bIns="0" rtlCol="0" anchor="ctr"/>
           <a:lstStyle/>
           <a:p>
-            <a:pPr algn="l" indent="0" marL="0">
+            <a:pPr marL="0" indent="0" algn="l">
               <a:buNone/>
             </a:pPr>
             <a:r>
@@ -6695,42 +6547,6 @@
               <a:t>Diseño experimental</a:t>
             </a:r>
             <a:endParaRPr lang="en-US" sz="3400" dirty="0"/>
-          </a:p>
-        </p:txBody>
-      </p:sp>
-      <p:sp>
-        <p:nvSpPr>
-          <p:cNvPr id="3" name="Text 1"/>
-          <p:cNvSpPr txBox="1"/>
-          <p:nvPr/>
-        </p:nvSpPr>
-        <p:spPr>
-          <a:xfrm>
-            <a:off x="548640" y="4754880"/>
-            <a:ext cx="7498080" cy="274320"/>
-          </a:xfrm>
-          <a:prstGeom prst="rect">
-            <a:avLst/>
-          </a:prstGeom>
-          <a:noFill/>
-          <a:ln/>
-        </p:spPr>
-        <p:txBody>
-          <a:bodyPr wrap="square" lIns="0" tIns="0" rIns="0" bIns="0" rtlCol="0" anchor="ctr"/>
-          <a:lstStyle/>
-          <a:p>
-            <a:pPr indent="0" marL="0">
-              <a:buNone/>
-            </a:pPr>
-            <a:r>
-              <a:rPr lang="en-US" sz="1000" dirty="0">
-                <a:solidFill>
-                  <a:schemeClr val="accent3"/>
-                </a:solidFill>
-              </a:rPr>
-              <a:t>Fuente: experimentos.md, configuraciones/, resultados/lora_r8/resumen.json, resultados/lora_r16/resumen.json</a:t>
-            </a:r>
-            <a:endParaRPr lang="en-US" sz="1000" dirty="0"/>
           </a:p>
         </p:txBody>
       </p:sp>
@@ -6750,16 +6566,34 @@
         </p:nvGraphicFramePr>
         <p:xfrm>
           <a:off x="548640" y="1188720"/>
-          <a:ext cx="4846320" cy="914400"/>
+          <a:ext cx="4846320" cy="2011680"/>
         </p:xfrm>
         <a:graphic>
           <a:graphicData uri="http://schemas.openxmlformats.org/drawingml/2006/table">
             <a:tbl>
               <a:tblPr/>
               <a:tblGrid>
-                <a:gridCol w="2103120"/>
-                <a:gridCol w="1371600"/>
-                <a:gridCol w="1371600"/>
+                <a:gridCol w="2103120">
+                  <a:extLst>
+                    <a:ext uri="{9D8B030D-6E8A-4147-A177-3AD203B41FA5}">
+                      <a16:colId xmlns:a16="http://schemas.microsoft.com/office/drawing/2014/main" val="20000"/>
+                    </a:ext>
+                  </a:extLst>
+                </a:gridCol>
+                <a:gridCol w="1371600">
+                  <a:extLst>
+                    <a:ext uri="{9D8B030D-6E8A-4147-A177-3AD203B41FA5}">
+                      <a16:colId xmlns:a16="http://schemas.microsoft.com/office/drawing/2014/main" val="20001"/>
+                    </a:ext>
+                  </a:extLst>
+                </a:gridCol>
+                <a:gridCol w="1371600">
+                  <a:extLst>
+                    <a:ext uri="{9D8B030D-6E8A-4147-A177-3AD203B41FA5}">
+                      <a16:colId xmlns:a16="http://schemas.microsoft.com/office/drawing/2014/main" val="20002"/>
+                    </a:ext>
+                  </a:extLst>
+                </a:gridCol>
               </a:tblGrid>
               <a:tr h="502920">
                 <a:tc>
@@ -6767,13 +6601,13 @@
                     <a:bodyPr/>
                     <a:lstStyle/>
                     <a:p>
-                      <a:pPr algn="l" indent="0" marL="0">
+                      <a:pPr marL="0" indent="0" algn="l">
                         <a:buNone/>
                       </a:pPr>
                       <a:endParaRPr lang="en-US" sz="1400" dirty="0"/>
                     </a:p>
                   </a:txBody>
-                  <a:tcPr marL="91440" marR="91440" marT="0" marB="0" anchor="ctr">
+                  <a:tcPr marT="0" marB="0" anchor="ctr">
                     <a:lnL w="0" cap="flat" cmpd="sng" algn="ctr">
                       <a:noFill/>
                     </a:lnL>
@@ -6802,7 +6636,7 @@
                     <a:bodyPr/>
                     <a:lstStyle/>
                     <a:p>
-                      <a:pPr algn="ctr" indent="0" marL="0">
+                      <a:pPr marL="0" indent="0" algn="ctr">
                         <a:buNone/>
                       </a:pPr>
                       <a:r>
@@ -6816,7 +6650,7 @@
                       <a:endParaRPr lang="en-US" sz="1400" dirty="0"/>
                     </a:p>
                   </a:txBody>
-                  <a:tcPr marL="91440" marR="91440" marT="0" marB="0" anchor="ctr">
+                  <a:tcPr marT="0" marB="0" anchor="ctr">
                     <a:lnL w="0" cap="flat" cmpd="sng" algn="ctr">
                       <a:noFill/>
                     </a:lnL>
@@ -6845,7 +6679,7 @@
                     <a:bodyPr/>
                     <a:lstStyle/>
                     <a:p>
-                      <a:pPr algn="ctr" indent="0" marL="0">
+                      <a:pPr marL="0" indent="0" algn="ctr">
                         <a:buNone/>
                       </a:pPr>
                       <a:r>
@@ -6859,7 +6693,7 @@
                       <a:endParaRPr lang="en-US" sz="1400" dirty="0"/>
                     </a:p>
                   </a:txBody>
-                  <a:tcPr marL="91440" marR="91440" marT="0" marB="0" anchor="ctr">
+                  <a:tcPr marT="0" marB="0" anchor="ctr">
                     <a:lnL w="0" cap="flat" cmpd="sng" algn="ctr">
                       <a:noFill/>
                     </a:lnL>
@@ -6883,6 +6717,11 @@
                     </a:solidFill>
                   </a:tcPr>
                 </a:tc>
+                <a:extLst>
+                  <a:ext uri="{0D108BD9-81ED-4DB2-BD59-A6C34878D82A}">
+                    <a16:rowId xmlns:a16="http://schemas.microsoft.com/office/drawing/2014/main" val="10000"/>
+                  </a:ext>
+                </a:extLst>
               </a:tr>
               <a:tr h="502920">
                 <a:tc>
@@ -6890,7 +6729,7 @@
                     <a:bodyPr/>
                     <a:lstStyle/>
                     <a:p>
-                      <a:pPr algn="l" indent="0" marL="0">
+                      <a:pPr marL="0" indent="0" algn="l">
                         <a:buNone/>
                       </a:pPr>
                       <a:r>
@@ -6904,15 +6743,21 @@
                       <a:endParaRPr lang="en-US" sz="1400" dirty="0"/>
                     </a:p>
                   </a:txBody>
-                  <a:tcPr marL="91440" marR="91440" marT="0" marB="0" anchor="ctr">
+                  <a:tcPr marT="0" marB="0" anchor="ctr">
                     <a:lnL w="0" cap="flat" cmpd="sng" algn="ctr">
                       <a:noFill/>
                     </a:lnL>
                     <a:lnR w="0" cap="flat" cmpd="sng" algn="ctr">
                       <a:noFill/>
                     </a:lnR>
-                    <a:lnT w="0" cap="flat" cmpd="sng" algn="ctr">
-                      <a:noFill/>
+                    <a:lnT w="19050" cap="flat" cmpd="sng" algn="ctr">
+                      <a:solidFill>
+                        <a:srgbClr val="007F92"/>
+                      </a:solidFill>
+                      <a:prstDash val="solid"/>
+                      <a:round/>
+                      <a:headEnd type="none" w="med" len="med"/>
+                      <a:tailEnd type="none" w="med" len="med"/>
                     </a:lnT>
                     <a:lnB w="6350" cap="flat" cmpd="sng" algn="ctr">
                       <a:solidFill>
@@ -6933,7 +6778,7 @@
                     <a:bodyPr/>
                     <a:lstStyle/>
                     <a:p>
-                      <a:pPr algn="ctr" indent="0" marL="0">
+                      <a:pPr marL="0" indent="0" algn="ctr">
                         <a:buNone/>
                       </a:pPr>
                       <a:r>
@@ -6947,15 +6792,21 @@
                       <a:endParaRPr lang="en-US" sz="1600" dirty="0"/>
                     </a:p>
                   </a:txBody>
-                  <a:tcPr marL="91440" marR="91440" marT="0" marB="0" anchor="ctr">
+                  <a:tcPr marT="0" marB="0" anchor="ctr">
                     <a:lnL w="0" cap="flat" cmpd="sng" algn="ctr">
                       <a:noFill/>
                     </a:lnL>
                     <a:lnR w="0" cap="flat" cmpd="sng" algn="ctr">
                       <a:noFill/>
                     </a:lnR>
-                    <a:lnT w="0" cap="flat" cmpd="sng" algn="ctr">
-                      <a:noFill/>
+                    <a:lnT w="19050" cap="flat" cmpd="sng" algn="ctr">
+                      <a:solidFill>
+                        <a:srgbClr val="007F92"/>
+                      </a:solidFill>
+                      <a:prstDash val="solid"/>
+                      <a:round/>
+                      <a:headEnd type="none" w="med" len="med"/>
+                      <a:tailEnd type="none" w="med" len="med"/>
                     </a:lnT>
                     <a:lnB w="6350" cap="flat" cmpd="sng" algn="ctr">
                       <a:solidFill>
@@ -6976,7 +6827,7 @@
                     <a:bodyPr/>
                     <a:lstStyle/>
                     <a:p>
-                      <a:pPr algn="ctr" indent="0" marL="0">
+                      <a:pPr marL="0" indent="0" algn="ctr">
                         <a:buNone/>
                       </a:pPr>
                       <a:r>
@@ -6990,15 +6841,21 @@
                       <a:endParaRPr lang="en-US" sz="1600" dirty="0"/>
                     </a:p>
                   </a:txBody>
-                  <a:tcPr marL="91440" marR="91440" marT="0" marB="0" anchor="ctr">
+                  <a:tcPr marT="0" marB="0" anchor="ctr">
                     <a:lnL w="0" cap="flat" cmpd="sng" algn="ctr">
                       <a:noFill/>
                     </a:lnL>
                     <a:lnR w="0" cap="flat" cmpd="sng" algn="ctr">
                       <a:noFill/>
                     </a:lnR>
-                    <a:lnT w="0" cap="flat" cmpd="sng" algn="ctr">
-                      <a:noFill/>
+                    <a:lnT w="19050" cap="flat" cmpd="sng" algn="ctr">
+                      <a:solidFill>
+                        <a:srgbClr val="007F92"/>
+                      </a:solidFill>
+                      <a:prstDash val="solid"/>
+                      <a:round/>
+                      <a:headEnd type="none" w="med" len="med"/>
+                      <a:tailEnd type="none" w="med" len="med"/>
                     </a:lnT>
                     <a:lnB w="6350" cap="flat" cmpd="sng" algn="ctr">
                       <a:solidFill>
@@ -7014,6 +6871,11 @@
                     </a:solidFill>
                   </a:tcPr>
                 </a:tc>
+                <a:extLst>
+                  <a:ext uri="{0D108BD9-81ED-4DB2-BD59-A6C34878D82A}">
+                    <a16:rowId xmlns:a16="http://schemas.microsoft.com/office/drawing/2014/main" val="10001"/>
+                  </a:ext>
+                </a:extLst>
               </a:tr>
               <a:tr h="502920">
                 <a:tc>
@@ -7021,7 +6883,7 @@
                     <a:bodyPr/>
                     <a:lstStyle/>
                     <a:p>
-                      <a:pPr algn="l" indent="0" marL="0">
+                      <a:pPr marL="0" indent="0" algn="l">
                         <a:buNone/>
                       </a:pPr>
                       <a:r>
@@ -7035,15 +6897,21 @@
                       <a:endParaRPr lang="en-US" sz="1400" dirty="0"/>
                     </a:p>
                   </a:txBody>
-                  <a:tcPr marL="91440" marR="91440" marT="0" marB="0" anchor="ctr">
+                  <a:tcPr marT="0" marB="0" anchor="ctr">
                     <a:lnL w="0" cap="flat" cmpd="sng" algn="ctr">
                       <a:noFill/>
                     </a:lnL>
                     <a:lnR w="0" cap="flat" cmpd="sng" algn="ctr">
                       <a:noFill/>
                     </a:lnR>
-                    <a:lnT w="0" cap="flat" cmpd="sng" algn="ctr">
-                      <a:noFill/>
+                    <a:lnT w="6350" cap="flat" cmpd="sng" algn="ctr">
+                      <a:solidFill>
+                        <a:srgbClr val="C9D6DB"/>
+                      </a:solidFill>
+                      <a:prstDash val="solid"/>
+                      <a:round/>
+                      <a:headEnd type="none" w="med" len="med"/>
+                      <a:tailEnd type="none" w="med" len="med"/>
                     </a:lnT>
                     <a:lnB w="6350" cap="flat" cmpd="sng" algn="ctr">
                       <a:solidFill>
@@ -7064,7 +6932,7 @@
                     <a:bodyPr/>
                     <a:lstStyle/>
                     <a:p>
-                      <a:pPr algn="ctr" indent="0" marL="0">
+                      <a:pPr marL="0" indent="0" algn="ctr">
                         <a:buNone/>
                       </a:pPr>
                       <a:r>
@@ -7078,15 +6946,21 @@
                       <a:endParaRPr lang="en-US" sz="1400" dirty="0"/>
                     </a:p>
                   </a:txBody>
-                  <a:tcPr marL="91440" marR="91440" marT="0" marB="0" anchor="ctr">
+                  <a:tcPr marT="0" marB="0" anchor="ctr">
                     <a:lnL w="0" cap="flat" cmpd="sng" algn="ctr">
                       <a:noFill/>
                     </a:lnL>
                     <a:lnR w="0" cap="flat" cmpd="sng" algn="ctr">
                       <a:noFill/>
                     </a:lnR>
-                    <a:lnT w="0" cap="flat" cmpd="sng" algn="ctr">
-                      <a:noFill/>
+                    <a:lnT w="6350" cap="flat" cmpd="sng" algn="ctr">
+                      <a:solidFill>
+                        <a:srgbClr val="C9D6DB"/>
+                      </a:solidFill>
+                      <a:prstDash val="solid"/>
+                      <a:round/>
+                      <a:headEnd type="none" w="med" len="med"/>
+                      <a:tailEnd type="none" w="med" len="med"/>
                     </a:lnT>
                     <a:lnB w="6350" cap="flat" cmpd="sng" algn="ctr">
                       <a:solidFill>
@@ -7107,7 +6981,7 @@
                     <a:bodyPr/>
                     <a:lstStyle/>
                     <a:p>
-                      <a:pPr algn="ctr" indent="0" marL="0">
+                      <a:pPr marL="0" indent="0" algn="ctr">
                         <a:buNone/>
                       </a:pPr>
                       <a:r>
@@ -7121,15 +6995,21 @@
                       <a:endParaRPr lang="en-US" sz="1400" dirty="0"/>
                     </a:p>
                   </a:txBody>
-                  <a:tcPr marL="91440" marR="91440" marT="0" marB="0" anchor="ctr">
+                  <a:tcPr marT="0" marB="0" anchor="ctr">
                     <a:lnL w="0" cap="flat" cmpd="sng" algn="ctr">
                       <a:noFill/>
                     </a:lnL>
                     <a:lnR w="0" cap="flat" cmpd="sng" algn="ctr">
                       <a:noFill/>
                     </a:lnR>
-                    <a:lnT w="0" cap="flat" cmpd="sng" algn="ctr">
-                      <a:noFill/>
+                    <a:lnT w="6350" cap="flat" cmpd="sng" algn="ctr">
+                      <a:solidFill>
+                        <a:srgbClr val="C9D6DB"/>
+                      </a:solidFill>
+                      <a:prstDash val="solid"/>
+                      <a:round/>
+                      <a:headEnd type="none" w="med" len="med"/>
+                      <a:tailEnd type="none" w="med" len="med"/>
                     </a:lnT>
                     <a:lnB w="6350" cap="flat" cmpd="sng" algn="ctr">
                       <a:solidFill>
@@ -7145,6 +7025,11 @@
                     </a:solidFill>
                   </a:tcPr>
                 </a:tc>
+                <a:extLst>
+                  <a:ext uri="{0D108BD9-81ED-4DB2-BD59-A6C34878D82A}">
+                    <a16:rowId xmlns:a16="http://schemas.microsoft.com/office/drawing/2014/main" val="10002"/>
+                  </a:ext>
+                </a:extLst>
               </a:tr>
               <a:tr h="502920">
                 <a:tc>
@@ -7152,7 +7037,7 @@
                     <a:bodyPr/>
                     <a:lstStyle/>
                     <a:p>
-                      <a:pPr algn="l" indent="0" marL="0">
+                      <a:pPr marL="0" indent="0" algn="l">
                         <a:buNone/>
                       </a:pPr>
                       <a:r>
@@ -7166,15 +7051,21 @@
                       <a:endParaRPr lang="en-US" sz="1400" dirty="0"/>
                     </a:p>
                   </a:txBody>
-                  <a:tcPr marL="91440" marR="91440" marT="0" marB="0" anchor="ctr">
+                  <a:tcPr marT="0" marB="0" anchor="ctr">
                     <a:lnL w="0" cap="flat" cmpd="sng" algn="ctr">
                       <a:noFill/>
                     </a:lnL>
                     <a:lnR w="0" cap="flat" cmpd="sng" algn="ctr">
                       <a:noFill/>
                     </a:lnR>
-                    <a:lnT w="0" cap="flat" cmpd="sng" algn="ctr">
-                      <a:noFill/>
+                    <a:lnT w="6350" cap="flat" cmpd="sng" algn="ctr">
+                      <a:solidFill>
+                        <a:srgbClr val="C9D6DB"/>
+                      </a:solidFill>
+                      <a:prstDash val="solid"/>
+                      <a:round/>
+                      <a:headEnd type="none" w="med" len="med"/>
+                      <a:tailEnd type="none" w="med" len="med"/>
                     </a:lnT>
                     <a:lnB w="6350" cap="flat" cmpd="sng" algn="ctr">
                       <a:solidFill>
@@ -7195,7 +7086,7 @@
                     <a:bodyPr/>
                     <a:lstStyle/>
                     <a:p>
-                      <a:pPr algn="ctr" indent="0" marL="0">
+                      <a:pPr marL="0" indent="0" algn="ctr">
                         <a:buNone/>
                       </a:pPr>
                       <a:r>
@@ -7209,15 +7100,21 @@
                       <a:endParaRPr lang="en-US" sz="1400" dirty="0"/>
                     </a:p>
                   </a:txBody>
-                  <a:tcPr marL="91440" marR="91440" marT="0" marB="0" anchor="ctr">
+                  <a:tcPr marT="0" marB="0" anchor="ctr">
                     <a:lnL w="0" cap="flat" cmpd="sng" algn="ctr">
                       <a:noFill/>
                     </a:lnL>
                     <a:lnR w="0" cap="flat" cmpd="sng" algn="ctr">
                       <a:noFill/>
                     </a:lnR>
-                    <a:lnT w="0" cap="flat" cmpd="sng" algn="ctr">
-                      <a:noFill/>
+                    <a:lnT w="6350" cap="flat" cmpd="sng" algn="ctr">
+                      <a:solidFill>
+                        <a:srgbClr val="C9D6DB"/>
+                      </a:solidFill>
+                      <a:prstDash val="solid"/>
+                      <a:round/>
+                      <a:headEnd type="none" w="med" len="med"/>
+                      <a:tailEnd type="none" w="med" len="med"/>
                     </a:lnT>
                     <a:lnB w="6350" cap="flat" cmpd="sng" algn="ctr">
                       <a:solidFill>
@@ -7238,7 +7135,7 @@
                     <a:bodyPr/>
                     <a:lstStyle/>
                     <a:p>
-                      <a:pPr algn="ctr" indent="0" marL="0">
+                      <a:pPr marL="0" indent="0" algn="ctr">
                         <a:buNone/>
                       </a:pPr>
                       <a:r>
@@ -7252,15 +7149,21 @@
                       <a:endParaRPr lang="en-US" sz="1400" dirty="0"/>
                     </a:p>
                   </a:txBody>
-                  <a:tcPr marL="91440" marR="91440" marT="0" marB="0" anchor="ctr">
+                  <a:tcPr marT="0" marB="0" anchor="ctr">
                     <a:lnL w="0" cap="flat" cmpd="sng" algn="ctr">
                       <a:noFill/>
                     </a:lnL>
                     <a:lnR w="0" cap="flat" cmpd="sng" algn="ctr">
                       <a:noFill/>
                     </a:lnR>
-                    <a:lnT w="0" cap="flat" cmpd="sng" algn="ctr">
-                      <a:noFill/>
+                    <a:lnT w="6350" cap="flat" cmpd="sng" algn="ctr">
+                      <a:solidFill>
+                        <a:srgbClr val="C9D6DB"/>
+                      </a:solidFill>
+                      <a:prstDash val="solid"/>
+                      <a:round/>
+                      <a:headEnd type="none" w="med" len="med"/>
+                      <a:tailEnd type="none" w="med" len="med"/>
                     </a:lnT>
                     <a:lnB w="6350" cap="flat" cmpd="sng" algn="ctr">
                       <a:solidFill>
@@ -7276,6 +7179,11 @@
                     </a:solidFill>
                   </a:tcPr>
                 </a:tc>
+                <a:extLst>
+                  <a:ext uri="{0D108BD9-81ED-4DB2-BD59-A6C34878D82A}">
+                    <a16:rowId xmlns:a16="http://schemas.microsoft.com/office/drawing/2014/main" val="10003"/>
+                  </a:ext>
+                </a:extLst>
               </a:tr>
             </a:tbl>
           </a:graphicData>
@@ -7302,7 +7210,7 @@
           <a:bodyPr wrap="square" lIns="0" tIns="0" rIns="0" bIns="0" rtlCol="0" anchor="t"/>
           <a:lstStyle/>
           <a:p>
-            <a:pPr indent="0" marL="0">
+            <a:pPr marL="0" indent="0">
               <a:buNone/>
             </a:pPr>
             <a:r>
@@ -7319,7 +7227,7 @@
       </p:sp>
       <p:sp>
         <p:nvSpPr>
-          <p:cNvPr id="6" name="Constantes tarjeta"/>
+          <p:cNvPr id="4" name="Constantes tarjeta"/>
           <p:cNvSpPr/>
           <p:nvPr/>
         </p:nvSpPr>
@@ -7343,6 +7251,13 @@
             <a:prstDash val="solid"/>
           </a:ln>
         </p:spPr>
+        <p:txBody>
+          <a:bodyPr/>
+          <a:lstStyle/>
+          <a:p>
+            <a:endParaRPr lang="es-GT"/>
+          </a:p>
+        </p:txBody>
       </p:sp>
       <p:sp>
         <p:nvSpPr>
@@ -7365,7 +7280,7 @@
           <a:bodyPr wrap="square" lIns="0" tIns="0" rIns="0" bIns="0" rtlCol="0" anchor="ctr"/>
           <a:lstStyle/>
           <a:p>
-            <a:pPr indent="0" marL="0">
+            <a:pPr marL="0" indent="0">
               <a:spcAft>
                 <a:spcPts val="500"/>
               </a:spcAft>
@@ -7382,7 +7297,7 @@
             <a:endParaRPr lang="en-US" sz="1400" dirty="0"/>
           </a:p>
           <a:p>
-            <a:pPr indent="0" marL="0">
+            <a:pPr marL="0" indent="0">
               <a:spcAft>
                 <a:spcPts val="500"/>
               </a:spcAft>
@@ -7399,7 +7314,7 @@
             <a:endParaRPr lang="en-US" sz="1400" dirty="0"/>
           </a:p>
           <a:p>
-            <a:pPr indent="0" marL="0">
+            <a:pPr marL="0" indent="0">
               <a:spcAft>
                 <a:spcPts val="500"/>
               </a:spcAft>
@@ -7416,7 +7331,7 @@
             <a:endParaRPr lang="en-US" sz="1400" dirty="0"/>
           </a:p>
           <a:p>
-            <a:pPr indent="0" marL="0">
+            <a:pPr marL="0" indent="0">
               <a:spcAft>
                 <a:spcPts val="500"/>
               </a:spcAft>
@@ -7433,7 +7348,7 @@
             <a:endParaRPr lang="en-US" sz="1400" dirty="0"/>
           </a:p>
           <a:p>
-            <a:pPr indent="0" marL="0">
+            <a:pPr marL="0" indent="0">
               <a:spcAft>
                 <a:spcPts val="500"/>
               </a:spcAft>
@@ -7450,7 +7365,7 @@
             <a:endParaRPr lang="en-US" sz="1400" dirty="0"/>
           </a:p>
           <a:p>
-            <a:pPr indent="0" marL="0">
+            <a:pPr marL="0" indent="0">
               <a:spcAft>
                 <a:spcPts val="500"/>
               </a:spcAft>
@@ -7494,6 +7409,13 @@
             <a:prstDash val="solid"/>
           </a:ln>
         </p:spPr>
+        <p:txBody>
+          <a:bodyPr/>
+          <a:lstStyle/>
+          <a:p>
+            <a:endParaRPr lang="es-GT"/>
+          </a:p>
+        </p:txBody>
       </p:sp>
       <p:sp>
         <p:nvSpPr>
@@ -7516,7 +7438,7 @@
           <a:bodyPr wrap="square" lIns="0" tIns="0" rIns="0" bIns="0" rtlCol="0" anchor="ctr"/>
           <a:lstStyle/>
           <a:p>
-            <a:pPr indent="0" marL="0">
+            <a:pPr marL="0" indent="0">
               <a:buNone/>
             </a:pPr>
             <a:r>
@@ -7527,9 +7449,6 @@
               </a:rPr>
               <a:t>Hipótesis previa: </a:t>
             </a:r>
-            <a:pPr indent="0" marL="0">
-              <a:buNone/>
-            </a:pPr>
             <a:r>
               <a:rPr lang="en-US" sz="1400" dirty="0">
                 <a:solidFill>
@@ -7562,7 +7481,7 @@
           </a:prstGeom>
           <a:extLst>
             <a:ext uri="{C572A759-6A51-4108-AA02-DFA0A04FC94B}">
-              <ma14:wrappingTextBoxFlag xmlns:ma14="http://schemas.microsoft.com/office/mac/drawingml/2011/main" val="0"/>
+              <ma14:wrappingTextBoxFlag xmlns:ma14="http://schemas.microsoft.com/office/mac/drawingml/2011/main" xmlns="" val="0"/>
             </a:ext>
           </a:extLst>
         </p:spPr>
@@ -7580,7 +7499,7 @@
           <a:p>
             <a:pPr algn="r"/>
             <a:fld id="{F7021451-1387-4CA6-816F-3879F97B5CBC}" type="slidenum">
-              <a:rPr b="0" lang="en-US"/>
+              <a:rPr lang="en-US" b="0"/>
               <a:t>5</a:t>
             </a:fld>
             <a:endParaRPr lang="en-US"/>
@@ -7615,9 +7534,11 @@
       <p:sp>
         <p:nvSpPr>
           <p:cNvPr id="2" name="Text 0"/>
-          <p:cNvSpPr/>
+          <p:cNvSpPr>
+            <a:spLocks noGrp="1"/>
+          </p:cNvSpPr>
           <p:nvPr>
-            <p:ph idx="100" type="title" hasCustomPrompt="1"/>
+            <p:ph type="title" idx="100" hasCustomPrompt="1"/>
           </p:nvPr>
         </p:nvSpPr>
         <p:spPr>
@@ -7635,7 +7556,7 @@
           <a:bodyPr wrap="square" lIns="0" tIns="0" rIns="0" bIns="0" rtlCol="0" anchor="ctr"/>
           <a:lstStyle/>
           <a:p>
-            <a:pPr algn="l" indent="0" marL="0">
+            <a:pPr marL="0" indent="0" algn="l">
               <a:buNone/>
             </a:pPr>
             <a:r>
@@ -7647,55 +7568,19 @@
               <a:t>Curvas de entrenamiento</a:t>
             </a:r>
             <a:endParaRPr lang="en-US" sz="3400" dirty="0"/>
-          </a:p>
-        </p:txBody>
-      </p:sp>
-      <p:sp>
-        <p:nvSpPr>
-          <p:cNvPr id="3" name="Text 1"/>
-          <p:cNvSpPr txBox="1"/>
-          <p:nvPr/>
-        </p:nvSpPr>
-        <p:spPr>
-          <a:xfrm>
-            <a:off x="548640" y="4754880"/>
-            <a:ext cx="7498080" cy="274320"/>
-          </a:xfrm>
-          <a:prstGeom prst="rect">
-            <a:avLst/>
-          </a:prstGeom>
-          <a:noFill/>
-          <a:ln/>
-        </p:spPr>
-        <p:txBody>
-          <a:bodyPr wrap="square" lIns="0" tIns="0" rIns="0" bIns="0" rtlCol="0" anchor="ctr"/>
-          <a:lstStyle/>
-          <a:p>
-            <a:pPr indent="0" marL="0">
-              <a:buNone/>
-            </a:pPr>
-            <a:r>
-              <a:rPr lang="en-US" sz="1000" dirty="0">
-                <a:solidFill>
-                  <a:schemeClr val="accent3"/>
-                </a:solidFill>
-              </a:rPr>
-              <a:t>Fuente: resultados/lora_r8/loss.csv, resultados/lora_r16/loss.csv</a:t>
-            </a:r>
-            <a:endParaRPr lang="en-US" sz="1000" dirty="0"/>
           </a:p>
         </p:txBody>
       </p:sp>
       <p:pic>
         <p:nvPicPr>
-          <p:cNvPr id="4" name="Curvas de loss" descr="Loss sobre SQL por paso de optimización para los rangos 8 y 16">    </p:cNvPr>
+          <p:cNvPr id="4" name="Curvas de loss" descr="Loss sobre SQL por paso de optimización para los rangos 8 y 16"/>
           <p:cNvPicPr>
             <a:picLocks noChangeAspect="1"/>
           </p:cNvPicPr>
           <p:nvPr/>
         </p:nvPicPr>
         <p:blipFill>
-          <a:blip r:embed="rId1"/>
+          <a:blip r:embed="rId3"/>
           <a:stretch>
             <a:fillRect/>
           </a:stretch>
@@ -7736,6 +7621,13 @@
             <a:prstDash val="solid"/>
           </a:ln>
         </p:spPr>
+        <p:txBody>
+          <a:bodyPr/>
+          <a:lstStyle/>
+          <a:p>
+            <a:endParaRPr lang="es-GT"/>
+          </a:p>
+        </p:txBody>
       </p:sp>
       <p:sp>
         <p:nvSpPr>
@@ -7758,7 +7650,7 @@
           <a:bodyPr wrap="square" lIns="0" tIns="0" rIns="0" bIns="0" rtlCol="0" anchor="ctr"/>
           <a:lstStyle/>
           <a:p>
-            <a:pPr indent="0" marL="0">
+            <a:pPr marL="0" indent="0">
               <a:buNone/>
             </a:pPr>
             <a:r>
@@ -7799,6 +7691,13 @@
             <a:prstDash val="solid"/>
           </a:ln>
         </p:spPr>
+        <p:txBody>
+          <a:bodyPr/>
+          <a:lstStyle/>
+          <a:p>
+            <a:endParaRPr lang="es-GT"/>
+          </a:p>
+        </p:txBody>
       </p:sp>
       <p:sp>
         <p:nvSpPr>
@@ -7821,7 +7720,7 @@
           <a:bodyPr wrap="square" lIns="0" tIns="0" rIns="0" bIns="0" rtlCol="0" anchor="ctr"/>
           <a:lstStyle/>
           <a:p>
-            <a:pPr indent="0" marL="0">
+            <a:pPr marL="0" indent="0">
               <a:buNone/>
             </a:pPr>
             <a:r>
@@ -7856,7 +7755,7 @@
           </a:prstGeom>
           <a:extLst>
             <a:ext uri="{C572A759-6A51-4108-AA02-DFA0A04FC94B}">
-              <ma14:wrappingTextBoxFlag xmlns:ma14="http://schemas.microsoft.com/office/mac/drawingml/2011/main" val="0"/>
+              <ma14:wrappingTextBoxFlag xmlns:ma14="http://schemas.microsoft.com/office/mac/drawingml/2011/main" xmlns="" val="0"/>
             </a:ext>
           </a:extLst>
         </p:spPr>
@@ -7874,7 +7773,7 @@
           <a:p>
             <a:pPr algn="r"/>
             <a:fld id="{F7021451-1387-4CA6-816F-3879F97B5CBC}" type="slidenum">
-              <a:rPr b="0" lang="en-US"/>
+              <a:rPr lang="en-US" b="0"/>
               <a:t>6</a:t>
             </a:fld>
             <a:endParaRPr lang="en-US"/>
@@ -7909,9 +7808,11 @@
       <p:sp>
         <p:nvSpPr>
           <p:cNvPr id="2" name="Text 0"/>
-          <p:cNvSpPr/>
+          <p:cNvSpPr>
+            <a:spLocks noGrp="1"/>
+          </p:cNvSpPr>
           <p:nvPr>
-            <p:ph idx="100" type="title" hasCustomPrompt="1"/>
+            <p:ph type="title" idx="100" hasCustomPrompt="1"/>
           </p:nvPr>
         </p:nvSpPr>
         <p:spPr>
@@ -7929,7 +7830,7 @@
           <a:bodyPr wrap="square" lIns="0" tIns="0" rIns="0" bIns="0" rtlCol="0" anchor="ctr"/>
           <a:lstStyle/>
           <a:p>
-            <a:pPr algn="l" indent="0" marL="0">
+            <a:pPr marL="0" indent="0" algn="l">
               <a:buNone/>
             </a:pPr>
             <a:r>
@@ -7941,48 +7842,12 @@
               <a:t>Resultados principales</a:t>
             </a:r>
             <a:endParaRPr lang="en-US" sz="3400" dirty="0"/>
-          </a:p>
-        </p:txBody>
-      </p:sp>
-      <p:sp>
-        <p:nvSpPr>
-          <p:cNvPr id="3" name="Text 1"/>
-          <p:cNvSpPr txBox="1"/>
-          <p:nvPr/>
-        </p:nvSpPr>
-        <p:spPr>
-          <a:xfrm>
-            <a:off x="548640" y="4754880"/>
-            <a:ext cx="7498080" cy="274320"/>
-          </a:xfrm>
-          <a:prstGeom prst="rect">
-            <a:avLst/>
-          </a:prstGeom>
-          <a:noFill/>
-          <a:ln/>
-        </p:spPr>
-        <p:txBody>
-          <a:bodyPr wrap="square" lIns="0" tIns="0" rIns="0" bIns="0" rtlCol="0" anchor="ctr"/>
-          <a:lstStyle/>
-          <a:p>
-            <a:pPr indent="0" marL="0">
-              <a:buNone/>
-            </a:pPr>
-            <a:r>
-              <a:rPr lang="en-US" sz="1000" dirty="0">
-                <a:solidFill>
-                  <a:schemeClr val="accent3"/>
-                </a:solidFill>
-              </a:rPr>
-              <a:t>Fuente: resultados/baseline.json, resultados/lora_r8.json, README.md</a:t>
-            </a:r>
-            <a:endParaRPr lang="en-US" sz="1000" dirty="0"/>
           </a:p>
         </p:txBody>
       </p:sp>
       <p:graphicFrame>
         <p:nvGraphicFramePr>
-          <p:cNvPr id="4" name="Gráfico EX" descr=""/>
+          <p:cNvPr id="4" name="Gráfico EX"/>
           <p:cNvGraphicFramePr/>
           <p:nvPr/>
         </p:nvGraphicFramePr>
@@ -7990,9 +7855,9 @@
           <a:off x="548640" y="1143000"/>
           <a:ext cx="5120640" cy="3429000"/>
         </p:xfrm>
-        <a:graphic xmlns:a="http://schemas.openxmlformats.org/drawingml/2006/main">
+        <a:graphic>
           <a:graphicData uri="http://schemas.openxmlformats.org/drawingml/2006/chart">
-            <c:chart xmlns:c="http://schemas.openxmlformats.org/drawingml/2006/chart" r:id="rId1"/>
+            <c:chart xmlns:c="http://schemas.openxmlformats.org/drawingml/2006/chart" xmlns:r="http://schemas.openxmlformats.org/officeDocument/2006/relationships" r:id="rId3"/>
           </a:graphicData>
         </a:graphic>
       </p:graphicFrame>
@@ -8022,6 +7887,13 @@
             <a:prstDash val="solid"/>
           </a:ln>
         </p:spPr>
+        <p:txBody>
+          <a:bodyPr/>
+          <a:lstStyle/>
+          <a:p>
+            <a:endParaRPr lang="es-GT"/>
+          </a:p>
+        </p:txBody>
       </p:sp>
       <p:sp>
         <p:nvSpPr>
@@ -8044,7 +7916,7 @@
           <a:bodyPr wrap="square" lIns="0" tIns="0" rIns="0" bIns="0" rtlCol="0" anchor="ctr"/>
           <a:lstStyle/>
           <a:p>
-            <a:pPr algn="l" indent="0" marL="0">
+            <a:pPr marL="0" indent="0" algn="l">
               <a:buNone/>
             </a:pPr>
             <a:r>
@@ -8083,7 +7955,7 @@
           <a:bodyPr wrap="square" lIns="0" tIns="0" rIns="0" bIns="0" rtlCol="0" anchor="t"/>
           <a:lstStyle/>
           <a:p>
-            <a:pPr algn="l" indent="0" marL="0">
+            <a:pPr marL="0" indent="0" algn="l">
               <a:buNone/>
             </a:pPr>
             <a:r>
@@ -8124,6 +7996,13 @@
             <a:prstDash val="solid"/>
           </a:ln>
         </p:spPr>
+        <p:txBody>
+          <a:bodyPr/>
+          <a:lstStyle/>
+          <a:p>
+            <a:endParaRPr lang="es-GT"/>
+          </a:p>
+        </p:txBody>
       </p:sp>
       <p:sp>
         <p:nvSpPr>
@@ -8146,7 +8025,7 @@
           <a:bodyPr wrap="square" lIns="0" tIns="0" rIns="0" bIns="0" rtlCol="0" anchor="ctr"/>
           <a:lstStyle/>
           <a:p>
-            <a:pPr indent="0" marL="0">
+            <a:pPr marL="0" indent="0">
               <a:spcAft>
                 <a:spcPts val="400"/>
               </a:spcAft>
@@ -8163,7 +8042,7 @@
             <a:endParaRPr lang="en-US" sz="1400" dirty="0"/>
           </a:p>
           <a:p>
-            <a:pPr indent="0" marL="0">
+            <a:pPr marL="0" indent="0">
               <a:spcAft>
                 <a:spcPts val="400"/>
               </a:spcAft>
@@ -8180,7 +8059,7 @@
             <a:endParaRPr lang="en-US" sz="1400" dirty="0"/>
           </a:p>
           <a:p>
-            <a:pPr indent="0" marL="0">
+            <a:pPr marL="0" indent="0">
               <a:spcAft>
                 <a:spcPts val="400"/>
               </a:spcAft>
@@ -8218,7 +8097,7 @@
           </a:prstGeom>
           <a:extLst>
             <a:ext uri="{C572A759-6A51-4108-AA02-DFA0A04FC94B}">
-              <ma14:wrappingTextBoxFlag xmlns:ma14="http://schemas.microsoft.com/office/mac/drawingml/2011/main" val="0"/>
+              <ma14:wrappingTextBoxFlag xmlns:ma14="http://schemas.microsoft.com/office/mac/drawingml/2011/main" xmlns="" val="0"/>
             </a:ext>
           </a:extLst>
         </p:spPr>
@@ -8236,7 +8115,7 @@
           <a:p>
             <a:pPr algn="r"/>
             <a:fld id="{F7021451-1387-4CA6-816F-3879F97B5CBC}" type="slidenum">
-              <a:rPr b="0" lang="en-US"/>
+              <a:rPr lang="en-US" b="0"/>
               <a:t>7</a:t>
             </a:fld>
             <a:endParaRPr lang="en-US"/>
@@ -8271,9 +8150,11 @@
       <p:sp>
         <p:nvSpPr>
           <p:cNvPr id="2" name="Text 0"/>
-          <p:cNvSpPr/>
+          <p:cNvSpPr>
+            <a:spLocks noGrp="1"/>
+          </p:cNvSpPr>
           <p:nvPr>
-            <p:ph idx="100" type="title" hasCustomPrompt="1"/>
+            <p:ph type="title" idx="100" hasCustomPrompt="1"/>
           </p:nvPr>
         </p:nvSpPr>
         <p:spPr>
@@ -8291,7 +8172,7 @@
           <a:bodyPr wrap="square" lIns="0" tIns="0" rIns="0" bIns="0" rtlCol="0" anchor="ctr"/>
           <a:lstStyle/>
           <a:p>
-            <a:pPr algn="l" indent="0" marL="0">
+            <a:pPr marL="0" indent="0" algn="l">
               <a:buNone/>
             </a:pPr>
             <a:r>
@@ -8303,42 +8184,6 @@
               <a:t>Experimento de reparación</a:t>
             </a:r>
             <a:endParaRPr lang="en-US" sz="3400" dirty="0"/>
-          </a:p>
-        </p:txBody>
-      </p:sp>
-      <p:sp>
-        <p:nvSpPr>
-          <p:cNvPr id="3" name="Text 1"/>
-          <p:cNvSpPr txBox="1"/>
-          <p:nvPr/>
-        </p:nvSpPr>
-        <p:spPr>
-          <a:xfrm>
-            <a:off x="548640" y="4754880"/>
-            <a:ext cx="7498080" cy="274320"/>
-          </a:xfrm>
-          <a:prstGeom prst="rect">
-            <a:avLst/>
-          </a:prstGeom>
-          <a:noFill/>
-          <a:ln/>
-        </p:spPr>
-        <p:txBody>
-          <a:bodyPr wrap="square" lIns="0" tIns="0" rIns="0" bIns="0" rtlCol="0" anchor="ctr"/>
-          <a:lstStyle/>
-          <a:p>
-            <a:pPr indent="0" marL="0">
-              <a:buNone/>
-            </a:pPr>
-            <a:r>
-              <a:rPr lang="en-US" sz="1000" dirty="0">
-                <a:solidFill>
-                  <a:schemeClr val="accent3"/>
-                </a:solidFill>
-              </a:rPr>
-              <a:t>Fuente: README.md, experimentos.md, resultados/lora_r8.json</a:t>
-            </a:r>
-            <a:endParaRPr lang="en-US" sz="1000" dirty="0"/>
           </a:p>
         </p:txBody>
       </p:sp>
@@ -8358,17 +8203,41 @@
         </p:nvGraphicFramePr>
         <p:xfrm>
           <a:off x="548640" y="1188720"/>
-          <a:ext cx="5120640" cy="914400"/>
+          <a:ext cx="5120640" cy="1234440"/>
         </p:xfrm>
         <a:graphic>
           <a:graphicData uri="http://schemas.openxmlformats.org/drawingml/2006/table">
             <a:tbl>
               <a:tblPr/>
               <a:tblGrid>
-                <a:gridCol w="1737360"/>
-                <a:gridCol w="914400"/>
-                <a:gridCol w="914400"/>
-                <a:gridCol w="1554480"/>
+                <a:gridCol w="1737360">
+                  <a:extLst>
+                    <a:ext uri="{9D8B030D-6E8A-4147-A177-3AD203B41FA5}">
+                      <a16:colId xmlns:a16="http://schemas.microsoft.com/office/drawing/2014/main" val="20000"/>
+                    </a:ext>
+                  </a:extLst>
+                </a:gridCol>
+                <a:gridCol w="914400">
+                  <a:extLst>
+                    <a:ext uri="{9D8B030D-6E8A-4147-A177-3AD203B41FA5}">
+                      <a16:colId xmlns:a16="http://schemas.microsoft.com/office/drawing/2014/main" val="20001"/>
+                    </a:ext>
+                  </a:extLst>
+                </a:gridCol>
+                <a:gridCol w="914400">
+                  <a:extLst>
+                    <a:ext uri="{9D8B030D-6E8A-4147-A177-3AD203B41FA5}">
+                      <a16:colId xmlns:a16="http://schemas.microsoft.com/office/drawing/2014/main" val="20002"/>
+                    </a:ext>
+                  </a:extLst>
+                </a:gridCol>
+                <a:gridCol w="1554480">
+                  <a:extLst>
+                    <a:ext uri="{9D8B030D-6E8A-4147-A177-3AD203B41FA5}">
+                      <a16:colId xmlns:a16="http://schemas.microsoft.com/office/drawing/2014/main" val="20003"/>
+                    </a:ext>
+                  </a:extLst>
+                </a:gridCol>
               </a:tblGrid>
               <a:tr h="411480">
                 <a:tc>
@@ -8376,7 +8245,7 @@
                     <a:bodyPr/>
                     <a:lstStyle/>
                     <a:p>
-                      <a:pPr algn="l" indent="0" marL="0">
+                      <a:pPr marL="0" indent="0" algn="l">
                         <a:buNone/>
                       </a:pPr>
                       <a:r>
@@ -8390,7 +8259,7 @@
                       <a:endParaRPr lang="en-US" sz="1400" dirty="0"/>
                     </a:p>
                   </a:txBody>
-                  <a:tcPr marL="91440" marR="91440" marT="0" marB="0" anchor="ctr">
+                  <a:tcPr marT="0" marB="0" anchor="ctr">
                     <a:lnL w="0" cap="flat" cmpd="sng" algn="ctr">
                       <a:noFill/>
                     </a:lnL>
@@ -8419,7 +8288,7 @@
                     <a:bodyPr/>
                     <a:lstStyle/>
                     <a:p>
-                      <a:pPr algn="ctr" indent="0" marL="0">
+                      <a:pPr marL="0" indent="0" algn="ctr">
                         <a:buNone/>
                       </a:pPr>
                       <a:r>
@@ -8433,7 +8302,7 @@
                       <a:endParaRPr lang="en-US" sz="1400" dirty="0"/>
                     </a:p>
                   </a:txBody>
-                  <a:tcPr marL="91440" marR="91440" marT="0" marB="0" anchor="ctr">
+                  <a:tcPr marT="0" marB="0" anchor="ctr">
                     <a:lnL w="0" cap="flat" cmpd="sng" algn="ctr">
                       <a:noFill/>
                     </a:lnL>
@@ -8462,7 +8331,7 @@
                     <a:bodyPr/>
                     <a:lstStyle/>
                     <a:p>
-                      <a:pPr algn="ctr" indent="0" marL="0">
+                      <a:pPr marL="0" indent="0" algn="ctr">
                         <a:buNone/>
                       </a:pPr>
                       <a:r>
@@ -8476,7 +8345,7 @@
                       <a:endParaRPr lang="en-US" sz="1400" dirty="0"/>
                     </a:p>
                   </a:txBody>
-                  <a:tcPr marL="91440" marR="91440" marT="0" marB="0" anchor="ctr">
+                  <a:tcPr marT="0" marB="0" anchor="ctr">
                     <a:lnL w="0" cap="flat" cmpd="sng" algn="ctr">
                       <a:noFill/>
                     </a:lnL>
@@ -8505,7 +8374,7 @@
                     <a:bodyPr/>
                     <a:lstStyle/>
                     <a:p>
-                      <a:pPr algn="ctr" indent="0" marL="0">
+                      <a:pPr marL="0" indent="0" algn="ctr">
                         <a:buNone/>
                       </a:pPr>
                       <a:r>
@@ -8519,7 +8388,7 @@
                       <a:endParaRPr lang="en-US" sz="1400" dirty="0"/>
                     </a:p>
                   </a:txBody>
-                  <a:tcPr marL="91440" marR="91440" marT="0" marB="0" anchor="ctr">
+                  <a:tcPr marT="0" marB="0" anchor="ctr">
                     <a:lnL w="0" cap="flat" cmpd="sng" algn="ctr">
                       <a:noFill/>
                     </a:lnL>
@@ -8543,6 +8412,11 @@
                     </a:solidFill>
                   </a:tcPr>
                 </a:tc>
+                <a:extLst>
+                  <a:ext uri="{0D108BD9-81ED-4DB2-BD59-A6C34878D82A}">
+                    <a16:rowId xmlns:a16="http://schemas.microsoft.com/office/drawing/2014/main" val="10000"/>
+                  </a:ext>
+                </a:extLst>
               </a:tr>
               <a:tr h="411480">
                 <a:tc>
@@ -8550,7 +8424,7 @@
                     <a:bodyPr/>
                     <a:lstStyle/>
                     <a:p>
-                      <a:pPr algn="l" indent="0" marL="0">
+                      <a:pPr marL="0" indent="0" algn="l">
                         <a:buNone/>
                       </a:pPr>
                       <a:r>
@@ -8564,15 +8438,21 @@
                       <a:endParaRPr lang="en-US" sz="1400" dirty="0"/>
                     </a:p>
                   </a:txBody>
-                  <a:tcPr marL="91440" marR="91440" marT="0" marB="0" anchor="ctr">
+                  <a:tcPr marT="0" marB="0" anchor="ctr">
                     <a:lnL w="0" cap="flat" cmpd="sng" algn="ctr">
                       <a:noFill/>
                     </a:lnL>
                     <a:lnR w="0" cap="flat" cmpd="sng" algn="ctr">
                       <a:noFill/>
                     </a:lnR>
-                    <a:lnT w="0" cap="flat" cmpd="sng" algn="ctr">
-                      <a:noFill/>
+                    <a:lnT w="19050" cap="flat" cmpd="sng" algn="ctr">
+                      <a:solidFill>
+                        <a:srgbClr val="007F92"/>
+                      </a:solidFill>
+                      <a:prstDash val="solid"/>
+                      <a:round/>
+                      <a:headEnd type="none" w="med" len="med"/>
+                      <a:tailEnd type="none" w="med" len="med"/>
                     </a:lnT>
                     <a:lnB w="6350" cap="flat" cmpd="sng" algn="ctr">
                       <a:solidFill>
@@ -8593,7 +8473,7 @@
                     <a:bodyPr/>
                     <a:lstStyle/>
                     <a:p>
-                      <a:pPr algn="ctr" indent="0" marL="0">
+                      <a:pPr marL="0" indent="0" algn="ctr">
                         <a:buNone/>
                       </a:pPr>
                       <a:r>
@@ -8607,15 +8487,21 @@
                       <a:endParaRPr lang="en-US" sz="1400" dirty="0"/>
                     </a:p>
                   </a:txBody>
-                  <a:tcPr marL="91440" marR="91440" marT="0" marB="0" anchor="ctr">
+                  <a:tcPr marT="0" marB="0" anchor="ctr">
                     <a:lnL w="0" cap="flat" cmpd="sng" algn="ctr">
                       <a:noFill/>
                     </a:lnL>
                     <a:lnR w="0" cap="flat" cmpd="sng" algn="ctr">
                       <a:noFill/>
                     </a:lnR>
-                    <a:lnT w="0" cap="flat" cmpd="sng" algn="ctr">
-                      <a:noFill/>
+                    <a:lnT w="19050" cap="flat" cmpd="sng" algn="ctr">
+                      <a:solidFill>
+                        <a:srgbClr val="007F92"/>
+                      </a:solidFill>
+                      <a:prstDash val="solid"/>
+                      <a:round/>
+                      <a:headEnd type="none" w="med" len="med"/>
+                      <a:tailEnd type="none" w="med" len="med"/>
                     </a:lnT>
                     <a:lnB w="6350" cap="flat" cmpd="sng" algn="ctr">
                       <a:solidFill>
@@ -8636,7 +8522,7 @@
                     <a:bodyPr/>
                     <a:lstStyle/>
                     <a:p>
-                      <a:pPr algn="ctr" indent="0" marL="0">
+                      <a:pPr marL="0" indent="0" algn="ctr">
                         <a:buNone/>
                       </a:pPr>
                       <a:r>
@@ -8650,15 +8536,21 @@
                       <a:endParaRPr lang="en-US" sz="1400" dirty="0"/>
                     </a:p>
                   </a:txBody>
-                  <a:tcPr marL="91440" marR="91440" marT="0" marB="0" anchor="ctr">
+                  <a:tcPr marT="0" marB="0" anchor="ctr">
                     <a:lnL w="0" cap="flat" cmpd="sng" algn="ctr">
                       <a:noFill/>
                     </a:lnL>
                     <a:lnR w="0" cap="flat" cmpd="sng" algn="ctr">
                       <a:noFill/>
                     </a:lnR>
-                    <a:lnT w="0" cap="flat" cmpd="sng" algn="ctr">
-                      <a:noFill/>
+                    <a:lnT w="19050" cap="flat" cmpd="sng" algn="ctr">
+                      <a:solidFill>
+                        <a:srgbClr val="007F92"/>
+                      </a:solidFill>
+                      <a:prstDash val="solid"/>
+                      <a:round/>
+                      <a:headEnd type="none" w="med" len="med"/>
+                      <a:tailEnd type="none" w="med" len="med"/>
                     </a:lnT>
                     <a:lnB w="6350" cap="flat" cmpd="sng" algn="ctr">
                       <a:solidFill>
@@ -8679,7 +8571,7 @@
                     <a:bodyPr/>
                     <a:lstStyle/>
                     <a:p>
-                      <a:pPr algn="ctr" indent="0" marL="0">
+                      <a:pPr marL="0" indent="0" algn="ctr">
                         <a:buNone/>
                       </a:pPr>
                       <a:r>
@@ -8693,15 +8585,21 @@
                       <a:endParaRPr lang="en-US" sz="1400" dirty="0"/>
                     </a:p>
                   </a:txBody>
-                  <a:tcPr marL="91440" marR="91440" marT="0" marB="0" anchor="ctr">
+                  <a:tcPr marT="0" marB="0" anchor="ctr">
                     <a:lnL w="0" cap="flat" cmpd="sng" algn="ctr">
                       <a:noFill/>
                     </a:lnL>
                     <a:lnR w="0" cap="flat" cmpd="sng" algn="ctr">
                       <a:noFill/>
                     </a:lnR>
-                    <a:lnT w="0" cap="flat" cmpd="sng" algn="ctr">
-                      <a:noFill/>
+                    <a:lnT w="19050" cap="flat" cmpd="sng" algn="ctr">
+                      <a:solidFill>
+                        <a:srgbClr val="007F92"/>
+                      </a:solidFill>
+                      <a:prstDash val="solid"/>
+                      <a:round/>
+                      <a:headEnd type="none" w="med" len="med"/>
+                      <a:tailEnd type="none" w="med" len="med"/>
                     </a:lnT>
                     <a:lnB w="6350" cap="flat" cmpd="sng" algn="ctr">
                       <a:solidFill>
@@ -8717,6 +8615,11 @@
                     </a:solidFill>
                   </a:tcPr>
                 </a:tc>
+                <a:extLst>
+                  <a:ext uri="{0D108BD9-81ED-4DB2-BD59-A6C34878D82A}">
+                    <a16:rowId xmlns:a16="http://schemas.microsoft.com/office/drawing/2014/main" val="10001"/>
+                  </a:ext>
+                </a:extLst>
               </a:tr>
               <a:tr h="411480">
                 <a:tc>
@@ -8724,7 +8627,7 @@
                     <a:bodyPr/>
                     <a:lstStyle/>
                     <a:p>
-                      <a:pPr algn="l" indent="0" marL="0">
+                      <a:pPr marL="0" indent="0" algn="l">
                         <a:buNone/>
                       </a:pPr>
                       <a:r>
@@ -8738,15 +8641,21 @@
                       <a:endParaRPr lang="en-US" sz="1400" dirty="0"/>
                     </a:p>
                   </a:txBody>
-                  <a:tcPr marL="91440" marR="91440" marT="0" marB="0" anchor="ctr">
+                  <a:tcPr marT="0" marB="0" anchor="ctr">
                     <a:lnL w="0" cap="flat" cmpd="sng" algn="ctr">
                       <a:noFill/>
                     </a:lnL>
                     <a:lnR w="0" cap="flat" cmpd="sng" algn="ctr">
                       <a:noFill/>
                     </a:lnR>
-                    <a:lnT w="0" cap="flat" cmpd="sng" algn="ctr">
-                      <a:noFill/>
+                    <a:lnT w="6350" cap="flat" cmpd="sng" algn="ctr">
+                      <a:solidFill>
+                        <a:srgbClr val="C9D6DB"/>
+                      </a:solidFill>
+                      <a:prstDash val="solid"/>
+                      <a:round/>
+                      <a:headEnd type="none" w="med" len="med"/>
+                      <a:tailEnd type="none" w="med" len="med"/>
                     </a:lnT>
                     <a:lnB w="6350" cap="flat" cmpd="sng" algn="ctr">
                       <a:solidFill>
@@ -8767,7 +8676,7 @@
                     <a:bodyPr/>
                     <a:lstStyle/>
                     <a:p>
-                      <a:pPr algn="ctr" indent="0" marL="0">
+                      <a:pPr marL="0" indent="0" algn="ctr">
                         <a:buNone/>
                       </a:pPr>
                       <a:r>
@@ -8781,15 +8690,21 @@
                       <a:endParaRPr lang="en-US" sz="1400" dirty="0"/>
                     </a:p>
                   </a:txBody>
-                  <a:tcPr marL="91440" marR="91440" marT="0" marB="0" anchor="ctr">
+                  <a:tcPr marT="0" marB="0" anchor="ctr">
                     <a:lnL w="0" cap="flat" cmpd="sng" algn="ctr">
                       <a:noFill/>
                     </a:lnL>
                     <a:lnR w="0" cap="flat" cmpd="sng" algn="ctr">
                       <a:noFill/>
                     </a:lnR>
-                    <a:lnT w="0" cap="flat" cmpd="sng" algn="ctr">
-                      <a:noFill/>
+                    <a:lnT w="6350" cap="flat" cmpd="sng" algn="ctr">
+                      <a:solidFill>
+                        <a:srgbClr val="C9D6DB"/>
+                      </a:solidFill>
+                      <a:prstDash val="solid"/>
+                      <a:round/>
+                      <a:headEnd type="none" w="med" len="med"/>
+                      <a:tailEnd type="none" w="med" len="med"/>
                     </a:lnT>
                     <a:lnB w="6350" cap="flat" cmpd="sng" algn="ctr">
                       <a:solidFill>
@@ -8810,7 +8725,7 @@
                     <a:bodyPr/>
                     <a:lstStyle/>
                     <a:p>
-                      <a:pPr algn="ctr" indent="0" marL="0">
+                      <a:pPr marL="0" indent="0" algn="ctr">
                         <a:buNone/>
                       </a:pPr>
                       <a:r>
@@ -8824,15 +8739,21 @@
                       <a:endParaRPr lang="en-US" sz="1400" dirty="0"/>
                     </a:p>
                   </a:txBody>
-                  <a:tcPr marL="91440" marR="91440" marT="0" marB="0" anchor="ctr">
+                  <a:tcPr marT="0" marB="0" anchor="ctr">
                     <a:lnL w="0" cap="flat" cmpd="sng" algn="ctr">
                       <a:noFill/>
                     </a:lnL>
                     <a:lnR w="0" cap="flat" cmpd="sng" algn="ctr">
                       <a:noFill/>
                     </a:lnR>
-                    <a:lnT w="0" cap="flat" cmpd="sng" algn="ctr">
-                      <a:noFill/>
+                    <a:lnT w="6350" cap="flat" cmpd="sng" algn="ctr">
+                      <a:solidFill>
+                        <a:srgbClr val="C9D6DB"/>
+                      </a:solidFill>
+                      <a:prstDash val="solid"/>
+                      <a:round/>
+                      <a:headEnd type="none" w="med" len="med"/>
+                      <a:tailEnd type="none" w="med" len="med"/>
                     </a:lnT>
                     <a:lnB w="6350" cap="flat" cmpd="sng" algn="ctr">
                       <a:solidFill>
@@ -8853,7 +8774,7 @@
                     <a:bodyPr/>
                     <a:lstStyle/>
                     <a:p>
-                      <a:pPr algn="ctr" indent="0" marL="0">
+                      <a:pPr marL="0" indent="0" algn="ctr">
                         <a:buNone/>
                       </a:pPr>
                       <a:r>
@@ -8867,15 +8788,21 @@
                       <a:endParaRPr lang="en-US" sz="1400" dirty="0"/>
                     </a:p>
                   </a:txBody>
-                  <a:tcPr marL="91440" marR="91440" marT="0" marB="0" anchor="ctr">
+                  <a:tcPr marT="0" marB="0" anchor="ctr">
                     <a:lnL w="0" cap="flat" cmpd="sng" algn="ctr">
                       <a:noFill/>
                     </a:lnL>
                     <a:lnR w="0" cap="flat" cmpd="sng" algn="ctr">
                       <a:noFill/>
                     </a:lnR>
-                    <a:lnT w="0" cap="flat" cmpd="sng" algn="ctr">
-                      <a:noFill/>
+                    <a:lnT w="6350" cap="flat" cmpd="sng" algn="ctr">
+                      <a:solidFill>
+                        <a:srgbClr val="C9D6DB"/>
+                      </a:solidFill>
+                      <a:prstDash val="solid"/>
+                      <a:round/>
+                      <a:headEnd type="none" w="med" len="med"/>
+                      <a:tailEnd type="none" w="med" len="med"/>
                     </a:lnT>
                     <a:lnB w="6350" cap="flat" cmpd="sng" algn="ctr">
                       <a:solidFill>
@@ -8891,6 +8818,11 @@
                     </a:solidFill>
                   </a:tcPr>
                 </a:tc>
+                <a:extLst>
+                  <a:ext uri="{0D108BD9-81ED-4DB2-BD59-A6C34878D82A}">
+                    <a16:rowId xmlns:a16="http://schemas.microsoft.com/office/drawing/2014/main" val="10002"/>
+                  </a:ext>
+                </a:extLst>
               </a:tr>
             </a:tbl>
           </a:graphicData>
@@ -8922,6 +8854,13 @@
             <a:prstDash val="solid"/>
           </a:ln>
         </p:spPr>
+        <p:txBody>
+          <a:bodyPr/>
+          <a:lstStyle/>
+          <a:p>
+            <a:endParaRPr lang="es-GT"/>
+          </a:p>
+        </p:txBody>
       </p:sp>
       <p:sp>
         <p:nvSpPr>
@@ -8944,7 +8883,7 @@
           <a:bodyPr wrap="square" lIns="0" tIns="0" rIns="0" bIns="0" rtlCol="0" anchor="ctr"/>
           <a:lstStyle/>
           <a:p>
-            <a:pPr indent="0" marL="0">
+            <a:pPr marL="0" indent="0">
               <a:spcAft>
                 <a:spcPts val="400"/>
               </a:spcAft>
@@ -8961,7 +8900,7 @@
             <a:endParaRPr lang="en-US" sz="1400" dirty="0"/>
           </a:p>
           <a:p>
-            <a:pPr indent="0" marL="0">
+            <a:pPr marL="0" indent="0">
               <a:spcAft>
                 <a:spcPts val="400"/>
               </a:spcAft>
@@ -9005,6 +8944,13 @@
             <a:prstDash val="solid"/>
           </a:ln>
         </p:spPr>
+        <p:txBody>
+          <a:bodyPr/>
+          <a:lstStyle/>
+          <a:p>
+            <a:endParaRPr lang="es-GT"/>
+          </a:p>
+        </p:txBody>
       </p:sp>
       <p:sp>
         <p:nvSpPr>
@@ -9030,10 +8976,17 @@
             <a:prstDash val="solid"/>
           </a:ln>
         </p:spPr>
-      </p:sp>
-      <p:sp>
-        <p:nvSpPr>
-          <p:cNvPr id="9" name="Paso 1 número"/>
+        <p:txBody>
+          <a:bodyPr/>
+          <a:lstStyle/>
+          <a:p>
+            <a:endParaRPr lang="es-GT"/>
+          </a:p>
+        </p:txBody>
+      </p:sp>
+      <p:sp>
+        <p:nvSpPr>
+          <p:cNvPr id="4" name="Paso 1 número"/>
           <p:cNvSpPr txBox="1"/>
           <p:nvPr/>
         </p:nvSpPr>
@@ -9052,7 +9005,7 @@
           <a:bodyPr wrap="square" lIns="0" tIns="0" rIns="0" bIns="0" rtlCol="0" anchor="ctr"/>
           <a:lstStyle/>
           <a:p>
-            <a:pPr algn="ctr" indent="0" marL="0">
+            <a:pPr marL="0" indent="0" algn="ctr">
               <a:buNone/>
             </a:pPr>
             <a:r>
@@ -9088,7 +9041,7 @@
           <a:bodyPr wrap="square" lIns="0" tIns="0" rIns="0" bIns="0" rtlCol="0" anchor="ctr"/>
           <a:lstStyle/>
           <a:p>
-            <a:pPr indent="0" marL="0">
+            <a:pPr marL="0" indent="0">
               <a:buNone/>
             </a:pPr>
             <a:r>
@@ -9129,6 +9082,13 @@
             <a:prstDash val="solid"/>
           </a:ln>
         </p:spPr>
+        <p:txBody>
+          <a:bodyPr/>
+          <a:lstStyle/>
+          <a:p>
+            <a:endParaRPr lang="es-GT"/>
+          </a:p>
+        </p:txBody>
       </p:sp>
       <p:sp>
         <p:nvSpPr>
@@ -9154,6 +9114,13 @@
             <a:prstDash val="solid"/>
           </a:ln>
         </p:spPr>
+        <p:txBody>
+          <a:bodyPr/>
+          <a:lstStyle/>
+          <a:p>
+            <a:endParaRPr lang="es-GT"/>
+          </a:p>
+        </p:txBody>
       </p:sp>
       <p:sp>
         <p:nvSpPr>
@@ -9176,7 +9143,7 @@
           <a:bodyPr wrap="square" lIns="0" tIns="0" rIns="0" bIns="0" rtlCol="0" anchor="ctr"/>
           <a:lstStyle/>
           <a:p>
-            <a:pPr algn="ctr" indent="0" marL="0">
+            <a:pPr marL="0" indent="0" algn="ctr">
               <a:buNone/>
             </a:pPr>
             <a:r>
@@ -9212,7 +9179,7 @@
           <a:bodyPr wrap="square" lIns="0" tIns="0" rIns="0" bIns="0" rtlCol="0" anchor="ctr"/>
           <a:lstStyle/>
           <a:p>
-            <a:pPr indent="0" marL="0">
+            <a:pPr marL="0" indent="0">
               <a:buNone/>
             </a:pPr>
             <a:r>
@@ -9305,7 +9272,7 @@
           </a:prstGeom>
           <a:extLst>
             <a:ext uri="{C572A759-6A51-4108-AA02-DFA0A04FC94B}">
-              <ma14:wrappingTextBoxFlag xmlns:ma14="http://schemas.microsoft.com/office/mac/drawingml/2011/main" val="0"/>
+              <ma14:wrappingTextBoxFlag xmlns:ma14="http://schemas.microsoft.com/office/mac/drawingml/2011/main" xmlns="" val="0"/>
             </a:ext>
           </a:extLst>
         </p:spPr>
@@ -9323,7 +9290,7 @@
           <a:p>
             <a:pPr algn="r"/>
             <a:fld id="{F7021451-1387-4CA6-816F-3879F97B5CBC}" type="slidenum">
-              <a:rPr b="0" lang="en-US"/>
+              <a:rPr lang="en-US" b="0"/>
               <a:t>8</a:t>
             </a:fld>
             <a:endParaRPr lang="en-US"/>
@@ -9358,9 +9325,11 @@
       <p:sp>
         <p:nvSpPr>
           <p:cNvPr id="2" name="Text 0"/>
-          <p:cNvSpPr/>
+          <p:cNvSpPr>
+            <a:spLocks noGrp="1"/>
+          </p:cNvSpPr>
           <p:nvPr>
-            <p:ph idx="100" type="title" hasCustomPrompt="1"/>
+            <p:ph type="title" idx="100" hasCustomPrompt="1"/>
           </p:nvPr>
         </p:nvSpPr>
         <p:spPr>
@@ -9378,7 +9347,7 @@
           <a:bodyPr wrap="square" lIns="0" tIns="0" rIns="0" bIns="0" rtlCol="0" anchor="ctr"/>
           <a:lstStyle/>
           <a:p>
-            <a:pPr algn="l" indent="0" marL="0">
+            <a:pPr marL="0" indent="0" algn="l">
               <a:buNone/>
             </a:pPr>
             <a:r>
@@ -9390,48 +9359,12 @@
               <a:t>Análisis de errores</a:t>
             </a:r>
             <a:endParaRPr lang="en-US" sz="3400" dirty="0"/>
-          </a:p>
-        </p:txBody>
-      </p:sp>
-      <p:sp>
-        <p:nvSpPr>
-          <p:cNvPr id="3" name="Text 1"/>
-          <p:cNvSpPr txBox="1"/>
-          <p:nvPr/>
-        </p:nvSpPr>
-        <p:spPr>
-          <a:xfrm>
-            <a:off x="548640" y="4754880"/>
-            <a:ext cx="7498080" cy="274320"/>
-          </a:xfrm>
-          <a:prstGeom prst="rect">
-            <a:avLst/>
-          </a:prstGeom>
-          <a:noFill/>
-          <a:ln/>
-        </p:spPr>
-        <p:txBody>
-          <a:bodyPr wrap="square" lIns="0" tIns="0" rIns="0" bIns="0" rtlCol="0" anchor="ctr"/>
-          <a:lstStyle/>
-          <a:p>
-            <a:pPr indent="0" marL="0">
-              <a:buNone/>
-            </a:pPr>
-            <a:r>
-              <a:rPr lang="en-US" sz="1000" dirty="0">
-                <a:solidFill>
-                  <a:schemeClr val="accent3"/>
-                </a:solidFill>
-              </a:rPr>
-              <a:t>Fuente: resultados/revision_errores.csv, resultados/lora_r8.csv</a:t>
-            </a:r>
-            <a:endParaRPr lang="en-US" sz="1000" dirty="0"/>
           </a:p>
         </p:txBody>
       </p:sp>
       <p:graphicFrame>
         <p:nvGraphicFramePr>
-          <p:cNvPr id="4" name="Gráfico de errores" descr=""/>
+          <p:cNvPr id="4" name="Gráfico de errores"/>
           <p:cNvGraphicFramePr/>
           <p:nvPr/>
         </p:nvGraphicFramePr>
@@ -9439,9 +9372,9 @@
           <a:off x="548640" y="1143000"/>
           <a:ext cx="4206240" cy="3429000"/>
         </p:xfrm>
-        <a:graphic xmlns:a="http://schemas.openxmlformats.org/drawingml/2006/main">
+        <a:graphic>
           <a:graphicData uri="http://schemas.openxmlformats.org/drawingml/2006/chart">
-            <c:chart xmlns:c="http://schemas.openxmlformats.org/drawingml/2006/chart" r:id="rId1"/>
+            <c:chart xmlns:c="http://schemas.openxmlformats.org/drawingml/2006/chart" xmlns:r="http://schemas.openxmlformats.org/officeDocument/2006/relationships" r:id="rId3"/>
           </a:graphicData>
         </a:graphic>
       </p:graphicFrame>
@@ -9471,6 +9404,13 @@
             <a:prstDash val="solid"/>
           </a:ln>
         </p:spPr>
+        <p:txBody>
+          <a:bodyPr/>
+          <a:lstStyle/>
+          <a:p>
+            <a:endParaRPr lang="es-GT"/>
+          </a:p>
+        </p:txBody>
       </p:sp>
       <p:sp>
         <p:nvSpPr>
@@ -9493,7 +9433,7 @@
           <a:bodyPr wrap="square" lIns="0" tIns="0" rIns="0" bIns="0" rtlCol="0" anchor="ctr"/>
           <a:lstStyle/>
           <a:p>
-            <a:pPr indent="0" marL="0">
+            <a:pPr marL="0" indent="0">
               <a:spcAft>
                 <a:spcPts val="400"/>
               </a:spcAft>
@@ -9510,7 +9450,7 @@
             <a:endParaRPr lang="en-US" sz="1400" dirty="0"/>
           </a:p>
           <a:p>
-            <a:pPr indent="0" marL="0">
+            <a:pPr marL="0" indent="0">
               <a:spcAft>
                 <a:spcPts val="400"/>
               </a:spcAft>
@@ -9530,7 +9470,7 @@
             <a:endParaRPr lang="en-US" sz="1400" dirty="0"/>
           </a:p>
           <a:p>
-            <a:pPr indent="0" marL="0">
+            <a:pPr marL="0" indent="0">
               <a:spcAft>
                 <a:spcPts val="400"/>
               </a:spcAft>
@@ -9550,7 +9490,7 @@
             <a:endParaRPr lang="en-US" sz="1400" dirty="0"/>
           </a:p>
           <a:p>
-            <a:pPr indent="0" marL="0">
+            <a:pPr marL="0" indent="0">
               <a:spcAft>
                 <a:spcPts val="400"/>
               </a:spcAft>
@@ -9594,6 +9534,13 @@
             <a:prstDash val="solid"/>
           </a:ln>
         </p:spPr>
+        <p:txBody>
+          <a:bodyPr/>
+          <a:lstStyle/>
+          <a:p>
+            <a:endParaRPr lang="es-GT"/>
+          </a:p>
+        </p:txBody>
       </p:sp>
       <p:sp>
         <p:nvSpPr>
@@ -9616,7 +9563,7 @@
           <a:bodyPr wrap="square" lIns="0" tIns="0" rIns="0" bIns="0" rtlCol="0" anchor="ctr"/>
           <a:lstStyle/>
           <a:p>
-            <a:pPr indent="0" marL="0">
+            <a:pPr marL="0" indent="0">
               <a:spcAft>
                 <a:spcPts val="400"/>
               </a:spcAft>
@@ -9633,7 +9580,7 @@
             <a:endParaRPr lang="en-US" sz="1400" dirty="0"/>
           </a:p>
           <a:p>
-            <a:pPr indent="0" marL="0">
+            <a:pPr marL="0" indent="0">
               <a:spcAft>
                 <a:spcPts val="400"/>
               </a:spcAft>
@@ -9653,7 +9600,7 @@
             <a:endParaRPr lang="en-US" sz="1400" dirty="0"/>
           </a:p>
           <a:p>
-            <a:pPr indent="0" marL="0">
+            <a:pPr marL="0" indent="0">
               <a:spcAft>
                 <a:spcPts val="400"/>
               </a:spcAft>
@@ -9673,7 +9620,7 @@
             <a:endParaRPr lang="en-US" sz="1400" dirty="0"/>
           </a:p>
           <a:p>
-            <a:pPr indent="0" marL="0">
+            <a:pPr marL="0" indent="0">
               <a:spcAft>
                 <a:spcPts val="400"/>
               </a:spcAft>
@@ -9711,7 +9658,7 @@
           </a:prstGeom>
           <a:extLst>
             <a:ext uri="{C572A759-6A51-4108-AA02-DFA0A04FC94B}">
-              <ma14:wrappingTextBoxFlag xmlns:ma14="http://schemas.microsoft.com/office/mac/drawingml/2011/main" val="0"/>
+              <ma14:wrappingTextBoxFlag xmlns:ma14="http://schemas.microsoft.com/office/mac/drawingml/2011/main" xmlns="" val="0"/>
             </a:ext>
           </a:extLst>
         </p:spPr>
@@ -9729,7 +9676,7 @@
           <a:p>
             <a:pPr algn="r"/>
             <a:fld id="{F7021451-1387-4CA6-816F-3879F97B5CBC}" type="slidenum">
-              <a:rPr b="0" lang="en-US"/>
+              <a:rPr lang="en-US" b="0"/>
               <a:t>9</a:t>
             </a:fld>
             <a:endParaRPr lang="en-US"/>
@@ -10037,4 +9984,319 @@
     </a:ext>
   </a:extLst>
 </a:theme>
+</file>
+
+<file path=ppt/theme/theme2.xml><?xml version="1.0" encoding="utf-8"?>
+<a:theme xmlns:a="http://schemas.openxmlformats.org/drawingml/2006/main" name="Tema de Office">
+  <a:themeElements>
+    <a:clrScheme name="Office">
+      <a:dk1>
+        <a:sysClr val="windowText" lastClr="000000"/>
+      </a:dk1>
+      <a:lt1>
+        <a:sysClr val="window" lastClr="FFFFFF"/>
+      </a:lt1>
+      <a:dk2>
+        <a:srgbClr val="0E2841"/>
+      </a:dk2>
+      <a:lt2>
+        <a:srgbClr val="E8E8E8"/>
+      </a:lt2>
+      <a:accent1>
+        <a:srgbClr val="156082"/>
+      </a:accent1>
+      <a:accent2>
+        <a:srgbClr val="E97132"/>
+      </a:accent2>
+      <a:accent3>
+        <a:srgbClr val="196B24"/>
+      </a:accent3>
+      <a:accent4>
+        <a:srgbClr val="0F9ED5"/>
+      </a:accent4>
+      <a:accent5>
+        <a:srgbClr val="A02B93"/>
+      </a:accent5>
+      <a:accent6>
+        <a:srgbClr val="4EA72E"/>
+      </a:accent6>
+      <a:hlink>
+        <a:srgbClr val="467886"/>
+      </a:hlink>
+      <a:folHlink>
+        <a:srgbClr val="96607D"/>
+      </a:folHlink>
+    </a:clrScheme>
+    <a:fontScheme name="Office">
+      <a:majorFont>
+        <a:latin typeface="Aptos Display" panose="02110004020202020204"/>
+        <a:ea typeface=""/>
+        <a:cs typeface=""/>
+        <a:font script="Jpan" typeface="游ゴシック Light"/>
+        <a:font script="Hang" typeface="맑은 고딕"/>
+        <a:font script="Hans" typeface="等线 Light"/>
+        <a:font script="Hant" typeface="新細明體"/>
+        <a:font script="Arab" typeface="Times New Roman"/>
+        <a:font script="Hebr" typeface="Times New Roman"/>
+        <a:font script="Thai" typeface="Angsana New"/>
+        <a:font script="Ethi" typeface="Nyala"/>
+        <a:font script="Beng" typeface="Vrinda"/>
+        <a:font script="Gujr" typeface="Shruti"/>
+        <a:font script="Khmr" typeface="MoolBoran"/>
+        <a:font script="Knda" typeface="Tunga"/>
+        <a:font script="Guru" typeface="Raavi"/>
+        <a:font script="Cans" typeface="Euphemia"/>
+        <a:font script="Cher" typeface="Plantagenet Cherokee"/>
+        <a:font script="Yiii" typeface="Microsoft Yi Baiti"/>
+        <a:font script="Tibt" typeface="Microsoft Himalaya"/>
+        <a:font script="Thaa" typeface="MV Boli"/>
+        <a:font script="Deva" typeface="Mangal"/>
+        <a:font script="Telu" typeface="Gautami"/>
+        <a:font script="Taml" typeface="Latha"/>
+        <a:font script="Syrc" typeface="Estrangelo Edessa"/>
+        <a:font script="Orya" typeface="Kalinga"/>
+        <a:font script="Mlym" typeface="Kartika"/>
+        <a:font script="Laoo" typeface="DokChampa"/>
+        <a:font script="Sinh" typeface="Iskoola Pota"/>
+        <a:font script="Mong" typeface="Mongolian Baiti"/>
+        <a:font script="Viet" typeface="Times New Roman"/>
+        <a:font script="Uigh" typeface="Microsoft Uighur"/>
+        <a:font script="Geor" typeface="Sylfaen"/>
+        <a:font script="Armn" typeface="Arial"/>
+        <a:font script="Bugi" typeface="Leelawadee UI"/>
+        <a:font script="Bopo" typeface="Microsoft JhengHei"/>
+        <a:font script="Java" typeface="Javanese Text"/>
+        <a:font script="Lisu" typeface="Segoe UI"/>
+        <a:font script="Mymr" typeface="Myanmar Text"/>
+        <a:font script="Nkoo" typeface="Ebrima"/>
+        <a:font script="Olck" typeface="Nirmala UI"/>
+        <a:font script="Osma" typeface="Ebrima"/>
+        <a:font script="Phag" typeface="Phagspa"/>
+        <a:font script="Syrn" typeface="Estrangelo Edessa"/>
+        <a:font script="Syrj" typeface="Estrangelo Edessa"/>
+        <a:font script="Syre" typeface="Estrangelo Edessa"/>
+        <a:font script="Sora" typeface="Nirmala UI"/>
+        <a:font script="Tale" typeface="Microsoft Tai Le"/>
+        <a:font script="Talu" typeface="Microsoft New Tai Lue"/>
+        <a:font script="Tfng" typeface="Ebrima"/>
+      </a:majorFont>
+      <a:minorFont>
+        <a:latin typeface="Aptos" panose="02110004020202020204"/>
+        <a:ea typeface=""/>
+        <a:cs typeface=""/>
+        <a:font script="Jpan" typeface="游ゴシック"/>
+        <a:font script="Hang" typeface="맑은 고딕"/>
+        <a:font script="Hans" typeface="等线"/>
+        <a:font script="Hant" typeface="新細明體"/>
+        <a:font script="Arab" typeface="Arial"/>
+        <a:font script="Hebr" typeface="Arial"/>
+        <a:font script="Thai" typeface="Cordia New"/>
+        <a:font script="Ethi" typeface="Nyala"/>
+        <a:font script="Beng" typeface="Vrinda"/>
+        <a:font script="Gujr" typeface="Shruti"/>
+        <a:font script="Khmr" typeface="DaunPenh"/>
+        <a:font script="Knda" typeface="Tunga"/>
+        <a:font script="Guru" typeface="Raavi"/>
+        <a:font script="Cans" typeface="Euphemia"/>
+        <a:font script="Cher" typeface="Plantagenet Cherokee"/>
+        <a:font script="Yiii" typeface="Microsoft Yi Baiti"/>
+        <a:font script="Tibt" typeface="Microsoft Himalaya"/>
+        <a:font script="Thaa" typeface="MV Boli"/>
+        <a:font script="Deva" typeface="Mangal"/>
+        <a:font script="Telu" typeface="Gautami"/>
+        <a:font script="Taml" typeface="Latha"/>
+        <a:font script="Syrc" typeface="Estrangelo Edessa"/>
+        <a:font script="Orya" typeface="Kalinga"/>
+        <a:font script="Mlym" typeface="Kartika"/>
+        <a:font script="Laoo" typeface="DokChampa"/>
+        <a:font script="Sinh" typeface="Iskoola Pota"/>
+        <a:font script="Mong" typeface="Mongolian Baiti"/>
+        <a:font script="Viet" typeface="Arial"/>
+        <a:font script="Uigh" typeface="Microsoft Uighur"/>
+        <a:font script="Geor" typeface="Sylfaen"/>
+        <a:font script="Armn" typeface="Arial"/>
+        <a:font script="Bugi" typeface="Leelawadee UI"/>
+        <a:font script="Bopo" typeface="Microsoft JhengHei"/>
+        <a:font script="Java" typeface="Javanese Text"/>
+        <a:font script="Lisu" typeface="Segoe UI"/>
+        <a:font script="Mymr" typeface="Myanmar Text"/>
+        <a:font script="Nkoo" typeface="Ebrima"/>
+        <a:font script="Olck" typeface="Nirmala UI"/>
+        <a:font script="Osma" typeface="Ebrima"/>
+        <a:font script="Phag" typeface="Phagspa"/>
+        <a:font script="Syrn" typeface="Estrangelo Edessa"/>
+        <a:font script="Syrj" typeface="Estrangelo Edessa"/>
+        <a:font script="Syre" typeface="Estrangelo Edessa"/>
+        <a:font script="Sora" typeface="Nirmala UI"/>
+        <a:font script="Tale" typeface="Microsoft Tai Le"/>
+        <a:font script="Talu" typeface="Microsoft New Tai Lue"/>
+        <a:font script="Tfng" typeface="Ebrima"/>
+      </a:minorFont>
+    </a:fontScheme>
+    <a:fmtScheme name="Office">
+      <a:fillStyleLst>
+        <a:solidFill>
+          <a:schemeClr val="phClr"/>
+        </a:solidFill>
+        <a:gradFill rotWithShape="1">
+          <a:gsLst>
+            <a:gs pos="0">
+              <a:schemeClr val="phClr">
+                <a:lumMod val="110000"/>
+                <a:satMod val="105000"/>
+                <a:tint val="67000"/>
+              </a:schemeClr>
+            </a:gs>
+            <a:gs pos="50000">
+              <a:schemeClr val="phClr">
+                <a:lumMod val="105000"/>
+                <a:satMod val="103000"/>
+                <a:tint val="73000"/>
+              </a:schemeClr>
+            </a:gs>
+            <a:gs pos="100000">
+              <a:schemeClr val="phClr">
+                <a:lumMod val="105000"/>
+                <a:satMod val="109000"/>
+                <a:tint val="81000"/>
+              </a:schemeClr>
+            </a:gs>
+          </a:gsLst>
+          <a:lin ang="5400000" scaled="0"/>
+        </a:gradFill>
+        <a:gradFill rotWithShape="1">
+          <a:gsLst>
+            <a:gs pos="0">
+              <a:schemeClr val="phClr">
+                <a:satMod val="103000"/>
+                <a:lumMod val="102000"/>
+                <a:tint val="94000"/>
+              </a:schemeClr>
+            </a:gs>
+            <a:gs pos="50000">
+              <a:schemeClr val="phClr">
+                <a:satMod val="110000"/>
+                <a:lumMod val="100000"/>
+                <a:shade val="100000"/>
+              </a:schemeClr>
+            </a:gs>
+            <a:gs pos="100000">
+              <a:schemeClr val="phClr">
+                <a:lumMod val="99000"/>
+                <a:satMod val="120000"/>
+                <a:shade val="78000"/>
+              </a:schemeClr>
+            </a:gs>
+          </a:gsLst>
+          <a:lin ang="5400000" scaled="0"/>
+        </a:gradFill>
+      </a:fillStyleLst>
+      <a:lnStyleLst>
+        <a:ln w="12700" cap="flat" cmpd="sng" algn="ctr">
+          <a:solidFill>
+            <a:schemeClr val="phClr"/>
+          </a:solidFill>
+          <a:prstDash val="solid"/>
+          <a:miter lim="800000"/>
+        </a:ln>
+        <a:ln w="19050" cap="flat" cmpd="sng" algn="ctr">
+          <a:solidFill>
+            <a:schemeClr val="phClr"/>
+          </a:solidFill>
+          <a:prstDash val="solid"/>
+          <a:miter lim="800000"/>
+        </a:ln>
+        <a:ln w="25400" cap="flat" cmpd="sng" algn="ctr">
+          <a:solidFill>
+            <a:schemeClr val="phClr"/>
+          </a:solidFill>
+          <a:prstDash val="solid"/>
+          <a:miter lim="800000"/>
+        </a:ln>
+      </a:lnStyleLst>
+      <a:effectStyleLst>
+        <a:effectStyle>
+          <a:effectLst/>
+        </a:effectStyle>
+        <a:effectStyle>
+          <a:effectLst/>
+        </a:effectStyle>
+        <a:effectStyle>
+          <a:effectLst>
+            <a:outerShdw blurRad="57150" dist="19050" dir="5400000" algn="ctr" rotWithShape="0">
+              <a:srgbClr val="000000">
+                <a:alpha val="63000"/>
+              </a:srgbClr>
+            </a:outerShdw>
+          </a:effectLst>
+        </a:effectStyle>
+      </a:effectStyleLst>
+      <a:bgFillStyleLst>
+        <a:solidFill>
+          <a:schemeClr val="phClr"/>
+        </a:solidFill>
+        <a:solidFill>
+          <a:schemeClr val="phClr">
+            <a:tint val="95000"/>
+            <a:satMod val="170000"/>
+          </a:schemeClr>
+        </a:solidFill>
+        <a:gradFill rotWithShape="1">
+          <a:gsLst>
+            <a:gs pos="0">
+              <a:schemeClr val="phClr">
+                <a:tint val="93000"/>
+                <a:satMod val="150000"/>
+                <a:shade val="98000"/>
+                <a:lumMod val="102000"/>
+              </a:schemeClr>
+            </a:gs>
+            <a:gs pos="50000">
+              <a:schemeClr val="phClr">
+                <a:tint val="98000"/>
+                <a:satMod val="130000"/>
+                <a:shade val="90000"/>
+                <a:lumMod val="103000"/>
+              </a:schemeClr>
+            </a:gs>
+            <a:gs pos="100000">
+              <a:schemeClr val="phClr">
+                <a:shade val="63000"/>
+                <a:satMod val="120000"/>
+              </a:schemeClr>
+            </a:gs>
+          </a:gsLst>
+          <a:lin ang="5400000" scaled="0"/>
+        </a:gradFill>
+      </a:bgFillStyleLst>
+    </a:fmtScheme>
+  </a:themeElements>
+  <a:objectDefaults>
+    <a:lnDef>
+      <a:spPr/>
+      <a:bodyPr/>
+      <a:lstStyle/>
+      <a:style>
+        <a:lnRef idx="2">
+          <a:schemeClr val="accent1"/>
+        </a:lnRef>
+        <a:fillRef idx="0">
+          <a:schemeClr val="accent1"/>
+        </a:fillRef>
+        <a:effectRef idx="1">
+          <a:schemeClr val="accent1"/>
+        </a:effectRef>
+        <a:fontRef idx="minor">
+          <a:schemeClr val="tx1"/>
+        </a:fontRef>
+      </a:style>
+    </a:lnDef>
+  </a:objectDefaults>
+  <a:extraClrSchemeLst/>
+  <a:extLst>
+    <a:ext uri="{05A4C25C-085E-4340-85A3-A5531E510DB2}">
+      <thm15:themeFamily xmlns:thm15="http://schemas.microsoft.com/office/thememl/2012/main" name="Office Theme" id="{2E142A2C-CD16-42D6-873A-C26D2A0506FA}" vid="{1BDDFF52-6CD6-40A5-AB3C-68EB2F1E4D0A}"/>
+    </a:ext>
+  </a:extLst>
+</a:theme>
 </file>
</xml_diff>

<commit_message>
update: document T4 results and refresh final presentation
</commit_message>
<xml_diff>
--- a/presentacion_proyecto.pptx
+++ b/presentacion_proyecto.pptx
@@ -285,35 +285,47 @@
           </c:dLbls>
           <c:cat>
             <c:strRef>
-              <c:f>Sheet1!$A$2:$A$4</c:f>
+              <c:f>Sheet1!$A$2:$A$6</c:f>
               <c:strCache>
-                <c:ptCount val="3"/>
+                <c:ptCount val="5"/>
                 <c:pt idx="0">
-                  <c:v>Base NF4 (15/40)</c:v>
+                  <c:v>Base NF4</c:v>
                 </c:pt>
                 <c:pt idx="1">
-                  <c:v>QLoRA rango 8 (21/40)</c:v>
+                  <c:v>R8 inicial</c:v>
                 </c:pt>
                 <c:pt idx="2">
-                  <c:v>QLoRA rango 16 (20/40)</c:v>
+                  <c:v>R16 inicial</c:v>
+                </c:pt>
+                <c:pt idx="3">
+                  <c:v>R8 completo</c:v>
+                </c:pt>
+                <c:pt idx="4">
+                  <c:v>R16 completo</c:v>
                 </c:pt>
               </c:strCache>
             </c:strRef>
           </c:cat>
           <c:val>
             <c:numRef>
-              <c:f>Sheet1!$B$2:$B$4</c:f>
+              <c:f>Sheet1!$B$2:$B$6</c:f>
               <c:numCache>
                 <c:formatCode>General</c:formatCode>
-                <c:ptCount val="3"/>
+                <c:ptCount val="5"/>
                 <c:pt idx="0">
-                  <c:v>28</c:v>
+                  <c:v>28.0</c:v>
                 </c:pt>
                 <c:pt idx="1">
                   <c:v>43.9</c:v>
                 </c:pt>
                 <c:pt idx="2">
-                  <c:v>40.200000000000003</c:v>
+                  <c:v>40.2</c:v>
+                </c:pt>
+                <c:pt idx="3">
+                  <c:v>41.5</c:v>
+                </c:pt>
+                <c:pt idx="4">
+                  <c:v>40.2</c:v>
                 </c:pt>
               </c:numCache>
             </c:numRef>
@@ -484,7 +496,7 @@
                 </a:solidFill>
                 <a:latin typeface="+mn-lt"/>
               </a:rPr>
-              <a:t>Errores de la selección final (19 de 40)</a:t>
+              <a:t>Errores de la selección final (18 de 40)</a:t>
             </a:r>
           </a:p>
         </c:rich>
@@ -558,9 +570,9 @@
           </c:dLbls>
           <c:cat>
             <c:strRef>
-              <c:f>Sheet1!$A$2:$A$6</c:f>
+              <c:f>Sheet1!$A$2:$A$5</c:f>
               <c:strCache>
-                <c:ptCount val="5"/>
+                <c:ptCount val="4"/>
                 <c:pt idx="0">
                   <c:v>Tabla o columna inexistente</c:v>
                 </c:pt>
@@ -573,20 +585,17 @@
                 <c:pt idx="3">
                   <c:v>JOIN</c:v>
                 </c:pt>
-                <c:pt idx="4">
-                  <c:v>Sintaxis</c:v>
-                </c:pt>
               </c:strCache>
             </c:strRef>
           </c:cat>
           <c:val>
             <c:numRef>
-              <c:f>Sheet1!$B$2:$B$6</c:f>
+              <c:f>Sheet1!$B$2:$B$5</c:f>
               <c:numCache>
                 <c:formatCode>General</c:formatCode>
-                <c:ptCount val="5"/>
+                <c:ptCount val="4"/>
                 <c:pt idx="0">
-                  <c:v>8</c:v>
+                  <c:v>9</c:v>
                 </c:pt>
                 <c:pt idx="1">
                   <c:v>5</c:v>
@@ -595,9 +604,6 @@
                   <c:v>3</c:v>
                 </c:pt>
                 <c:pt idx="3">
-                  <c:v>2</c:v>
-                </c:pt>
-                <c:pt idx="4">
                   <c:v>1</c:v>
                 </c:pt>
               </c:numCache>
@@ -2609,7 +2615,7 @@
                 <a:ea typeface="Cambria" pitchFamily="34" charset="-122"/>
                 <a:cs typeface="Cambria" pitchFamily="34" charset="-120"/>
               </a:rPr>
-              <a:t>6.37 s</a:t>
+              <a:t>4.89 s</a:t>
             </a:r>
             <a:endParaRPr lang="en-US" sz="3400" dirty="0"/>
           </a:p>
@@ -2827,7 +2833,7 @@
                 <a:ea typeface="Cambria" pitchFamily="34" charset="-122"/>
                 <a:cs typeface="Cambria" pitchFamily="34" charset="-120"/>
               </a:rPr>
-              <a:t>23</a:t>
+              <a:t>25</a:t>
             </a:r>
             <a:endParaRPr lang="en-US" sz="3400" dirty="0"/>
           </a:p>
@@ -3179,7 +3185,7 @@
                   <a:schemeClr val="tx1"/>
                 </a:solidFill>
               </a:rPr>
-              <a:t>Las mediciones corresponden a la GPU local MX350 y no acreditan una prueba en Colab T4.</a:t>
+              <a:t>Validación e inferencia comprobadas en Tesla T4. Tiempo máximo por pregunta: 25.15 s.</a:t>
             </a:r>
             <a:endParaRPr lang="en-US" sz="1600" dirty="0"/>
           </a:p>
@@ -3471,7 +3477,7 @@
                 <a:ea typeface="Cambria" pitchFamily="34" charset="-122"/>
                 <a:cs typeface="Cambria" pitchFamily="34" charset="-120"/>
               </a:rPr>
-              <a:t>Sin reparación</a:t>
+              <a:t>Con reparación</a:t>
             </a:r>
             <a:endParaRPr lang="en-US" sz="1800" dirty="0"/>
           </a:p>
@@ -3580,7 +3586,7 @@
                 <a:ea typeface="Cambria" pitchFamily="34" charset="-122"/>
                 <a:cs typeface="Cambria" pitchFamily="34" charset="-120"/>
               </a:rPr>
-              <a:t>0.439</a:t>
+              <a:t>0.451</a:t>
             </a:r>
             <a:endParaRPr lang="en-US" sz="3000" dirty="0"/>
           </a:p>
@@ -3689,7 +3695,7 @@
                 <a:ea typeface="Cambria" pitchFamily="34" charset="-122"/>
                 <a:cs typeface="Cambria" pitchFamily="34" charset="-120"/>
               </a:rPr>
-              <a:t>0.35</a:t>
+              <a:t>0.36</a:t>
             </a:r>
             <a:endParaRPr lang="en-US" sz="3000" dirty="0"/>
           </a:p>
@@ -4007,7 +4013,7 @@
                   <a:schemeClr val="tx1"/>
                 </a:solidFill>
               </a:rPr>
-              <a:t>304 ejemplos de entrenamiento por configuración</a:t>
+              <a:t>Mayor cobertura sin mejora de EX</a:t>
             </a:r>
             <a:endParaRPr lang="en-US" sz="1400" dirty="0"/>
           </a:p>
@@ -6941,7 +6947,7 @@
                             <a:schemeClr val="tx1"/>
                           </a:solidFill>
                         </a:rPr>
-                        <a:t>76 / 304</a:t>
+                        <a:t>756 / 3,023</a:t>
                       </a:r>
                       <a:endParaRPr lang="en-US" sz="1400" dirty="0"/>
                     </a:p>
@@ -6990,7 +6996,7 @@
                             <a:schemeClr val="tx1"/>
                           </a:solidFill>
                         </a:rPr>
-                        <a:t>76 / 304</a:t>
+                        <a:t>756 / 3,023</a:t>
                       </a:r>
                       <a:endParaRPr lang="en-US" sz="1400" dirty="0"/>
                     </a:p>
@@ -7046,7 +7052,7 @@
                             <a:schemeClr val="tx1"/>
                           </a:solidFill>
                         </a:rPr>
-                        <a:t>Entrenamiento</a:t>
+                        <a:t>Tiempo en T4</a:t>
                       </a:r>
                       <a:endParaRPr lang="en-US" sz="1400" dirty="0"/>
                     </a:p>
@@ -7095,7 +7101,7 @@
                             <a:schemeClr val="tx1"/>
                           </a:solidFill>
                         </a:rPr>
-                        <a:t>37.1 min</a:t>
+                        <a:t>27.1 min</a:t>
                       </a:r>
                       <a:endParaRPr lang="en-US" sz="1400" dirty="0"/>
                     </a:p>
@@ -7144,7 +7150,7 @@
                             <a:schemeClr val="tx1"/>
                           </a:solidFill>
                         </a:rPr>
-                        <a:t>41.0 min</a:t>
+                        <a:t>27.0 min</a:t>
                       </a:r>
                       <a:endParaRPr lang="en-US" sz="1400" dirty="0"/>
                     </a:p>
@@ -7219,7 +7225,7 @@
                   <a:schemeClr val="accent3"/>
                 </a:solidFill>
               </a:rPr>
-              <a:t>Tiempo de entrenamiento; no corresponde a inferencia. Ejemplos procesados del corpus de 3,023 pares.</a:t>
+              <a:t>Continuación desde 76 pasos y 304 ejemplos por rango. Se recorrió una época adicional completa en T4.</a:t>
             </a:r>
             <a:endParaRPr lang="en-US" sz="1200" dirty="0"/>
           </a:p>
@@ -7360,7 +7366,7 @@
                   <a:schemeClr val="tx1"/>
                 </a:solidFill>
               </a:rPr>
-              <a:t>Tasa 0.0002</a:t>
+              <a:t>Tasa 0.0001</a:t>
             </a:r>
             <a:endParaRPr lang="en-US" sz="1400" dirty="0"/>
           </a:p>
@@ -7659,7 +7665,7 @@
                   <a:schemeClr val="tx1"/>
                 </a:solidFill>
               </a:rPr>
-              <a:t>La pérdida se calcula solo sobre la respuesta SQL.</a:t>
+              <a:t>Continuación: una época completa por rango en T4.</a:t>
             </a:r>
             <a:endParaRPr lang="en-US" sz="1300" dirty="0"/>
           </a:p>
@@ -8054,7 +8060,7 @@
                   <a:schemeClr val="tx2"/>
                 </a:solidFill>
               </a:rPr>
-              <a:t>QLoRA rango 8</a:t>
+              <a:t>R8 + reparación</a:t>
             </a:r>
             <a:endParaRPr lang="en-US" sz="1400" dirty="0"/>
           </a:p>
@@ -8071,7 +8077,7 @@
                   <a:schemeClr val="tx1"/>
                 </a:solidFill>
               </a:rPr>
-              <a:t>EX 43.9%</a:t>
+              <a:t>EX 45.1%</a:t>
             </a:r>
             <a:endParaRPr lang="en-US" sz="1400" dirty="0"/>
           </a:p>
@@ -8580,7 +8586,7 @@
                             <a:schemeClr val="tx1"/>
                           </a:solidFill>
                         </a:rPr>
-                        <a:t>11.49 s</a:t>
+                        <a:t>3.18 s</a:t>
                       </a:r>
                       <a:endParaRPr lang="en-US" sz="1400" dirty="0"/>
                     </a:p>
@@ -8685,7 +8691,7 @@
                             <a:schemeClr val="tx1"/>
                           </a:solidFill>
                         </a:rPr>
-                        <a:t>0.427</a:t>
+                        <a:t>0.451</a:t>
                       </a:r>
                       <a:endParaRPr lang="en-US" sz="1400" dirty="0"/>
                     </a:p>
@@ -8734,7 +8740,7 @@
                             <a:schemeClr val="tx1"/>
                           </a:solidFill>
                         </a:rPr>
-                        <a:t>21/40</a:t>
+                        <a:t>22/40</a:t>
                       </a:r>
                       <a:endParaRPr lang="en-US" sz="1400" dirty="0"/>
                     </a:p>
@@ -8783,7 +8789,7 @@
                             <a:schemeClr val="tx1"/>
                           </a:solidFill>
                         </a:rPr>
-                        <a:t>13.20 s</a:t>
+                        <a:t>4.93 s</a:t>
                       </a:r>
                       <a:endParaRPr lang="en-US" sz="1400" dirty="0"/>
                     </a:p>
@@ -8912,7 +8918,7 @@
                   <a:schemeClr val="tx2"/>
                 </a:solidFill>
               </a:rPr>
-              <a:t>Reparación desactivada</a:t>
+              <a:t>Reparación activada</a:t>
             </a:r>
             <a:endParaRPr lang="en-US" sz="1400" dirty="0"/>
           </a:p>
@@ -9445,7 +9451,7 @@
                   <a:schemeClr val="accent1"/>
                 </a:solidFill>
               </a:rPr>
-              <a:t>Tabla inexistente (v01)</a:t>
+              <a:t>Columna inexistente (v13)</a:t>
             </a:r>
             <a:endParaRPr lang="en-US" sz="1400" dirty="0"/>
           </a:p>
@@ -9465,7 +9471,7 @@
                 <a:ea typeface="Courier New" pitchFamily="34" charset="-122"/>
                 <a:cs typeface="Courier New" pitchFamily="34" charset="-120"/>
               </a:rPr>
-              <a:t>Pred: FROM HOTELS</a:t>
+              <a:t>Pred: AVG(h.tarifa_noche)</a:t>
             </a:r>
             <a:endParaRPr lang="en-US" sz="1400" dirty="0"/>
           </a:p>
@@ -9485,7 +9491,7 @@
                 <a:ea typeface="Courier New" pitchFamily="34" charset="-122"/>
                 <a:cs typeface="Courier New" pitchFamily="34" charset="-120"/>
               </a:rPr>
-              <a:t>Ref:  FROM hoteles</a:t>
+              <a:t>Ref:  AVG(t.tarifa_noche)</a:t>
             </a:r>
             <a:endParaRPr lang="en-US" sz="1400" dirty="0"/>
           </a:p>
@@ -9502,7 +9508,7 @@
                   <a:schemeClr val="tx1"/>
                 </a:solidFill>
               </a:rPr>
-              <a:t>Se usó HOTELS en lugar de hoteles.</a:t>
+              <a:t>La tarifa pertenece a tipos_habitacion.</a:t>
             </a:r>
             <a:endParaRPr lang="en-US" sz="1400" dirty="0"/>
           </a:p>

</xml_diff>